<commit_message>
Give the decision figure an IDE-inspired palette
</commit_message>
<xml_diff>
--- a/docs/figures/codeprep-decision-flow/editable/codeprep-decision-flow.pptx
+++ b/docs/figures/codeprep-decision-flow/editable/codeprep-decision-flow.pptx
@@ -2,13 +2,13 @@
 <file path=ppt/presentation.xml><?xml version="1.0" encoding="utf-8"?>
 <p:presentation xmlns:p="http://schemas.openxmlformats.org/presentationml/2006/main">
   <p:sldMasterIdLst>
-    <p:sldMasterId xmlns:r="http://schemas.openxmlformats.org/officeDocument/2006/relationships" id="2147483648" r:id="R846335b8b3b54404"/>
+    <p:sldMasterId xmlns:r="http://schemas.openxmlformats.org/officeDocument/2006/relationships" id="2147483648" r:id="R3b37e8978f1d46cb"/>
   </p:sldMasterIdLst>
   <p:notesMasterIdLst>
-    <p:notesMasterId xmlns:r="http://schemas.openxmlformats.org/officeDocument/2006/relationships" r:id="Rc53804bc91f54326"/>
+    <p:notesMasterId xmlns:r="http://schemas.openxmlformats.org/officeDocument/2006/relationships" r:id="R6e9fb6b7921e4036"/>
   </p:notesMasterIdLst>
   <p:sldIdLst>
-    <p:sldId xmlns:r="http://schemas.openxmlformats.org/officeDocument/2006/relationships" id="256" r:id="Rf204236f2e424285"/>
+    <p:sldId xmlns:r="http://schemas.openxmlformats.org/officeDocument/2006/relationships" id="256" r:id="Rfb244082ef22465d"/>
   </p:sldIdLst>
   <p:sldSz cx="12192000" cy="6858000"/>
   <p:notesSz cx="6858000" cy="9144000"/>
@@ -601,7 +601,7 @@
   </p:cSld>
   <p:clrMap bg1="lt1" tx1="dk1" bg2="lt2" tx2="dk2" accent1="accent1" accent2="accent2" accent3="accent3" accent4="accent4" accent5="accent5" accent6="accent6" hlink="hlink" folHlink="folHlink"/>
   <p:sldLayoutIdLst>
-    <p:sldLayoutId xmlns:r="http://schemas.openxmlformats.org/officeDocument/2006/relationships" id="2147483649" r:id="Rbbacf7515d5b4e42"/>
+    <p:sldLayoutId xmlns:r="http://schemas.openxmlformats.org/officeDocument/2006/relationships" id="2147483649" r:id="Re991020a90694708"/>
   </p:sldLayoutIdLst>
   <p:txStyles>
     <p:titleStyle>
@@ -1134,7 +1134,7 @@
     <p:bg>
       <p:bgPr>
         <a:solidFill xmlns:a="http://schemas.openxmlformats.org/drawingml/2006/main">
-          <a:srgbClr val="F5F2EC"/>
+          <a:srgbClr val="17181C"/>
         </a:solidFill>
       </p:bgPr>
     </p:bg>
@@ -1152,7 +1152,7 @@
           <p:cNvPr id="88" name="title">
             <a:extLst xmlns:a="http://schemas.openxmlformats.org/drawingml/2006/main">
               <a:ext uri="{FF2B5EF4-FFF2-40B4-BE49-F238E27FC236}">
-                <a16:creationId xmlns:a16="http://schemas.microsoft.com/office/drawing/2014/main" id="{3B782AA4-2E25-48D1-9739-E2933F56D5A2}"/>
+                <a16:creationId xmlns:a16="http://schemas.microsoft.com/office/drawing/2014/main" id="{4D028F3C-FC7C-4026-B6F1-19851CF09117}"/>
               </a:ext>
             </a:extLst>
           </p:cNvPr>
@@ -1182,14 +1182,14 @@
             <a:pPr algn="l">
               <a:defRPr sz="2550" b="1">
                 <a:solidFill>
-                  <a:srgbClr val="20201E"/>
+                  <a:srgbClr val="F5F3ED"/>
                 </a:solidFill>
               </a:defRPr>
             </a:pPr>
             <a:r>
               <a:rPr sz="2550" b="1">
                 <a:solidFill>
-                  <a:srgbClr val="20201E"/>
+                  <a:srgbClr val="F5F3ED"/>
                 </a:solidFill>
               </a:rPr>
               <a:t>CodePrep turns one answer selection into a visible reasoning state</a:t>
@@ -1202,7 +1202,7 @@
           <p:cNvPr id="2" name="subtitle">
             <a:extLst xmlns:a="http://schemas.openxmlformats.org/drawingml/2006/main">
               <a:ext uri="{FF2B5EF4-FFF2-40B4-BE49-F238E27FC236}">
-                <a16:creationId xmlns:a16="http://schemas.microsoft.com/office/drawing/2014/main" id="{1D229805-0482-4122-961F-DC2C000C8E64}"/>
+                <a16:creationId xmlns:a16="http://schemas.microsoft.com/office/drawing/2014/main" id="{DFD71384-A08C-49B6-8964-E814583960D3}"/>
               </a:ext>
             </a:extLst>
           </p:cNvPr>
@@ -1232,14 +1232,14 @@
             <a:pPr algn="l">
               <a:defRPr sz="1200" b="0">
                 <a:solidFill>
-                  <a:srgbClr val="6C6B66"/>
+                  <a:srgbClr val="ADB2BC"/>
                 </a:solidFill>
               </a:defRPr>
             </a:pPr>
             <a:r>
               <a:rPr sz="1200" b="0">
                 <a:solidFill>
-                  <a:srgbClr val="6C6B66"/>
+                  <a:srgbClr val="ADB2BC"/>
                 </a:solidFill>
               </a:rPr>
               <a:t>The rationale is absent before commitment and appears immediately after selection; live challenge creation adds a separate validated transaction.</a:t>
@@ -1252,7 +1252,7 @@
           <p:cNvPr id="3" name="header-rule">
             <a:extLst xmlns:a="http://schemas.openxmlformats.org/drawingml/2006/main">
               <a:ext uri="{FF2B5EF4-FFF2-40B4-BE49-F238E27FC236}">
-                <a16:creationId xmlns:a16="http://schemas.microsoft.com/office/drawing/2014/main" id="{1196414C-0DA5-448E-97E9-136434B04E40}"/>
+                <a16:creationId xmlns:a16="http://schemas.microsoft.com/office/drawing/2014/main" id="{64ADD15F-F2C4-4572-B3A5-AD85766F5475}"/>
               </a:ext>
             </a:extLst>
           </p:cNvPr>
@@ -1272,7 +1272,7 @@
           <a:noFill xmlns:a="http://schemas.openxmlformats.org/drawingml/2006/main"/>
           <a:ln xmlns:a="http://schemas.openxmlformats.org/drawingml/2006/main" w="14288">
             <a:solidFill>
-              <a:srgbClr val="20201E"/>
+              <a:srgbClr val="F5F3ED"/>
             </a:solidFill>
             <a:prstDash val="solid"/>
           </a:ln>
@@ -1283,7 +1283,7 @@
           <p:cNvPr id="4" name="story-label">
             <a:extLst xmlns:a="http://schemas.openxmlformats.org/drawingml/2006/main">
               <a:ext uri="{FF2B5EF4-FFF2-40B4-BE49-F238E27FC236}">
-                <a16:creationId xmlns:a16="http://schemas.microsoft.com/office/drawing/2014/main" id="{D3FF0B75-C732-4C0C-AE48-7B0C5708AB69}"/>
+                <a16:creationId xmlns:a16="http://schemas.microsoft.com/office/drawing/2014/main" id="{AC63349F-FD2A-4F9A-BBA8-4C9CFDB3F348}"/>
               </a:ext>
             </a:extLst>
           </p:cNvPr>
@@ -1313,14 +1313,14 @@
             <a:pPr algn="l">
               <a:defRPr sz="900" b="1">
                 <a:solidFill>
-                  <a:srgbClr val="C9431C"/>
+                  <a:srgbClr val="FF8A45"/>
                 </a:solidFill>
               </a:defRPr>
             </a:pPr>
             <a:r>
               <a:rPr sz="900" b="1">
                 <a:solidFill>
-                  <a:srgbClr val="C9431C"/>
+                  <a:srgbClr val="FF8A45"/>
                 </a:solidFill>
               </a:rPr>
               <a:t>BEFORE  →  ACTION  →  AFTER</a:t>
@@ -1333,7 +1333,7 @@
           <p:cNvPr id="5" name="commit-arrow">
             <a:extLst xmlns:a="http://schemas.openxmlformats.org/drawingml/2006/main">
               <a:ext uri="{FF2B5EF4-FFF2-40B4-BE49-F238E27FC236}">
-                <a16:creationId xmlns:a16="http://schemas.microsoft.com/office/drawing/2014/main" id="{6E2BBEBA-DC46-4FF1-A79D-33650C4DFCC7}"/>
+                <a16:creationId xmlns:a16="http://schemas.microsoft.com/office/drawing/2014/main" id="{7A06E45C-A64F-4A92-AD25-D035FFE9FF0C}"/>
               </a:ext>
             </a:extLst>
           </p:cNvPr>
@@ -1351,11 +1351,11 @@
             <a:avLst/>
           </a:prstGeom>
           <a:solidFill xmlns:a="http://schemas.openxmlformats.org/drawingml/2006/main">
-            <a:srgbClr val="C9431C"/>
+            <a:srgbClr val="FF8A45"/>
           </a:solidFill>
           <a:ln xmlns:a="http://schemas.openxmlformats.org/drawingml/2006/main" w="0">
             <a:solidFill>
-              <a:srgbClr val="C9431C"/>
+              <a:srgbClr val="FF8A45"/>
             </a:solidFill>
             <a:prstDash val="solid"/>
           </a:ln>
@@ -1366,7 +1366,7 @@
           <p:cNvPr id="6" name="commit-label">
             <a:extLst xmlns:a="http://schemas.openxmlformats.org/drawingml/2006/main">
               <a:ext uri="{FF2B5EF4-FFF2-40B4-BE49-F238E27FC236}">
-                <a16:creationId xmlns:a16="http://schemas.microsoft.com/office/drawing/2014/main" id="{4CFCDAAC-8194-42E1-BB94-43B2221D1651}"/>
+                <a16:creationId xmlns:a16="http://schemas.microsoft.com/office/drawing/2014/main" id="{D9E2C123-371D-4605-93B4-FE26F5CFD04C}"/>
               </a:ext>
             </a:extLst>
           </p:cNvPr>
@@ -1396,14 +1396,14 @@
             <a:pPr algn="ctr">
               <a:defRPr sz="900" b="1">
                 <a:solidFill>
-                  <a:srgbClr val="C9431C"/>
+                  <a:srgbClr val="FF8A45"/>
                 </a:solidFill>
               </a:defRPr>
             </a:pPr>
             <a:r>
               <a:rPr sz="900" b="1">
                 <a:solidFill>
-                  <a:srgbClr val="C9431C"/>
+                  <a:srgbClr val="FF8A45"/>
                 </a:solidFill>
               </a:rPr>
               <a:t>select B</a:t>
@@ -1416,7 +1416,7 @@
           <p:cNvPr id="7" name="commit-value">
             <a:extLst xmlns:a="http://schemas.openxmlformats.org/drawingml/2006/main">
               <a:ext uri="{FF2B5EF4-FFF2-40B4-BE49-F238E27FC236}">
-                <a16:creationId xmlns:a16="http://schemas.microsoft.com/office/drawing/2014/main" id="{0F8C9B68-D3D5-4A1B-B396-475B8136950F}"/>
+                <a16:creationId xmlns:a16="http://schemas.microsoft.com/office/drawing/2014/main" id="{C24390AB-AC11-4956-B0A9-2D644A182805}"/>
               </a:ext>
             </a:extLst>
           </p:cNvPr>
@@ -1446,14 +1446,14 @@
             <a:pPr algn="ctr">
               <a:defRPr sz="825" b="1">
                 <a:solidFill>
-                  <a:srgbClr val="C9431C"/>
+                  <a:srgbClr val="FF8A45"/>
                 </a:solidFill>
               </a:defRPr>
             </a:pPr>
             <a:r>
               <a:rPr sz="825" b="1">
                 <a:solidFill>
-                  <a:srgbClr val="C9431C"/>
+                  <a:srgbClr val="FF8A45"/>
                 </a:solidFill>
               </a:rPr>
               <a:t>O(log n)</a:t>
@@ -1466,7 +1466,7 @@
           <p:cNvPr id="8" name="before-frame">
             <a:extLst xmlns:a="http://schemas.openxmlformats.org/drawingml/2006/main">
               <a:ext uri="{FF2B5EF4-FFF2-40B4-BE49-F238E27FC236}">
-                <a16:creationId xmlns:a16="http://schemas.microsoft.com/office/drawing/2014/main" id="{E1BE9995-A864-4E50-9C71-52785333430F}"/>
+                <a16:creationId xmlns:a16="http://schemas.microsoft.com/office/drawing/2014/main" id="{7501B7F5-C2B6-48C3-BEDE-76394C37AB4B}"/>
               </a:ext>
             </a:extLst>
           </p:cNvPr>
@@ -1486,11 +1486,11 @@
             </a:avLst>
           </a:prstGeom>
           <a:solidFill xmlns:a="http://schemas.openxmlformats.org/drawingml/2006/main">
-            <a:srgbClr val="FFFFFF"/>
+            <a:srgbClr val="23252B"/>
           </a:solidFill>
           <a:ln xmlns:a="http://schemas.openxmlformats.org/drawingml/2006/main" w="11430">
             <a:solidFill>
-              <a:srgbClr val="817F79"/>
+              <a:srgbClr val="9096A1"/>
             </a:solidFill>
             <a:prstDash val="solid"/>
           </a:ln>
@@ -1501,7 +1501,7 @@
           <p:cNvPr id="9" name="before-topbar">
             <a:extLst xmlns:a="http://schemas.openxmlformats.org/drawingml/2006/main">
               <a:ext uri="{FF2B5EF4-FFF2-40B4-BE49-F238E27FC236}">
-                <a16:creationId xmlns:a16="http://schemas.microsoft.com/office/drawing/2014/main" id="{DAC5076A-B89C-4E2F-8E55-0BDE1ED32C60}"/>
+                <a16:creationId xmlns:a16="http://schemas.microsoft.com/office/drawing/2014/main" id="{B4ADB44E-FF68-4C5C-B5EE-63BDB9454B90}"/>
               </a:ext>
             </a:extLst>
           </p:cNvPr>
@@ -1519,11 +1519,11 @@
             <a:avLst/>
           </a:prstGeom>
           <a:solidFill xmlns:a="http://schemas.openxmlformats.org/drawingml/2006/main">
-            <a:srgbClr val="ECEAE5"/>
+            <a:srgbClr val="2D2F35"/>
           </a:solidFill>
           <a:ln xmlns:a="http://schemas.openxmlformats.org/drawingml/2006/main" w="9525">
             <a:solidFill>
-              <a:srgbClr val="817F79"/>
+              <a:srgbClr val="9096A1"/>
             </a:solidFill>
             <a:prstDash val="solid"/>
           </a:ln>
@@ -1534,7 +1534,7 @@
           <p:cNvPr id="10" name="before-state">
             <a:extLst xmlns:a="http://schemas.openxmlformats.org/drawingml/2006/main">
               <a:ext uri="{FF2B5EF4-FFF2-40B4-BE49-F238E27FC236}">
-                <a16:creationId xmlns:a16="http://schemas.microsoft.com/office/drawing/2014/main" id="{E118AF94-DAD7-4C89-81DD-AFD60232F40F}"/>
+                <a16:creationId xmlns:a16="http://schemas.microsoft.com/office/drawing/2014/main" id="{3F60940A-2633-4FF4-8945-BA724DB8A336}"/>
               </a:ext>
             </a:extLst>
           </p:cNvPr>
@@ -1564,14 +1564,14 @@
             <a:pPr algn="l">
               <a:defRPr sz="750" b="1">
                 <a:solidFill>
-                  <a:srgbClr val="817F79"/>
+                  <a:srgbClr val="9096A1"/>
                 </a:solidFill>
               </a:defRPr>
             </a:pPr>
             <a:r>
               <a:rPr sz="750" b="1">
                 <a:solidFill>
-                  <a:srgbClr val="817F79"/>
+                  <a:srgbClr val="9096A1"/>
                 </a:solidFill>
               </a:rPr>
               <a:t>STATE 0 · UNANSWERED</a:t>
@@ -1584,7 +1584,7 @@
           <p:cNvPr id="11" name="before-difficulty">
             <a:extLst xmlns:a="http://schemas.openxmlformats.org/drawingml/2006/main">
               <a:ext uri="{FF2B5EF4-FFF2-40B4-BE49-F238E27FC236}">
-                <a16:creationId xmlns:a16="http://schemas.microsoft.com/office/drawing/2014/main" id="{3DE4E518-550A-4E06-BDC3-EF03B34825DC}"/>
+                <a16:creationId xmlns:a16="http://schemas.microsoft.com/office/drawing/2014/main" id="{60C5F297-0E02-454D-BC0D-8F418CEA607D}"/>
               </a:ext>
             </a:extLst>
           </p:cNvPr>
@@ -1614,14 +1614,14 @@
             <a:pPr algn="r">
               <a:defRPr sz="750" b="1">
                 <a:solidFill>
-                  <a:srgbClr val="C9431C"/>
+                  <a:srgbClr val="FF8A45"/>
                 </a:solidFill>
               </a:defRPr>
             </a:pPr>
             <a:r>
               <a:rPr sz="750" b="1">
                 <a:solidFill>
-                  <a:srgbClr val="C9431C"/>
+                  <a:srgbClr val="FF8A45"/>
                 </a:solidFill>
               </a:rPr>
               <a:t>MEDIUM</a:t>
@@ -1634,7 +1634,7 @@
           <p:cNvPr id="12" name="before-question">
             <a:extLst xmlns:a="http://schemas.openxmlformats.org/drawingml/2006/main">
               <a:ext uri="{FF2B5EF4-FFF2-40B4-BE49-F238E27FC236}">
-                <a16:creationId xmlns:a16="http://schemas.microsoft.com/office/drawing/2014/main" id="{56B96682-321E-4ABE-9945-BBCD9CE0F9D0}"/>
+                <a16:creationId xmlns:a16="http://schemas.microsoft.com/office/drawing/2014/main" id="{7D6617DC-1213-4D4C-850A-200849C176CB}"/>
               </a:ext>
             </a:extLst>
           </p:cNvPr>
@@ -1664,14 +1664,14 @@
             <a:pPr algn="l">
               <a:defRPr sz="1125" b="1">
                 <a:solidFill>
-                  <a:srgbClr val="20201E"/>
+                  <a:srgbClr val="F5F3ED"/>
                 </a:solidFill>
               </a:defRPr>
             </a:pPr>
             <a:r>
               <a:rPr sz="1125" b="1">
                 <a:solidFill>
-                  <a:srgbClr val="20201E"/>
+                  <a:srgbClr val="F5F3ED"/>
                 </a:solidFill>
               </a:rPr>
               <a:t>What is the time complexity of finding a value in a balanced binary search tree?</a:t>
@@ -1684,7 +1684,7 @@
           <p:cNvPr id="13" name="before-instruction">
             <a:extLst xmlns:a="http://schemas.openxmlformats.org/drawingml/2006/main">
               <a:ext uri="{FF2B5EF4-FFF2-40B4-BE49-F238E27FC236}">
-                <a16:creationId xmlns:a16="http://schemas.microsoft.com/office/drawing/2014/main" id="{91170DF6-5DE2-4512-9CCE-886FAA9DD22B}"/>
+                <a16:creationId xmlns:a16="http://schemas.microsoft.com/office/drawing/2014/main" id="{F742E647-D2C9-44FB-8C12-0C90D113640F}"/>
               </a:ext>
             </a:extLst>
           </p:cNvPr>
@@ -1714,14 +1714,14 @@
             <a:pPr algn="l">
               <a:defRPr sz="788" b="0">
                 <a:solidFill>
-                  <a:srgbClr val="6C6B66"/>
+                  <a:srgbClr val="ADB2BC"/>
                 </a:solidFill>
               </a:defRPr>
             </a:pPr>
             <a:r>
               <a:rPr sz="788" b="0">
                 <a:solidFill>
-                  <a:srgbClr val="6C6B66"/>
+                  <a:srgbClr val="ADB2BC"/>
                 </a:solidFill>
               </a:rPr>
               <a:t>Choose one answer.</a:t>
@@ -1734,7 +1734,7 @@
           <p:cNvPr id="14" name="before-option-0">
             <a:extLst xmlns:a="http://schemas.openxmlformats.org/drawingml/2006/main">
               <a:ext uri="{FF2B5EF4-FFF2-40B4-BE49-F238E27FC236}">
-                <a16:creationId xmlns:a16="http://schemas.microsoft.com/office/drawing/2014/main" id="{A74A8837-583B-413F-8E8E-5D50F3835650}"/>
+                <a16:creationId xmlns:a16="http://schemas.microsoft.com/office/drawing/2014/main" id="{7458CD0B-B973-436D-80AA-8692CAA7663D}"/>
               </a:ext>
             </a:extLst>
           </p:cNvPr>
@@ -1752,11 +1752,11 @@
             <a:avLst/>
           </a:prstGeom>
           <a:solidFill xmlns:a="http://schemas.openxmlformats.org/drawingml/2006/main">
-            <a:srgbClr val="FFFFFF"/>
+            <a:srgbClr val="23252B"/>
           </a:solidFill>
           <a:ln xmlns:a="http://schemas.openxmlformats.org/drawingml/2006/main" w="9525">
             <a:solidFill>
-              <a:srgbClr val="C9C6BF"/>
+              <a:srgbClr val="565B66"/>
             </a:solidFill>
             <a:prstDash val="solid"/>
           </a:ln>
@@ -1767,7 +1767,7 @@
           <p:cNvPr id="15" name="before-option-label-0">
             <a:extLst xmlns:a="http://schemas.openxmlformats.org/drawingml/2006/main">
               <a:ext uri="{FF2B5EF4-FFF2-40B4-BE49-F238E27FC236}">
-                <a16:creationId xmlns:a16="http://schemas.microsoft.com/office/drawing/2014/main" id="{1940C9B1-38B7-42DC-893A-5384BD4DC32F}"/>
+                <a16:creationId xmlns:a16="http://schemas.microsoft.com/office/drawing/2014/main" id="{F784B5DC-5D86-42BF-9DA5-83A92CB3237F}"/>
               </a:ext>
             </a:extLst>
           </p:cNvPr>
@@ -1797,14 +1797,14 @@
             <a:pPr algn="l">
               <a:defRPr sz="750" b="1">
                 <a:solidFill>
-                  <a:srgbClr val="817F79"/>
+                  <a:srgbClr val="9096A1"/>
                 </a:solidFill>
               </a:defRPr>
             </a:pPr>
             <a:r>
               <a:rPr sz="750" b="1">
                 <a:solidFill>
-                  <a:srgbClr val="817F79"/>
+                  <a:srgbClr val="9096A1"/>
                 </a:solidFill>
               </a:rPr>
               <a:t>A</a:t>
@@ -1817,7 +1817,7 @@
           <p:cNvPr id="16" name="before-option-copy-0">
             <a:extLst xmlns:a="http://schemas.openxmlformats.org/drawingml/2006/main">
               <a:ext uri="{FF2B5EF4-FFF2-40B4-BE49-F238E27FC236}">
-                <a16:creationId xmlns:a16="http://schemas.microsoft.com/office/drawing/2014/main" id="{61C274E0-B4B7-4121-B845-D91527A18E3B}"/>
+                <a16:creationId xmlns:a16="http://schemas.microsoft.com/office/drawing/2014/main" id="{E42BBAC6-9ECE-49DD-9BBE-5D2DC5F9F4CA}"/>
               </a:ext>
             </a:extLst>
           </p:cNvPr>
@@ -1847,14 +1847,14 @@
             <a:pPr algn="l">
               <a:defRPr sz="825" b="0">
                 <a:solidFill>
-                  <a:srgbClr val="20201E"/>
+                  <a:srgbClr val="F5F3ED"/>
                 </a:solidFill>
               </a:defRPr>
             </a:pPr>
             <a:r>
               <a:rPr sz="825" b="0">
                 <a:solidFill>
-                  <a:srgbClr val="20201E"/>
+                  <a:srgbClr val="F5F3ED"/>
                 </a:solidFill>
               </a:rPr>
               <a:t>O(1)</a:t>
@@ -1867,7 +1867,7 @@
           <p:cNvPr id="17" name="before-option-1">
             <a:extLst xmlns:a="http://schemas.openxmlformats.org/drawingml/2006/main">
               <a:ext uri="{FF2B5EF4-FFF2-40B4-BE49-F238E27FC236}">
-                <a16:creationId xmlns:a16="http://schemas.microsoft.com/office/drawing/2014/main" id="{30EC338E-4B14-4277-972E-C989567307C4}"/>
+                <a16:creationId xmlns:a16="http://schemas.microsoft.com/office/drawing/2014/main" id="{AAD0B17A-4F9B-490E-9975-3AA28A6C8B0E}"/>
               </a:ext>
             </a:extLst>
           </p:cNvPr>
@@ -1885,11 +1885,11 @@
             <a:avLst/>
           </a:prstGeom>
           <a:solidFill xmlns:a="http://schemas.openxmlformats.org/drawingml/2006/main">
-            <a:srgbClr val="FFFFFF"/>
+            <a:srgbClr val="23252B"/>
           </a:solidFill>
           <a:ln xmlns:a="http://schemas.openxmlformats.org/drawingml/2006/main" w="9525">
             <a:solidFill>
-              <a:srgbClr val="C9C6BF"/>
+              <a:srgbClr val="565B66"/>
             </a:solidFill>
             <a:prstDash val="solid"/>
           </a:ln>
@@ -1900,7 +1900,7 @@
           <p:cNvPr id="18" name="before-option-label-1">
             <a:extLst xmlns:a="http://schemas.openxmlformats.org/drawingml/2006/main">
               <a:ext uri="{FF2B5EF4-FFF2-40B4-BE49-F238E27FC236}">
-                <a16:creationId xmlns:a16="http://schemas.microsoft.com/office/drawing/2014/main" id="{F997E857-200E-49D3-9669-E3A50949685E}"/>
+                <a16:creationId xmlns:a16="http://schemas.microsoft.com/office/drawing/2014/main" id="{3920BDD1-D3FB-4B4E-95E1-D08675BA3B51}"/>
               </a:ext>
             </a:extLst>
           </p:cNvPr>
@@ -1930,14 +1930,14 @@
             <a:pPr algn="l">
               <a:defRPr sz="750" b="1">
                 <a:solidFill>
-                  <a:srgbClr val="817F79"/>
+                  <a:srgbClr val="9096A1"/>
                 </a:solidFill>
               </a:defRPr>
             </a:pPr>
             <a:r>
               <a:rPr sz="750" b="1">
                 <a:solidFill>
-                  <a:srgbClr val="817F79"/>
+                  <a:srgbClr val="9096A1"/>
                 </a:solidFill>
               </a:rPr>
               <a:t>B</a:t>
@@ -1950,7 +1950,7 @@
           <p:cNvPr id="19" name="before-option-copy-1">
             <a:extLst xmlns:a="http://schemas.openxmlformats.org/drawingml/2006/main">
               <a:ext uri="{FF2B5EF4-FFF2-40B4-BE49-F238E27FC236}">
-                <a16:creationId xmlns:a16="http://schemas.microsoft.com/office/drawing/2014/main" id="{E0DFE5C5-C4A1-4164-B28F-7C1F1E932972}"/>
+                <a16:creationId xmlns:a16="http://schemas.microsoft.com/office/drawing/2014/main" id="{6ED4B1D0-A431-4DAB-B2DD-9307BEF0E39A}"/>
               </a:ext>
             </a:extLst>
           </p:cNvPr>
@@ -1980,14 +1980,14 @@
             <a:pPr algn="l">
               <a:defRPr sz="825" b="0">
                 <a:solidFill>
-                  <a:srgbClr val="20201E"/>
+                  <a:srgbClr val="F5F3ED"/>
                 </a:solidFill>
               </a:defRPr>
             </a:pPr>
             <a:r>
               <a:rPr sz="825" b="0">
                 <a:solidFill>
-                  <a:srgbClr val="20201E"/>
+                  <a:srgbClr val="F5F3ED"/>
                 </a:solidFill>
               </a:rPr>
               <a:t>O(log n)</a:t>
@@ -2000,7 +2000,7 @@
           <p:cNvPr id="20" name="before-option-2">
             <a:extLst xmlns:a="http://schemas.openxmlformats.org/drawingml/2006/main">
               <a:ext uri="{FF2B5EF4-FFF2-40B4-BE49-F238E27FC236}">
-                <a16:creationId xmlns:a16="http://schemas.microsoft.com/office/drawing/2014/main" id="{735C01F6-855F-422C-BB6E-62BC01432408}"/>
+                <a16:creationId xmlns:a16="http://schemas.microsoft.com/office/drawing/2014/main" id="{D7F0440F-7A7D-4BA0-A0BB-258C52383DDF}"/>
               </a:ext>
             </a:extLst>
           </p:cNvPr>
@@ -2018,11 +2018,11 @@
             <a:avLst/>
           </a:prstGeom>
           <a:solidFill xmlns:a="http://schemas.openxmlformats.org/drawingml/2006/main">
-            <a:srgbClr val="FFFFFF"/>
+            <a:srgbClr val="23252B"/>
           </a:solidFill>
           <a:ln xmlns:a="http://schemas.openxmlformats.org/drawingml/2006/main" w="9525">
             <a:solidFill>
-              <a:srgbClr val="C9C6BF"/>
+              <a:srgbClr val="565B66"/>
             </a:solidFill>
             <a:prstDash val="solid"/>
           </a:ln>
@@ -2033,7 +2033,7 @@
           <p:cNvPr id="21" name="before-option-label-2">
             <a:extLst xmlns:a="http://schemas.openxmlformats.org/drawingml/2006/main">
               <a:ext uri="{FF2B5EF4-FFF2-40B4-BE49-F238E27FC236}">
-                <a16:creationId xmlns:a16="http://schemas.microsoft.com/office/drawing/2014/main" id="{A000ED6B-886A-4CE2-8875-8A23C3704EDA}"/>
+                <a16:creationId xmlns:a16="http://schemas.microsoft.com/office/drawing/2014/main" id="{7A4424BB-F7B4-4686-801F-3929115AD6D1}"/>
               </a:ext>
             </a:extLst>
           </p:cNvPr>
@@ -2063,14 +2063,14 @@
             <a:pPr algn="l">
               <a:defRPr sz="750" b="1">
                 <a:solidFill>
-                  <a:srgbClr val="817F79"/>
+                  <a:srgbClr val="9096A1"/>
                 </a:solidFill>
               </a:defRPr>
             </a:pPr>
             <a:r>
               <a:rPr sz="750" b="1">
                 <a:solidFill>
-                  <a:srgbClr val="817F79"/>
+                  <a:srgbClr val="9096A1"/>
                 </a:solidFill>
               </a:rPr>
               <a:t>C</a:t>
@@ -2083,7 +2083,7 @@
           <p:cNvPr id="22" name="before-option-copy-2">
             <a:extLst xmlns:a="http://schemas.openxmlformats.org/drawingml/2006/main">
               <a:ext uri="{FF2B5EF4-FFF2-40B4-BE49-F238E27FC236}">
-                <a16:creationId xmlns:a16="http://schemas.microsoft.com/office/drawing/2014/main" id="{247179CB-417E-4542-840D-188E11372DD6}"/>
+                <a16:creationId xmlns:a16="http://schemas.microsoft.com/office/drawing/2014/main" id="{3CB41C83-89AD-4BD2-AF98-7ECC924E39E5}"/>
               </a:ext>
             </a:extLst>
           </p:cNvPr>
@@ -2113,14 +2113,14 @@
             <a:pPr algn="l">
               <a:defRPr sz="825" b="0">
                 <a:solidFill>
-                  <a:srgbClr val="20201E"/>
+                  <a:srgbClr val="F5F3ED"/>
                 </a:solidFill>
               </a:defRPr>
             </a:pPr>
             <a:r>
               <a:rPr sz="825" b="0">
                 <a:solidFill>
-                  <a:srgbClr val="20201E"/>
+                  <a:srgbClr val="F5F3ED"/>
                 </a:solidFill>
               </a:rPr>
               <a:t>O(n)</a:t>
@@ -2133,7 +2133,7 @@
           <p:cNvPr id="23" name="before-option-3">
             <a:extLst xmlns:a="http://schemas.openxmlformats.org/drawingml/2006/main">
               <a:ext uri="{FF2B5EF4-FFF2-40B4-BE49-F238E27FC236}">
-                <a16:creationId xmlns:a16="http://schemas.microsoft.com/office/drawing/2014/main" id="{099414CD-DA75-478B-952A-EBAB12C47C84}"/>
+                <a16:creationId xmlns:a16="http://schemas.microsoft.com/office/drawing/2014/main" id="{B589EB79-97BF-4F0F-814D-B23E80541CC2}"/>
               </a:ext>
             </a:extLst>
           </p:cNvPr>
@@ -2151,11 +2151,11 @@
             <a:avLst/>
           </a:prstGeom>
           <a:solidFill xmlns:a="http://schemas.openxmlformats.org/drawingml/2006/main">
-            <a:srgbClr val="FFFFFF"/>
+            <a:srgbClr val="23252B"/>
           </a:solidFill>
           <a:ln xmlns:a="http://schemas.openxmlformats.org/drawingml/2006/main" w="9525">
             <a:solidFill>
-              <a:srgbClr val="C9C6BF"/>
+              <a:srgbClr val="565B66"/>
             </a:solidFill>
             <a:prstDash val="solid"/>
           </a:ln>
@@ -2166,7 +2166,7 @@
           <p:cNvPr id="24" name="before-option-label-3">
             <a:extLst xmlns:a="http://schemas.openxmlformats.org/drawingml/2006/main">
               <a:ext uri="{FF2B5EF4-FFF2-40B4-BE49-F238E27FC236}">
-                <a16:creationId xmlns:a16="http://schemas.microsoft.com/office/drawing/2014/main" id="{D780BFFA-A0B2-48A9-89B5-BCC1EA9C6ED5}"/>
+                <a16:creationId xmlns:a16="http://schemas.microsoft.com/office/drawing/2014/main" id="{3A16B746-B86C-4CDF-8E47-535C096A51B9}"/>
               </a:ext>
             </a:extLst>
           </p:cNvPr>
@@ -2196,14 +2196,14 @@
             <a:pPr algn="l">
               <a:defRPr sz="750" b="1">
                 <a:solidFill>
-                  <a:srgbClr val="817F79"/>
+                  <a:srgbClr val="9096A1"/>
                 </a:solidFill>
               </a:defRPr>
             </a:pPr>
             <a:r>
               <a:rPr sz="750" b="1">
                 <a:solidFill>
-                  <a:srgbClr val="817F79"/>
+                  <a:srgbClr val="9096A1"/>
                 </a:solidFill>
               </a:rPr>
               <a:t>D</a:t>
@@ -2216,7 +2216,7 @@
           <p:cNvPr id="25" name="before-option-copy-3">
             <a:extLst xmlns:a="http://schemas.openxmlformats.org/drawingml/2006/main">
               <a:ext uri="{FF2B5EF4-FFF2-40B4-BE49-F238E27FC236}">
-                <a16:creationId xmlns:a16="http://schemas.microsoft.com/office/drawing/2014/main" id="{F4C82DDD-A794-4388-8EB8-C6EB244C5DFB}"/>
+                <a16:creationId xmlns:a16="http://schemas.microsoft.com/office/drawing/2014/main" id="{2DF18FF2-5259-4761-95E9-DD48A8D506A9}"/>
               </a:ext>
             </a:extLst>
           </p:cNvPr>
@@ -2246,14 +2246,14 @@
             <a:pPr algn="l">
               <a:defRPr sz="825" b="0">
                 <a:solidFill>
-                  <a:srgbClr val="20201E"/>
+                  <a:srgbClr val="F5F3ED"/>
                 </a:solidFill>
               </a:defRPr>
             </a:pPr>
             <a:r>
               <a:rPr sz="825" b="0">
                 <a:solidFill>
-                  <a:srgbClr val="20201E"/>
+                  <a:srgbClr val="F5F3ED"/>
                 </a:solidFill>
               </a:rPr>
               <a:t>O(n log n)</a:t>
@@ -2266,7 +2266,7 @@
           <p:cNvPr id="26" name="before-divider">
             <a:extLst xmlns:a="http://schemas.openxmlformats.org/drawingml/2006/main">
               <a:ext uri="{FF2B5EF4-FFF2-40B4-BE49-F238E27FC236}">
-                <a16:creationId xmlns:a16="http://schemas.microsoft.com/office/drawing/2014/main" id="{FE2A47F6-7FA3-4393-BE25-E03B804B63BB}"/>
+                <a16:creationId xmlns:a16="http://schemas.microsoft.com/office/drawing/2014/main" id="{A49F41C5-5F65-47A5-BFC7-8ACFA94B6FCD}"/>
               </a:ext>
             </a:extLst>
           </p:cNvPr>
@@ -2286,7 +2286,7 @@
           <a:noFill xmlns:a="http://schemas.openxmlformats.org/drawingml/2006/main"/>
           <a:ln xmlns:a="http://schemas.openxmlformats.org/drawingml/2006/main" w="9525">
             <a:solidFill>
-              <a:srgbClr val="C9C6BF"/>
+              <a:srgbClr val="565B66"/>
             </a:solidFill>
             <a:prstDash val="solid"/>
           </a:ln>
@@ -2297,7 +2297,7 @@
           <p:cNvPr id="27" name="before-explanation-label">
             <a:extLst xmlns:a="http://schemas.openxmlformats.org/drawingml/2006/main">
               <a:ext uri="{FF2B5EF4-FFF2-40B4-BE49-F238E27FC236}">
-                <a16:creationId xmlns:a16="http://schemas.microsoft.com/office/drawing/2014/main" id="{402A33E4-E9AA-416C-A95A-5DCF14628EAD}"/>
+                <a16:creationId xmlns:a16="http://schemas.microsoft.com/office/drawing/2014/main" id="{EA1A1D6E-EE9A-449B-9CD4-FC7153ABE67F}"/>
               </a:ext>
             </a:extLst>
           </p:cNvPr>
@@ -2327,14 +2327,14 @@
             <a:pPr algn="l">
               <a:defRPr sz="750" b="1">
                 <a:solidFill>
-                  <a:srgbClr val="817F79"/>
+                  <a:srgbClr val="9096A1"/>
                 </a:solidFill>
               </a:defRPr>
             </a:pPr>
             <a:r>
               <a:rPr sz="750" b="1">
                 <a:solidFill>
-                  <a:srgbClr val="817F79"/>
+                  <a:srgbClr val="9096A1"/>
                 </a:solidFill>
               </a:rPr>
               <a:t>EXPLANATION</a:t>
@@ -2347,7 +2347,7 @@
           <p:cNvPr id="28" name="before-locked">
             <a:extLst xmlns:a="http://schemas.openxmlformats.org/drawingml/2006/main">
               <a:ext uri="{FF2B5EF4-FFF2-40B4-BE49-F238E27FC236}">
-                <a16:creationId xmlns:a16="http://schemas.microsoft.com/office/drawing/2014/main" id="{D6BC94AE-1271-43FD-AC74-91FF00DB1012}"/>
+                <a16:creationId xmlns:a16="http://schemas.microsoft.com/office/drawing/2014/main" id="{D3C0E27F-2361-4BF3-B292-22DBEAFB5B17}"/>
               </a:ext>
             </a:extLst>
           </p:cNvPr>
@@ -2367,11 +2367,11 @@
             </a:avLst>
           </a:prstGeom>
           <a:solidFill xmlns:a="http://schemas.openxmlformats.org/drawingml/2006/main">
-            <a:srgbClr val="ECEAE5"/>
+            <a:srgbClr val="2D2F35"/>
           </a:solidFill>
           <a:ln xmlns:a="http://schemas.openxmlformats.org/drawingml/2006/main" w="9525">
             <a:solidFill>
-              <a:srgbClr val="C9C6BF"/>
+              <a:srgbClr val="565B66"/>
             </a:solidFill>
             <a:prstDash val="solid"/>
           </a:ln>
@@ -2382,7 +2382,7 @@
           <p:cNvPr id="29" name="before-lock">
             <a:extLst xmlns:a="http://schemas.openxmlformats.org/drawingml/2006/main">
               <a:ext uri="{FF2B5EF4-FFF2-40B4-BE49-F238E27FC236}">
-                <a16:creationId xmlns:a16="http://schemas.microsoft.com/office/drawing/2014/main" id="{B57C1832-33E2-47FD-B7F2-0F14B734A445}"/>
+                <a16:creationId xmlns:a16="http://schemas.microsoft.com/office/drawing/2014/main" id="{6903F3DF-1467-424A-986B-F97FC899B0F3}"/>
               </a:ext>
             </a:extLst>
           </p:cNvPr>
@@ -2412,14 +2412,14 @@
             <a:pPr algn="ctr">
               <a:defRPr sz="975" b="1">
                 <a:solidFill>
-                  <a:srgbClr val="817F79"/>
+                  <a:srgbClr val="9096A1"/>
                 </a:solidFill>
               </a:defRPr>
             </a:pPr>
             <a:r>
               <a:rPr sz="975" b="1">
                 <a:solidFill>
-                  <a:srgbClr val="817F79"/>
+                  <a:srgbClr val="9096A1"/>
                 </a:solidFill>
               </a:rPr>
               <a:t>RATIONALE</a:t>
@@ -2429,14 +2429,14 @@
             <a:pPr algn="ctr">
               <a:defRPr sz="975" b="1">
                 <a:solidFill>
-                  <a:srgbClr val="817F79"/>
+                  <a:srgbClr val="9096A1"/>
                 </a:solidFill>
               </a:defRPr>
             </a:pPr>
             <a:r>
               <a:rPr sz="975" b="1">
                 <a:solidFill>
-                  <a:srgbClr val="817F79"/>
+                  <a:srgbClr val="9096A1"/>
                 </a:solidFill>
               </a:rPr>
               <a:t>LOCKED</a:t>
@@ -2449,7 +2449,7 @@
           <p:cNvPr id="30" name="before-lock-copy">
             <a:extLst xmlns:a="http://schemas.openxmlformats.org/drawingml/2006/main">
               <a:ext uri="{FF2B5EF4-FFF2-40B4-BE49-F238E27FC236}">
-                <a16:creationId xmlns:a16="http://schemas.microsoft.com/office/drawing/2014/main" id="{1278D9CE-0FAA-4FED-9DDF-7EB2DC6FC5C0}"/>
+                <a16:creationId xmlns:a16="http://schemas.microsoft.com/office/drawing/2014/main" id="{40D71B62-7994-4ACB-B1CD-9A00B86E9121}"/>
               </a:ext>
             </a:extLst>
           </p:cNvPr>
@@ -2479,14 +2479,14 @@
             <a:pPr algn="ctr">
               <a:defRPr sz="750" b="0">
                 <a:solidFill>
-                  <a:srgbClr val="6C6B66"/>
+                  <a:srgbClr val="ADB2BC"/>
                 </a:solidFill>
               </a:defRPr>
             </a:pPr>
             <a:r>
               <a:rPr sz="750" b="0">
                 <a:solidFill>
-                  <a:srgbClr val="6C6B66"/>
+                  <a:srgbClr val="ADB2BC"/>
                 </a:solidFill>
               </a:rPr>
               <a:t>Select an option to inspect the technical reasoning.</a:t>
@@ -2499,7 +2499,7 @@
           <p:cNvPr id="31" name="before-note">
             <a:extLst xmlns:a="http://schemas.openxmlformats.org/drawingml/2006/main">
               <a:ext uri="{FF2B5EF4-FFF2-40B4-BE49-F238E27FC236}">
-                <a16:creationId xmlns:a16="http://schemas.microsoft.com/office/drawing/2014/main" id="{37068019-91FA-44F3-BA06-BBA8748DC2A9}"/>
+                <a16:creationId xmlns:a16="http://schemas.microsoft.com/office/drawing/2014/main" id="{36609713-A1F3-4785-B488-70884872C44F}"/>
               </a:ext>
             </a:extLst>
           </p:cNvPr>
@@ -2529,14 +2529,14 @@
             <a:pPr algn="ctr">
               <a:defRPr sz="788" b="0">
                 <a:solidFill>
-                  <a:srgbClr val="6C6B66"/>
+                  <a:srgbClr val="ADB2BC"/>
                 </a:solidFill>
               </a:defRPr>
             </a:pPr>
             <a:r>
               <a:rPr sz="788" b="0">
                 <a:solidFill>
-                  <a:srgbClr val="6C6B66"/>
+                  <a:srgbClr val="ADB2BC"/>
                 </a:solidFill>
               </a:rPr>
               <a:t>No concept or explanation is visible.</a:t>
@@ -2549,7 +2549,7 @@
           <p:cNvPr id="32" name="after-frame">
             <a:extLst xmlns:a="http://schemas.openxmlformats.org/drawingml/2006/main">
               <a:ext uri="{FF2B5EF4-FFF2-40B4-BE49-F238E27FC236}">
-                <a16:creationId xmlns:a16="http://schemas.microsoft.com/office/drawing/2014/main" id="{8566C0FA-DF2F-4AAA-A191-D05D3BDBAFFF}"/>
+                <a16:creationId xmlns:a16="http://schemas.microsoft.com/office/drawing/2014/main" id="{EC49A159-E947-46AD-9D70-9089C78674BF}"/>
               </a:ext>
             </a:extLst>
           </p:cNvPr>
@@ -2569,11 +2569,11 @@
             </a:avLst>
           </a:prstGeom>
           <a:solidFill xmlns:a="http://schemas.openxmlformats.org/drawingml/2006/main">
-            <a:srgbClr val="FFFFFF"/>
+            <a:srgbClr val="23252B"/>
           </a:solidFill>
           <a:ln xmlns:a="http://schemas.openxmlformats.org/drawingml/2006/main" w="13335">
             <a:solidFill>
-              <a:srgbClr val="2C7B45"/>
+              <a:srgbClr val="A3E635"/>
             </a:solidFill>
             <a:prstDash val="solid"/>
           </a:ln>
@@ -2584,7 +2584,7 @@
           <p:cNvPr id="33" name="after-topbar">
             <a:extLst xmlns:a="http://schemas.openxmlformats.org/drawingml/2006/main">
               <a:ext uri="{FF2B5EF4-FFF2-40B4-BE49-F238E27FC236}">
-                <a16:creationId xmlns:a16="http://schemas.microsoft.com/office/drawing/2014/main" id="{6200A2FD-2C83-4E8A-A9F6-1CAE5A4A380F}"/>
+                <a16:creationId xmlns:a16="http://schemas.microsoft.com/office/drawing/2014/main" id="{C4AB6019-EE29-499E-A64B-1D4EF59BBF32}"/>
               </a:ext>
             </a:extLst>
           </p:cNvPr>
@@ -2602,11 +2602,11 @@
             <a:avLst/>
           </a:prstGeom>
           <a:solidFill xmlns:a="http://schemas.openxmlformats.org/drawingml/2006/main">
-            <a:srgbClr val="E7F1E9"/>
+            <a:srgbClr val="263323"/>
           </a:solidFill>
           <a:ln xmlns:a="http://schemas.openxmlformats.org/drawingml/2006/main" w="9525">
             <a:solidFill>
-              <a:srgbClr val="2C7B45"/>
+              <a:srgbClr val="A3E635"/>
             </a:solidFill>
             <a:prstDash val="solid"/>
           </a:ln>
@@ -2617,7 +2617,7 @@
           <p:cNvPr id="34" name="after-state">
             <a:extLst xmlns:a="http://schemas.openxmlformats.org/drawingml/2006/main">
               <a:ext uri="{FF2B5EF4-FFF2-40B4-BE49-F238E27FC236}">
-                <a16:creationId xmlns:a16="http://schemas.microsoft.com/office/drawing/2014/main" id="{92AF5C81-A912-410E-9641-A3CF2414BF25}"/>
+                <a16:creationId xmlns:a16="http://schemas.microsoft.com/office/drawing/2014/main" id="{80719152-4D56-43E0-8A67-12400B415C3F}"/>
               </a:ext>
             </a:extLst>
           </p:cNvPr>
@@ -2647,14 +2647,14 @@
             <a:pPr algn="l">
               <a:defRPr sz="750" b="1">
                 <a:solidFill>
-                  <a:srgbClr val="2C7B45"/>
+                  <a:srgbClr val="A3E635"/>
                 </a:solidFill>
               </a:defRPr>
             </a:pPr>
             <a:r>
               <a:rPr sz="750" b="1">
                 <a:solidFill>
-                  <a:srgbClr val="2C7B45"/>
+                  <a:srgbClr val="A3E635"/>
                 </a:solidFill>
               </a:rPr>
               <a:t>STATE 1 · ANSWER COMMITTED</a:t>
@@ -2667,7 +2667,7 @@
           <p:cNvPr id="35" name="after-result">
             <a:extLst xmlns:a="http://schemas.openxmlformats.org/drawingml/2006/main">
               <a:ext uri="{FF2B5EF4-FFF2-40B4-BE49-F238E27FC236}">
-                <a16:creationId xmlns:a16="http://schemas.microsoft.com/office/drawing/2014/main" id="{5426A35E-8CE0-498A-B05C-3315C4F26204}"/>
+                <a16:creationId xmlns:a16="http://schemas.microsoft.com/office/drawing/2014/main" id="{577F6866-BF3E-402A-982B-F61136E07997}"/>
               </a:ext>
             </a:extLst>
           </p:cNvPr>
@@ -2697,14 +2697,14 @@
             <a:pPr algn="r">
               <a:defRPr sz="750" b="1">
                 <a:solidFill>
-                  <a:srgbClr val="2C7B45"/>
+                  <a:srgbClr val="A3E635"/>
                 </a:solidFill>
               </a:defRPr>
             </a:pPr>
             <a:r>
               <a:rPr sz="750" b="1">
                 <a:solidFill>
-                  <a:srgbClr val="2C7B45"/>
+                  <a:srgbClr val="A3E635"/>
                 </a:solidFill>
               </a:rPr>
               <a:t>DECISION ACCEPTED</a:t>
@@ -2717,7 +2717,7 @@
           <p:cNvPr id="36" name="after-question">
             <a:extLst xmlns:a="http://schemas.openxmlformats.org/drawingml/2006/main">
               <a:ext uri="{FF2B5EF4-FFF2-40B4-BE49-F238E27FC236}">
-                <a16:creationId xmlns:a16="http://schemas.microsoft.com/office/drawing/2014/main" id="{927ED984-CFC3-4737-A9F7-216EC3AD6A3E}"/>
+                <a16:creationId xmlns:a16="http://schemas.microsoft.com/office/drawing/2014/main" id="{04CB94CC-E202-4957-A9DA-82D500A6379E}"/>
               </a:ext>
             </a:extLst>
           </p:cNvPr>
@@ -2747,14 +2747,14 @@
             <a:pPr algn="l">
               <a:defRPr sz="1125" b="1">
                 <a:solidFill>
-                  <a:srgbClr val="20201E"/>
+                  <a:srgbClr val="F5F3ED"/>
                 </a:solidFill>
               </a:defRPr>
             </a:pPr>
             <a:r>
               <a:rPr sz="1125" b="1">
                 <a:solidFill>
-                  <a:srgbClr val="20201E"/>
+                  <a:srgbClr val="F5F3ED"/>
                 </a:solidFill>
               </a:rPr>
               <a:t>What is the time complexity of finding a value in a balanced binary search tree?</a:t>
@@ -2767,7 +2767,7 @@
           <p:cNvPr id="37" name="after-option-0">
             <a:extLst xmlns:a="http://schemas.openxmlformats.org/drawingml/2006/main">
               <a:ext uri="{FF2B5EF4-FFF2-40B4-BE49-F238E27FC236}">
-                <a16:creationId xmlns:a16="http://schemas.microsoft.com/office/drawing/2014/main" id="{3CA2E331-C3F7-4DFF-9F79-1590BEBB7E44}"/>
+                <a16:creationId xmlns:a16="http://schemas.microsoft.com/office/drawing/2014/main" id="{E95BD4A8-8E46-446D-97D1-07CAA86E2CB3}"/>
               </a:ext>
             </a:extLst>
           </p:cNvPr>
@@ -2785,11 +2785,11 @@
             <a:avLst/>
           </a:prstGeom>
           <a:solidFill xmlns:a="http://schemas.openxmlformats.org/drawingml/2006/main">
-            <a:srgbClr val="ECEAE5"/>
+            <a:srgbClr val="2D2F35"/>
           </a:solidFill>
           <a:ln xmlns:a="http://schemas.openxmlformats.org/drawingml/2006/main" w="9525">
             <a:solidFill>
-              <a:srgbClr val="C9C6BF"/>
+              <a:srgbClr val="565B66"/>
             </a:solidFill>
             <a:prstDash val="solid"/>
           </a:ln>
@@ -2800,7 +2800,7 @@
           <p:cNvPr id="38" name="after-option-label-0">
             <a:extLst xmlns:a="http://schemas.openxmlformats.org/drawingml/2006/main">
               <a:ext uri="{FF2B5EF4-FFF2-40B4-BE49-F238E27FC236}">
-                <a16:creationId xmlns:a16="http://schemas.microsoft.com/office/drawing/2014/main" id="{400EEA6F-D232-40B4-B7B7-532C55656D44}"/>
+                <a16:creationId xmlns:a16="http://schemas.microsoft.com/office/drawing/2014/main" id="{9FC1918F-DC81-4B33-A9C2-579B9A89BE71}"/>
               </a:ext>
             </a:extLst>
           </p:cNvPr>
@@ -2830,14 +2830,14 @@
             <a:pPr algn="l">
               <a:defRPr sz="750" b="1">
                 <a:solidFill>
-                  <a:srgbClr val="817F79"/>
+                  <a:srgbClr val="9096A1"/>
                 </a:solidFill>
               </a:defRPr>
             </a:pPr>
             <a:r>
               <a:rPr sz="750" b="1">
                 <a:solidFill>
-                  <a:srgbClr val="817F79"/>
+                  <a:srgbClr val="9096A1"/>
                 </a:solidFill>
               </a:rPr>
               <a:t>A</a:t>
@@ -2850,7 +2850,7 @@
           <p:cNvPr id="39" name="after-option-copy-0">
             <a:extLst xmlns:a="http://schemas.openxmlformats.org/drawingml/2006/main">
               <a:ext uri="{FF2B5EF4-FFF2-40B4-BE49-F238E27FC236}">
-                <a16:creationId xmlns:a16="http://schemas.microsoft.com/office/drawing/2014/main" id="{C3DE4639-1A11-43BA-8096-BD6AB0FF008C}"/>
+                <a16:creationId xmlns:a16="http://schemas.microsoft.com/office/drawing/2014/main" id="{7205F2EA-142D-4E55-BE6E-9CC9D76E2541}"/>
               </a:ext>
             </a:extLst>
           </p:cNvPr>
@@ -2880,14 +2880,14 @@
             <a:pPr algn="l">
               <a:defRPr sz="825" b="0">
                 <a:solidFill>
-                  <a:srgbClr val="6C6B66"/>
+                  <a:srgbClr val="ADB2BC"/>
                 </a:solidFill>
               </a:defRPr>
             </a:pPr>
             <a:r>
               <a:rPr sz="825" b="0">
                 <a:solidFill>
-                  <a:srgbClr val="6C6B66"/>
+                  <a:srgbClr val="ADB2BC"/>
                 </a:solidFill>
               </a:rPr>
               <a:t>O(1)</a:t>
@@ -2900,7 +2900,7 @@
           <p:cNvPr id="40" name="after-option-1">
             <a:extLst xmlns:a="http://schemas.openxmlformats.org/drawingml/2006/main">
               <a:ext uri="{FF2B5EF4-FFF2-40B4-BE49-F238E27FC236}">
-                <a16:creationId xmlns:a16="http://schemas.microsoft.com/office/drawing/2014/main" id="{EFAAE2CD-0C25-4170-ADFE-5B372ED64C44}"/>
+                <a16:creationId xmlns:a16="http://schemas.microsoft.com/office/drawing/2014/main" id="{F954A480-3503-4956-8E96-E44658D46ECA}"/>
               </a:ext>
             </a:extLst>
           </p:cNvPr>
@@ -2918,11 +2918,11 @@
             <a:avLst/>
           </a:prstGeom>
           <a:solidFill xmlns:a="http://schemas.openxmlformats.org/drawingml/2006/main">
-            <a:srgbClr val="E7F1E9"/>
+            <a:srgbClr val="263323"/>
           </a:solidFill>
           <a:ln xmlns:a="http://schemas.openxmlformats.org/drawingml/2006/main" w="13335">
             <a:solidFill>
-              <a:srgbClr val="2C7B45"/>
+              <a:srgbClr val="A3E635"/>
             </a:solidFill>
             <a:prstDash val="solid"/>
           </a:ln>
@@ -2933,7 +2933,7 @@
           <p:cNvPr id="41" name="after-option-label-1">
             <a:extLst xmlns:a="http://schemas.openxmlformats.org/drawingml/2006/main">
               <a:ext uri="{FF2B5EF4-FFF2-40B4-BE49-F238E27FC236}">
-                <a16:creationId xmlns:a16="http://schemas.microsoft.com/office/drawing/2014/main" id="{92DF9202-07CE-4782-9187-BA05AA071032}"/>
+                <a16:creationId xmlns:a16="http://schemas.microsoft.com/office/drawing/2014/main" id="{54E6103B-6DA5-4526-A80A-41B97F9D6ED9}"/>
               </a:ext>
             </a:extLst>
           </p:cNvPr>
@@ -2963,14 +2963,14 @@
             <a:pPr algn="l">
               <a:defRPr sz="750" b="1">
                 <a:solidFill>
-                  <a:srgbClr val="2C7B45"/>
+                  <a:srgbClr val="A3E635"/>
                 </a:solidFill>
               </a:defRPr>
             </a:pPr>
             <a:r>
               <a:rPr sz="750" b="1">
                 <a:solidFill>
-                  <a:srgbClr val="2C7B45"/>
+                  <a:srgbClr val="A3E635"/>
                 </a:solidFill>
               </a:rPr>
               <a:t>B</a:t>
@@ -2983,7 +2983,7 @@
           <p:cNvPr id="42" name="after-option-copy-1">
             <a:extLst xmlns:a="http://schemas.openxmlformats.org/drawingml/2006/main">
               <a:ext uri="{FF2B5EF4-FFF2-40B4-BE49-F238E27FC236}">
-                <a16:creationId xmlns:a16="http://schemas.microsoft.com/office/drawing/2014/main" id="{6F45B442-407B-49A5-A394-616DBA6E7E64}"/>
+                <a16:creationId xmlns:a16="http://schemas.microsoft.com/office/drawing/2014/main" id="{B853D1EA-EBBA-4371-94ED-37EEA4FB204E}"/>
               </a:ext>
             </a:extLst>
           </p:cNvPr>
@@ -3013,14 +3013,14 @@
             <a:pPr algn="l">
               <a:defRPr sz="825" b="1">
                 <a:solidFill>
-                  <a:srgbClr val="2C7B45"/>
+                  <a:srgbClr val="A3E635"/>
                 </a:solidFill>
               </a:defRPr>
             </a:pPr>
             <a:r>
               <a:rPr sz="825" b="1">
                 <a:solidFill>
-                  <a:srgbClr val="2C7B45"/>
+                  <a:srgbClr val="A3E635"/>
                 </a:solidFill>
               </a:rPr>
               <a:t>O(log n)</a:t>
@@ -3033,7 +3033,7 @@
           <p:cNvPr id="43" name="after-correct">
             <a:extLst xmlns:a="http://schemas.openxmlformats.org/drawingml/2006/main">
               <a:ext uri="{FF2B5EF4-FFF2-40B4-BE49-F238E27FC236}">
-                <a16:creationId xmlns:a16="http://schemas.microsoft.com/office/drawing/2014/main" id="{BB097B8F-8388-47E1-A520-7D02094AA8EF}"/>
+                <a16:creationId xmlns:a16="http://schemas.microsoft.com/office/drawing/2014/main" id="{D59E72CF-AB71-4D3A-8D26-3B6D539EB4D6}"/>
               </a:ext>
             </a:extLst>
           </p:cNvPr>
@@ -3063,14 +3063,14 @@
             <a:pPr algn="r">
               <a:defRPr sz="675" b="1">
                 <a:solidFill>
-                  <a:srgbClr val="2C7B45"/>
+                  <a:srgbClr val="A3E635"/>
                 </a:solidFill>
               </a:defRPr>
             </a:pPr>
             <a:r>
               <a:rPr sz="675" b="1">
                 <a:solidFill>
-                  <a:srgbClr val="2C7B45"/>
+                  <a:srgbClr val="A3E635"/>
                 </a:solidFill>
               </a:rPr>
               <a:t>CORRECT</a:t>
@@ -3083,7 +3083,7 @@
           <p:cNvPr id="44" name="after-option-2">
             <a:extLst xmlns:a="http://schemas.openxmlformats.org/drawingml/2006/main">
               <a:ext uri="{FF2B5EF4-FFF2-40B4-BE49-F238E27FC236}">
-                <a16:creationId xmlns:a16="http://schemas.microsoft.com/office/drawing/2014/main" id="{878CACB3-529E-4F16-AEB1-20287AA9933A}"/>
+                <a16:creationId xmlns:a16="http://schemas.microsoft.com/office/drawing/2014/main" id="{DAA8BBDF-F8BA-4498-BB98-51E3656E2F77}"/>
               </a:ext>
             </a:extLst>
           </p:cNvPr>
@@ -3101,11 +3101,11 @@
             <a:avLst/>
           </a:prstGeom>
           <a:solidFill xmlns:a="http://schemas.openxmlformats.org/drawingml/2006/main">
-            <a:srgbClr val="ECEAE5"/>
+            <a:srgbClr val="2D2F35"/>
           </a:solidFill>
           <a:ln xmlns:a="http://schemas.openxmlformats.org/drawingml/2006/main" w="9525">
             <a:solidFill>
-              <a:srgbClr val="C9C6BF"/>
+              <a:srgbClr val="565B66"/>
             </a:solidFill>
             <a:prstDash val="solid"/>
           </a:ln>
@@ -3116,7 +3116,7 @@
           <p:cNvPr id="45" name="after-option-label-2">
             <a:extLst xmlns:a="http://schemas.openxmlformats.org/drawingml/2006/main">
               <a:ext uri="{FF2B5EF4-FFF2-40B4-BE49-F238E27FC236}">
-                <a16:creationId xmlns:a16="http://schemas.microsoft.com/office/drawing/2014/main" id="{3440A67A-3200-42CD-9A00-DE4F412CF754}"/>
+                <a16:creationId xmlns:a16="http://schemas.microsoft.com/office/drawing/2014/main" id="{1D15C02B-EBBE-4F9C-8A5D-D6C231A46F90}"/>
               </a:ext>
             </a:extLst>
           </p:cNvPr>
@@ -3146,14 +3146,14 @@
             <a:pPr algn="l">
               <a:defRPr sz="750" b="1">
                 <a:solidFill>
-                  <a:srgbClr val="817F79"/>
+                  <a:srgbClr val="9096A1"/>
                 </a:solidFill>
               </a:defRPr>
             </a:pPr>
             <a:r>
               <a:rPr sz="750" b="1">
                 <a:solidFill>
-                  <a:srgbClr val="817F79"/>
+                  <a:srgbClr val="9096A1"/>
                 </a:solidFill>
               </a:rPr>
               <a:t>C</a:t>
@@ -3166,7 +3166,7 @@
           <p:cNvPr id="46" name="after-option-copy-2">
             <a:extLst xmlns:a="http://schemas.openxmlformats.org/drawingml/2006/main">
               <a:ext uri="{FF2B5EF4-FFF2-40B4-BE49-F238E27FC236}">
-                <a16:creationId xmlns:a16="http://schemas.microsoft.com/office/drawing/2014/main" id="{1F2570DB-8AC7-4D75-94A4-0600DA0FC76A}"/>
+                <a16:creationId xmlns:a16="http://schemas.microsoft.com/office/drawing/2014/main" id="{99B020B8-C610-4B56-9CF0-1D50BD46C4A7}"/>
               </a:ext>
             </a:extLst>
           </p:cNvPr>
@@ -3196,14 +3196,14 @@
             <a:pPr algn="l">
               <a:defRPr sz="825" b="0">
                 <a:solidFill>
-                  <a:srgbClr val="6C6B66"/>
+                  <a:srgbClr val="ADB2BC"/>
                 </a:solidFill>
               </a:defRPr>
             </a:pPr>
             <a:r>
               <a:rPr sz="825" b="0">
                 <a:solidFill>
-                  <a:srgbClr val="6C6B66"/>
+                  <a:srgbClr val="ADB2BC"/>
                 </a:solidFill>
               </a:rPr>
               <a:t>O(n)</a:t>
@@ -3216,7 +3216,7 @@
           <p:cNvPr id="47" name="after-option-3">
             <a:extLst xmlns:a="http://schemas.openxmlformats.org/drawingml/2006/main">
               <a:ext uri="{FF2B5EF4-FFF2-40B4-BE49-F238E27FC236}">
-                <a16:creationId xmlns:a16="http://schemas.microsoft.com/office/drawing/2014/main" id="{650B482C-3851-4065-8554-5CE1B562F146}"/>
+                <a16:creationId xmlns:a16="http://schemas.microsoft.com/office/drawing/2014/main" id="{B5F694FE-D93E-486E-86B8-CF7AB68EFAD8}"/>
               </a:ext>
             </a:extLst>
           </p:cNvPr>
@@ -3234,11 +3234,11 @@
             <a:avLst/>
           </a:prstGeom>
           <a:solidFill xmlns:a="http://schemas.openxmlformats.org/drawingml/2006/main">
-            <a:srgbClr val="ECEAE5"/>
+            <a:srgbClr val="2D2F35"/>
           </a:solidFill>
           <a:ln xmlns:a="http://schemas.openxmlformats.org/drawingml/2006/main" w="9525">
             <a:solidFill>
-              <a:srgbClr val="C9C6BF"/>
+              <a:srgbClr val="565B66"/>
             </a:solidFill>
             <a:prstDash val="solid"/>
           </a:ln>
@@ -3249,7 +3249,7 @@
           <p:cNvPr id="48" name="after-option-label-3">
             <a:extLst xmlns:a="http://schemas.openxmlformats.org/drawingml/2006/main">
               <a:ext uri="{FF2B5EF4-FFF2-40B4-BE49-F238E27FC236}">
-                <a16:creationId xmlns:a16="http://schemas.microsoft.com/office/drawing/2014/main" id="{C9E2F114-F89A-4687-95F5-9C81E665BFA7}"/>
+                <a16:creationId xmlns:a16="http://schemas.microsoft.com/office/drawing/2014/main" id="{C1F6DDD7-C262-46FE-B0AB-EB3B1818FCF7}"/>
               </a:ext>
             </a:extLst>
           </p:cNvPr>
@@ -3279,14 +3279,14 @@
             <a:pPr algn="l">
               <a:defRPr sz="750" b="1">
                 <a:solidFill>
-                  <a:srgbClr val="817F79"/>
+                  <a:srgbClr val="9096A1"/>
                 </a:solidFill>
               </a:defRPr>
             </a:pPr>
             <a:r>
               <a:rPr sz="750" b="1">
                 <a:solidFill>
-                  <a:srgbClr val="817F79"/>
+                  <a:srgbClr val="9096A1"/>
                 </a:solidFill>
               </a:rPr>
               <a:t>D</a:t>
@@ -3299,7 +3299,7 @@
           <p:cNvPr id="49" name="after-option-copy-3">
             <a:extLst xmlns:a="http://schemas.openxmlformats.org/drawingml/2006/main">
               <a:ext uri="{FF2B5EF4-FFF2-40B4-BE49-F238E27FC236}">
-                <a16:creationId xmlns:a16="http://schemas.microsoft.com/office/drawing/2014/main" id="{1F9EEB01-E920-4A42-88B4-0A473B9A623C}"/>
+                <a16:creationId xmlns:a16="http://schemas.microsoft.com/office/drawing/2014/main" id="{BE51A20B-CAA2-4E46-BE6F-7B0B5C63EF11}"/>
               </a:ext>
             </a:extLst>
           </p:cNvPr>
@@ -3329,14 +3329,14 @@
             <a:pPr algn="l">
               <a:defRPr sz="825" b="0">
                 <a:solidFill>
-                  <a:srgbClr val="6C6B66"/>
+                  <a:srgbClr val="ADB2BC"/>
                 </a:solidFill>
               </a:defRPr>
             </a:pPr>
             <a:r>
               <a:rPr sz="825" b="0">
                 <a:solidFill>
-                  <a:srgbClr val="6C6B66"/>
+                  <a:srgbClr val="ADB2BC"/>
                 </a:solidFill>
               </a:rPr>
               <a:t>O(n log n)</a:t>
@@ -3349,7 +3349,7 @@
           <p:cNvPr id="50" name="after-divider">
             <a:extLst xmlns:a="http://schemas.openxmlformats.org/drawingml/2006/main">
               <a:ext uri="{FF2B5EF4-FFF2-40B4-BE49-F238E27FC236}">
-                <a16:creationId xmlns:a16="http://schemas.microsoft.com/office/drawing/2014/main" id="{7D053966-8525-4130-924F-2ECE79D74DA7}"/>
+                <a16:creationId xmlns:a16="http://schemas.microsoft.com/office/drawing/2014/main" id="{92A763ED-4E43-47EA-B5B0-3371FF0A25E7}"/>
               </a:ext>
             </a:extLst>
           </p:cNvPr>
@@ -3369,7 +3369,7 @@
           <a:noFill xmlns:a="http://schemas.openxmlformats.org/drawingml/2006/main"/>
           <a:ln xmlns:a="http://schemas.openxmlformats.org/drawingml/2006/main" w="9525">
             <a:solidFill>
-              <a:srgbClr val="C9C6BF"/>
+              <a:srgbClr val="565B66"/>
             </a:solidFill>
             <a:prstDash val="solid"/>
           </a:ln>
@@ -3380,7 +3380,7 @@
           <p:cNvPr id="51" name="after-explanation-label">
             <a:extLst xmlns:a="http://schemas.openxmlformats.org/drawingml/2006/main">
               <a:ext uri="{FF2B5EF4-FFF2-40B4-BE49-F238E27FC236}">
-                <a16:creationId xmlns:a16="http://schemas.microsoft.com/office/drawing/2014/main" id="{B7197935-F988-46B1-9E49-455896A7A3AB}"/>
+                <a16:creationId xmlns:a16="http://schemas.microsoft.com/office/drawing/2014/main" id="{53C2E748-867D-4AC1-BEB4-02371F2CD9D8}"/>
               </a:ext>
             </a:extLst>
           </p:cNvPr>
@@ -3410,14 +3410,14 @@
             <a:pPr algn="l">
               <a:defRPr sz="750" b="1">
                 <a:solidFill>
-                  <a:srgbClr val="2C7B45"/>
+                  <a:srgbClr val="A3E635"/>
                 </a:solidFill>
               </a:defRPr>
             </a:pPr>
             <a:r>
               <a:rPr sz="750" b="1">
                 <a:solidFill>
-                  <a:srgbClr val="2C7B45"/>
+                  <a:srgbClr val="A3E635"/>
                 </a:solidFill>
               </a:rPr>
               <a:t>RATIONALE REVEALED</a:t>
@@ -3430,7 +3430,7 @@
           <p:cNvPr id="52" name="after-concept-label">
             <a:extLst xmlns:a="http://schemas.openxmlformats.org/drawingml/2006/main">
               <a:ext uri="{FF2B5EF4-FFF2-40B4-BE49-F238E27FC236}">
-                <a16:creationId xmlns:a16="http://schemas.microsoft.com/office/drawing/2014/main" id="{896839AE-F077-438F-A920-5DDA1FA12C8C}"/>
+                <a16:creationId xmlns:a16="http://schemas.microsoft.com/office/drawing/2014/main" id="{04E7BC2A-A2E0-4C17-9F29-3549BD113388}"/>
               </a:ext>
             </a:extLst>
           </p:cNvPr>
@@ -3460,14 +3460,14 @@
             <a:pPr algn="l">
               <a:defRPr sz="675" b="1">
                 <a:solidFill>
-                  <a:srgbClr val="6C6B66"/>
+                  <a:srgbClr val="ADB2BC"/>
                 </a:solidFill>
               </a:defRPr>
             </a:pPr>
             <a:r>
               <a:rPr sz="675" b="1">
                 <a:solidFill>
-                  <a:srgbClr val="6C6B66"/>
+                  <a:srgbClr val="ADB2BC"/>
                 </a:solidFill>
               </a:rPr>
               <a:t>WHAT THIS TESTS</a:t>
@@ -3480,7 +3480,7 @@
           <p:cNvPr id="53" name="after-concept">
             <a:extLst xmlns:a="http://schemas.openxmlformats.org/drawingml/2006/main">
               <a:ext uri="{FF2B5EF4-FFF2-40B4-BE49-F238E27FC236}">
-                <a16:creationId xmlns:a16="http://schemas.microsoft.com/office/drawing/2014/main" id="{30A25600-118C-4F55-8DFD-C3BADFE0E819}"/>
+                <a16:creationId xmlns:a16="http://schemas.microsoft.com/office/drawing/2014/main" id="{6BB80D71-65D1-4870-91F2-F9809F730480}"/>
               </a:ext>
             </a:extLst>
           </p:cNvPr>
@@ -3510,14 +3510,14 @@
             <a:pPr algn="l">
               <a:defRPr sz="938" b="1">
                 <a:solidFill>
-                  <a:srgbClr val="20201E"/>
+                  <a:srgbClr val="F5F3ED"/>
                 </a:solidFill>
               </a:defRPr>
             </a:pPr>
             <a:r>
               <a:rPr sz="938" b="1">
                 <a:solidFill>
-                  <a:srgbClr val="20201E"/>
+                  <a:srgbClr val="F5F3ED"/>
                 </a:solidFill>
               </a:rPr>
               <a:t>Balanced-tree search height</a:t>
@@ -3530,7 +3530,7 @@
           <p:cNvPr id="54" name="after-reason-rule">
             <a:extLst xmlns:a="http://schemas.openxmlformats.org/drawingml/2006/main">
               <a:ext uri="{FF2B5EF4-FFF2-40B4-BE49-F238E27FC236}">
-                <a16:creationId xmlns:a16="http://schemas.microsoft.com/office/drawing/2014/main" id="{E504D6BB-F8DF-4A13-8DF0-DD07D4E97FCC}"/>
+                <a16:creationId xmlns:a16="http://schemas.microsoft.com/office/drawing/2014/main" id="{3CE858AD-6C28-4149-8D6C-6D0C36A807EA}"/>
               </a:ext>
             </a:extLst>
           </p:cNvPr>
@@ -3550,7 +3550,7 @@
           <a:noFill xmlns:a="http://schemas.openxmlformats.org/drawingml/2006/main"/>
           <a:ln xmlns:a="http://schemas.openxmlformats.org/drawingml/2006/main" w="9525">
             <a:solidFill>
-              <a:srgbClr val="C9C6BF"/>
+              <a:srgbClr val="565B66"/>
             </a:solidFill>
             <a:prstDash val="solid"/>
           </a:ln>
@@ -3561,7 +3561,7 @@
           <p:cNvPr id="55" name="after-explanation">
             <a:extLst xmlns:a="http://schemas.openxmlformats.org/drawingml/2006/main">
               <a:ext uri="{FF2B5EF4-FFF2-40B4-BE49-F238E27FC236}">
-                <a16:creationId xmlns:a16="http://schemas.microsoft.com/office/drawing/2014/main" id="{9363D768-4F05-4373-99F5-4CEBE3BDBC5E}"/>
+                <a16:creationId xmlns:a16="http://schemas.microsoft.com/office/drawing/2014/main" id="{52FBA9BC-7290-4661-B942-017F04BE937A}"/>
               </a:ext>
             </a:extLst>
           </p:cNvPr>
@@ -3591,14 +3591,14 @@
             <a:pPr algn="l">
               <a:defRPr sz="840" b="0">
                 <a:solidFill>
-                  <a:srgbClr val="20201E"/>
+                  <a:srgbClr val="F5F3ED"/>
                 </a:solidFill>
               </a:defRPr>
             </a:pPr>
             <a:r>
               <a:rPr sz="840" b="0">
                 <a:solidFill>
-                  <a:srgbClr val="20201E"/>
+                  <a:srgbClr val="F5F3ED"/>
                 </a:solidFill>
               </a:rPr>
               <a:t>Each comparison discards roughly half of the remaining subtree, so search follows one root-to-leaf path of height O(log n).</a:t>
@@ -3611,7 +3611,7 @@
           <p:cNvPr id="56" name="after-note">
             <a:extLst xmlns:a="http://schemas.openxmlformats.org/drawingml/2006/main">
               <a:ext uri="{FF2B5EF4-FFF2-40B4-BE49-F238E27FC236}">
-                <a16:creationId xmlns:a16="http://schemas.microsoft.com/office/drawing/2014/main" id="{B253C3DC-215F-4F9B-9C8B-B649AADD7103}"/>
+                <a16:creationId xmlns:a16="http://schemas.microsoft.com/office/drawing/2014/main" id="{D8D0DFF5-DB3D-45C2-A114-C8833A059539}"/>
               </a:ext>
             </a:extLst>
           </p:cNvPr>
@@ -3641,14 +3641,14 @@
             <a:pPr algn="l">
               <a:defRPr sz="750" b="0">
                 <a:solidFill>
-                  <a:srgbClr val="6C6B66"/>
+                  <a:srgbClr val="ADB2BC"/>
                 </a:solidFill>
               </a:defRPr>
             </a:pPr>
             <a:r>
               <a:rPr sz="750" b="0">
                 <a:solidFill>
-                  <a:srgbClr val="6C6B66"/>
+                  <a:srgbClr val="ADB2BC"/>
                 </a:solidFill>
               </a:rPr>
               <a:t>The same selection also enables challenge-quality feedback.</a:t>
@@ -3661,7 +3661,7 @@
           <p:cNvPr id="57" name="live-label">
             <a:extLst xmlns:a="http://schemas.openxmlformats.org/drawingml/2006/main">
               <a:ext uri="{FF2B5EF4-FFF2-40B4-BE49-F238E27FC236}">
-                <a16:creationId xmlns:a16="http://schemas.microsoft.com/office/drawing/2014/main" id="{E355A7AB-6E79-47EE-BA77-D577B469D5F0}"/>
+                <a16:creationId xmlns:a16="http://schemas.microsoft.com/office/drawing/2014/main" id="{5B20658E-ADC5-414D-87BD-7C1B057025CF}"/>
               </a:ext>
             </a:extLst>
           </p:cNvPr>
@@ -3691,14 +3691,14 @@
             <a:pPr algn="l">
               <a:defRPr sz="900" b="1">
                 <a:solidFill>
-                  <a:srgbClr val="315D8B"/>
+                  <a:srgbClr val="A78BFA"/>
                 </a:solidFill>
               </a:defRPr>
             </a:pPr>
             <a:r>
               <a:rPr sz="900" b="1">
                 <a:solidFill>
-                  <a:srgbClr val="315D8B"/>
+                  <a:srgbClr val="A78BFA"/>
                 </a:solidFill>
               </a:rPr>
               <a:t>LIVE CHALLENGE CREATION · SEPARATE FROM THE INTERACTION ABOVE</a:t>
@@ -3711,7 +3711,7 @@
           <p:cNvPr id="58" name="live-arrow-0">
             <a:extLst xmlns:a="http://schemas.openxmlformats.org/drawingml/2006/main">
               <a:ext uri="{FF2B5EF4-FFF2-40B4-BE49-F238E27FC236}">
-                <a16:creationId xmlns:a16="http://schemas.microsoft.com/office/drawing/2014/main" id="{D90ECE00-61C5-4156-B395-F1F90991AEE4}"/>
+                <a16:creationId xmlns:a16="http://schemas.microsoft.com/office/drawing/2014/main" id="{6B4BBE21-8C89-4896-A5C8-3F5C4380641C}"/>
               </a:ext>
             </a:extLst>
           </p:cNvPr>
@@ -3729,11 +3729,11 @@
             <a:avLst/>
           </a:prstGeom>
           <a:solidFill xmlns:a="http://schemas.openxmlformats.org/drawingml/2006/main">
-            <a:srgbClr val="315D8B"/>
+            <a:srgbClr val="A78BFA"/>
           </a:solidFill>
           <a:ln xmlns:a="http://schemas.openxmlformats.org/drawingml/2006/main" w="0">
             <a:solidFill>
-              <a:srgbClr val="315D8B"/>
+              <a:srgbClr val="A78BFA"/>
             </a:solidFill>
             <a:prstDash val="solid"/>
           </a:ln>
@@ -3744,7 +3744,7 @@
           <p:cNvPr id="59" name="live-arrow-1">
             <a:extLst xmlns:a="http://schemas.openxmlformats.org/drawingml/2006/main">
               <a:ext uri="{FF2B5EF4-FFF2-40B4-BE49-F238E27FC236}">
-                <a16:creationId xmlns:a16="http://schemas.microsoft.com/office/drawing/2014/main" id="{B7339BC8-52E1-446C-8D81-B283FAC23743}"/>
+                <a16:creationId xmlns:a16="http://schemas.microsoft.com/office/drawing/2014/main" id="{A0C0A60C-8660-4F61-90A3-B265F50231F1}"/>
               </a:ext>
             </a:extLst>
           </p:cNvPr>
@@ -3762,11 +3762,11 @@
             <a:avLst/>
           </a:prstGeom>
           <a:solidFill xmlns:a="http://schemas.openxmlformats.org/drawingml/2006/main">
-            <a:srgbClr val="315D8B"/>
+            <a:srgbClr val="A78BFA"/>
           </a:solidFill>
           <a:ln xmlns:a="http://schemas.openxmlformats.org/drawingml/2006/main" w="0">
             <a:solidFill>
-              <a:srgbClr val="315D8B"/>
+              <a:srgbClr val="A78BFA"/>
             </a:solidFill>
             <a:prstDash val="solid"/>
           </a:ln>
@@ -3777,7 +3777,7 @@
           <p:cNvPr id="60" name="live-arrow-2">
             <a:extLst xmlns:a="http://schemas.openxmlformats.org/drawingml/2006/main">
               <a:ext uri="{FF2B5EF4-FFF2-40B4-BE49-F238E27FC236}">
-                <a16:creationId xmlns:a16="http://schemas.microsoft.com/office/drawing/2014/main" id="{D384C871-E354-475B-A70C-8780AF54F55D}"/>
+                <a16:creationId xmlns:a16="http://schemas.microsoft.com/office/drawing/2014/main" id="{5847261F-FC46-4630-937A-5BFCC7C241A7}"/>
               </a:ext>
             </a:extLst>
           </p:cNvPr>
@@ -3795,11 +3795,11 @@
             <a:avLst/>
           </a:prstGeom>
           <a:solidFill xmlns:a="http://schemas.openxmlformats.org/drawingml/2006/main">
-            <a:srgbClr val="315D8B"/>
+            <a:srgbClr val="A78BFA"/>
           </a:solidFill>
           <a:ln xmlns:a="http://schemas.openxmlformats.org/drawingml/2006/main" w="0">
             <a:solidFill>
-              <a:srgbClr val="315D8B"/>
+              <a:srgbClr val="A78BFA"/>
             </a:solidFill>
             <a:prstDash val="solid"/>
           </a:ln>
@@ -3810,7 +3810,7 @@
           <p:cNvPr id="61" name="live-arrow-3">
             <a:extLst xmlns:a="http://schemas.openxmlformats.org/drawingml/2006/main">
               <a:ext uri="{FF2B5EF4-FFF2-40B4-BE49-F238E27FC236}">
-                <a16:creationId xmlns:a16="http://schemas.microsoft.com/office/drawing/2014/main" id="{4C7D2695-1DD1-498D-B24D-0DB647DA1988}"/>
+                <a16:creationId xmlns:a16="http://schemas.microsoft.com/office/drawing/2014/main" id="{B7C650A4-F3FF-45E9-9511-E2EC4F554989}"/>
               </a:ext>
             </a:extLst>
           </p:cNvPr>
@@ -3828,11 +3828,11 @@
             <a:avLst/>
           </a:prstGeom>
           <a:solidFill xmlns:a="http://schemas.openxmlformats.org/drawingml/2006/main">
-            <a:srgbClr val="2C7B45"/>
+            <a:srgbClr val="A3E635"/>
           </a:solidFill>
           <a:ln xmlns:a="http://schemas.openxmlformats.org/drawingml/2006/main" w="0">
             <a:solidFill>
-              <a:srgbClr val="2C7B45"/>
+              <a:srgbClr val="A3E635"/>
             </a:solidFill>
             <a:prstDash val="solid"/>
           </a:ln>
@@ -3843,7 +3843,7 @@
           <p:cNvPr id="62" name="live-node-0">
             <a:extLst xmlns:a="http://schemas.openxmlformats.org/drawingml/2006/main">
               <a:ext uri="{FF2B5EF4-FFF2-40B4-BE49-F238E27FC236}">
-                <a16:creationId xmlns:a16="http://schemas.microsoft.com/office/drawing/2014/main" id="{CBED2B95-CA61-4754-AA36-83D71E9ECAB7}"/>
+                <a16:creationId xmlns:a16="http://schemas.microsoft.com/office/drawing/2014/main" id="{E5CCF8B6-81AA-4555-B050-0E168262A4F2}"/>
               </a:ext>
             </a:extLst>
           </p:cNvPr>
@@ -3863,11 +3863,11 @@
             </a:avLst>
           </a:prstGeom>
           <a:solidFill xmlns:a="http://schemas.openxmlformats.org/drawingml/2006/main">
-            <a:srgbClr val="E6EDF4"/>
+            <a:srgbClr val="302B46"/>
           </a:solidFill>
           <a:ln xmlns:a="http://schemas.openxmlformats.org/drawingml/2006/main" w="9525">
             <a:solidFill>
-              <a:srgbClr val="315D8B"/>
+              <a:srgbClr val="A78BFA"/>
             </a:solidFill>
             <a:prstDash val="solid"/>
           </a:ln>
@@ -3878,7 +3878,7 @@
           <p:cNvPr id="63" name="live-head-0">
             <a:extLst xmlns:a="http://schemas.openxmlformats.org/drawingml/2006/main">
               <a:ext uri="{FF2B5EF4-FFF2-40B4-BE49-F238E27FC236}">
-                <a16:creationId xmlns:a16="http://schemas.microsoft.com/office/drawing/2014/main" id="{CDE037DB-9B2E-4291-92EE-53F7D7E05A9B}"/>
+                <a16:creationId xmlns:a16="http://schemas.microsoft.com/office/drawing/2014/main" id="{7CDA7DB6-D1DC-480B-B587-5B8B01705F05}"/>
               </a:ext>
             </a:extLst>
           </p:cNvPr>
@@ -3908,14 +3908,14 @@
             <a:pPr algn="l">
               <a:defRPr sz="713" b="1">
                 <a:solidFill>
-                  <a:srgbClr val="315D8B"/>
+                  <a:srgbClr val="A78BFA"/>
                 </a:solidFill>
               </a:defRPr>
             </a:pPr>
             <a:r>
               <a:rPr sz="713" b="1">
                 <a:solidFill>
-                  <a:srgbClr val="315D8B"/>
+                  <a:srgbClr val="A78BFA"/>
                 </a:solidFill>
               </a:rPr>
               <a:t>SESSION</a:t>
@@ -3928,7 +3928,7 @@
           <p:cNvPr id="64" name="live-copy-0">
             <a:extLst xmlns:a="http://schemas.openxmlformats.org/drawingml/2006/main">
               <a:ext uri="{FF2B5EF4-FFF2-40B4-BE49-F238E27FC236}">
-                <a16:creationId xmlns:a16="http://schemas.microsoft.com/office/drawing/2014/main" id="{6006E04B-C9FB-4158-826F-A59493140AFB}"/>
+                <a16:creationId xmlns:a16="http://schemas.microsoft.com/office/drawing/2014/main" id="{3F43CA5A-99F8-4C96-A6DE-81DC4D1C9978}"/>
               </a:ext>
             </a:extLst>
           </p:cNvPr>
@@ -3958,14 +3958,14 @@
             <a:pPr algn="l">
               <a:defRPr sz="863" b="1">
                 <a:solidFill>
-                  <a:srgbClr val="20201E"/>
+                  <a:srgbClr val="F5F3ED"/>
                 </a:solidFill>
               </a:defRPr>
             </a:pPr>
             <a:r>
               <a:rPr sz="863" b="1">
                 <a:solidFill>
-                  <a:srgbClr val="20201E"/>
+                  <a:srgbClr val="F5F3ED"/>
                 </a:solidFill>
               </a:rPr>
               <a:t>Clerk user</a:t>
@@ -3978,7 +3978,7 @@
           <p:cNvPr id="65" name="live-node-1">
             <a:extLst xmlns:a="http://schemas.openxmlformats.org/drawingml/2006/main">
               <a:ext uri="{FF2B5EF4-FFF2-40B4-BE49-F238E27FC236}">
-                <a16:creationId xmlns:a16="http://schemas.microsoft.com/office/drawing/2014/main" id="{DE68ADAF-A1AC-44C8-854D-B6641F058052}"/>
+                <a16:creationId xmlns:a16="http://schemas.microsoft.com/office/drawing/2014/main" id="{262572B9-8830-45FC-B7A3-357A06149272}"/>
               </a:ext>
             </a:extLst>
           </p:cNvPr>
@@ -3998,11 +3998,11 @@
             </a:avLst>
           </a:prstGeom>
           <a:solidFill xmlns:a="http://schemas.openxmlformats.org/drawingml/2006/main">
-            <a:srgbClr val="E6EDF4"/>
+            <a:srgbClr val="302B46"/>
           </a:solidFill>
           <a:ln xmlns:a="http://schemas.openxmlformats.org/drawingml/2006/main" w="9525">
             <a:solidFill>
-              <a:srgbClr val="315D8B"/>
+              <a:srgbClr val="A78BFA"/>
             </a:solidFill>
             <a:prstDash val="solid"/>
           </a:ln>
@@ -4013,7 +4013,7 @@
           <p:cNvPr id="66" name="live-head-1">
             <a:extLst xmlns:a="http://schemas.openxmlformats.org/drawingml/2006/main">
               <a:ext uri="{FF2B5EF4-FFF2-40B4-BE49-F238E27FC236}">
-                <a16:creationId xmlns:a16="http://schemas.microsoft.com/office/drawing/2014/main" id="{534EE618-D3B7-45F7-A93E-D82801FE853F}"/>
+                <a16:creationId xmlns:a16="http://schemas.microsoft.com/office/drawing/2014/main" id="{52D9E2AC-6048-418E-B24B-2CB7E524C4BC}"/>
               </a:ext>
             </a:extLst>
           </p:cNvPr>
@@ -4043,14 +4043,14 @@
             <a:pPr algn="l">
               <a:defRPr sz="713" b="1">
                 <a:solidFill>
-                  <a:srgbClr val="315D8B"/>
+                  <a:srgbClr val="A78BFA"/>
                 </a:solidFill>
               </a:defRPr>
             </a:pPr>
             <a:r>
               <a:rPr sz="713" b="1">
                 <a:solidFill>
-                  <a:srgbClr val="315D8B"/>
+                  <a:srgbClr val="A78BFA"/>
                 </a:solidFill>
               </a:rPr>
               <a:t>QUOTA</a:t>
@@ -4063,7 +4063,7 @@
           <p:cNvPr id="67" name="live-copy-1">
             <a:extLst xmlns:a="http://schemas.openxmlformats.org/drawingml/2006/main">
               <a:ext uri="{FF2B5EF4-FFF2-40B4-BE49-F238E27FC236}">
-                <a16:creationId xmlns:a16="http://schemas.microsoft.com/office/drawing/2014/main" id="{20D107BB-3525-43B6-B489-1FA0409ABF95}"/>
+                <a16:creationId xmlns:a16="http://schemas.microsoft.com/office/drawing/2014/main" id="{CF9789AA-05EC-4A5F-825F-92942CEA828B}"/>
               </a:ext>
             </a:extLst>
           </p:cNvPr>
@@ -4093,14 +4093,14 @@
             <a:pPr algn="l">
               <a:defRPr sz="863" b="1">
                 <a:solidFill>
-                  <a:srgbClr val="20201E"/>
+                  <a:srgbClr val="F5F3ED"/>
                 </a:solidFill>
               </a:defRPr>
             </a:pPr>
             <a:r>
               <a:rPr sz="863" b="1">
                 <a:solidFill>
-                  <a:srgbClr val="20201E"/>
+                  <a:srgbClr val="F5F3ED"/>
                 </a:solidFill>
               </a:rPr>
               <a:t>&gt; 0</a:t>
@@ -4113,7 +4113,7 @@
           <p:cNvPr id="68" name="live-node-2">
             <a:extLst xmlns:a="http://schemas.openxmlformats.org/drawingml/2006/main">
               <a:ext uri="{FF2B5EF4-FFF2-40B4-BE49-F238E27FC236}">
-                <a16:creationId xmlns:a16="http://schemas.microsoft.com/office/drawing/2014/main" id="{9FAE554E-7B03-4941-821B-23F0C87DA0C0}"/>
+                <a16:creationId xmlns:a16="http://schemas.microsoft.com/office/drawing/2014/main" id="{8C2013AF-8AE6-4BB0-A039-5AF5E01F29E2}"/>
               </a:ext>
             </a:extLst>
           </p:cNvPr>
@@ -4133,11 +4133,11 @@
             </a:avLst>
           </a:prstGeom>
           <a:solidFill xmlns:a="http://schemas.openxmlformats.org/drawingml/2006/main">
-            <a:srgbClr val="E6EDF4"/>
+            <a:srgbClr val="302B46"/>
           </a:solidFill>
           <a:ln xmlns:a="http://schemas.openxmlformats.org/drawingml/2006/main" w="9525">
             <a:solidFill>
-              <a:srgbClr val="315D8B"/>
+              <a:srgbClr val="A78BFA"/>
             </a:solidFill>
             <a:prstDash val="solid"/>
           </a:ln>
@@ -4148,7 +4148,7 @@
           <p:cNvPr id="69" name="live-head-2">
             <a:extLst xmlns:a="http://schemas.openxmlformats.org/drawingml/2006/main">
               <a:ext uri="{FF2B5EF4-FFF2-40B4-BE49-F238E27FC236}">
-                <a16:creationId xmlns:a16="http://schemas.microsoft.com/office/drawing/2014/main" id="{4C8B3F57-A6D4-4ED5-9D9F-F4B9F908BB87}"/>
+                <a16:creationId xmlns:a16="http://schemas.microsoft.com/office/drawing/2014/main" id="{0A2C57FA-BDE8-4FED-A7D8-4A4CD4EB2E3C}"/>
               </a:ext>
             </a:extLst>
           </p:cNvPr>
@@ -4178,14 +4178,14 @@
             <a:pPr algn="l">
               <a:defRPr sz="713" b="1">
                 <a:solidFill>
-                  <a:srgbClr val="315D8B"/>
+                  <a:srgbClr val="A78BFA"/>
                 </a:solidFill>
               </a:defRPr>
             </a:pPr>
             <a:r>
               <a:rPr sz="713" b="1">
                 <a:solidFill>
-                  <a:srgbClr val="315D8B"/>
+                  <a:srgbClr val="A78BFA"/>
                 </a:solidFill>
               </a:rPr>
               <a:t>PROVIDER</a:t>
@@ -4198,7 +4198,7 @@
           <p:cNvPr id="70" name="live-copy-2">
             <a:extLst xmlns:a="http://schemas.openxmlformats.org/drawingml/2006/main">
               <a:ext uri="{FF2B5EF4-FFF2-40B4-BE49-F238E27FC236}">
-                <a16:creationId xmlns:a16="http://schemas.microsoft.com/office/drawing/2014/main" id="{1991A850-39E8-4825-8FD3-BBC0A79AFB7B}"/>
+                <a16:creationId xmlns:a16="http://schemas.microsoft.com/office/drawing/2014/main" id="{53332E5B-79A1-41C6-B784-5CC23190D3D3}"/>
               </a:ext>
             </a:extLst>
           </p:cNvPr>
@@ -4228,14 +4228,14 @@
             <a:pPr algn="l">
               <a:defRPr sz="863" b="1">
                 <a:solidFill>
-                  <a:srgbClr val="20201E"/>
+                  <a:srgbClr val="F5F3ED"/>
                 </a:solidFill>
               </a:defRPr>
             </a:pPr>
             <a:r>
               <a:rPr sz="863" b="1">
                 <a:solidFill>
-                  <a:srgbClr val="20201E"/>
+                  <a:srgbClr val="F5F3ED"/>
                 </a:solidFill>
               </a:rPr>
               <a:t>one JSON</a:t>
@@ -4248,7 +4248,7 @@
           <p:cNvPr id="71" name="live-node-3">
             <a:extLst xmlns:a="http://schemas.openxmlformats.org/drawingml/2006/main">
               <a:ext uri="{FF2B5EF4-FFF2-40B4-BE49-F238E27FC236}">
-                <a16:creationId xmlns:a16="http://schemas.microsoft.com/office/drawing/2014/main" id="{25378AED-5886-46BD-9DC1-132A44EEF26A}"/>
+                <a16:creationId xmlns:a16="http://schemas.microsoft.com/office/drawing/2014/main" id="{4424E2CC-40EA-43F5-BE51-C35FFC6F6050}"/>
               </a:ext>
             </a:extLst>
           </p:cNvPr>
@@ -4268,11 +4268,11 @@
             </a:avLst>
           </a:prstGeom>
           <a:solidFill xmlns:a="http://schemas.openxmlformats.org/drawingml/2006/main">
-            <a:srgbClr val="E6EDF4"/>
+            <a:srgbClr val="302B46"/>
           </a:solidFill>
           <a:ln xmlns:a="http://schemas.openxmlformats.org/drawingml/2006/main" w="9525">
             <a:solidFill>
-              <a:srgbClr val="315D8B"/>
+              <a:srgbClr val="A78BFA"/>
             </a:solidFill>
             <a:prstDash val="solid"/>
           </a:ln>
@@ -4283,7 +4283,7 @@
           <p:cNvPr id="72" name="live-head-3">
             <a:extLst xmlns:a="http://schemas.openxmlformats.org/drawingml/2006/main">
               <a:ext uri="{FF2B5EF4-FFF2-40B4-BE49-F238E27FC236}">
-                <a16:creationId xmlns:a16="http://schemas.microsoft.com/office/drawing/2014/main" id="{28D5CE41-A512-4AA4-9D29-834222CF0F9F}"/>
+                <a16:creationId xmlns:a16="http://schemas.microsoft.com/office/drawing/2014/main" id="{CFF8517A-7B53-4C57-AE18-00D3C12D3BC6}"/>
               </a:ext>
             </a:extLst>
           </p:cNvPr>
@@ -4313,14 +4313,14 @@
             <a:pPr algn="l">
               <a:defRPr sz="713" b="1">
                 <a:solidFill>
-                  <a:srgbClr val="315D8B"/>
+                  <a:srgbClr val="A78BFA"/>
                 </a:solidFill>
               </a:defRPr>
             </a:pPr>
             <a:r>
               <a:rPr sz="713" b="1">
                 <a:solidFill>
-                  <a:srgbClr val="315D8B"/>
+                  <a:srgbClr val="A78BFA"/>
                 </a:solidFill>
               </a:rPr>
               <a:t>PYDANTIC</a:t>
@@ -4333,7 +4333,7 @@
           <p:cNvPr id="73" name="live-copy-3">
             <a:extLst xmlns:a="http://schemas.openxmlformats.org/drawingml/2006/main">
               <a:ext uri="{FF2B5EF4-FFF2-40B4-BE49-F238E27FC236}">
-                <a16:creationId xmlns:a16="http://schemas.microsoft.com/office/drawing/2014/main" id="{D772FC07-E7FA-42A5-85BA-E10624A75D89}"/>
+                <a16:creationId xmlns:a16="http://schemas.microsoft.com/office/drawing/2014/main" id="{06E88955-89A5-4527-908F-B36C916CCB2B}"/>
               </a:ext>
             </a:extLst>
           </p:cNvPr>
@@ -4363,14 +4363,14 @@
             <a:pPr algn="l">
               <a:defRPr sz="863" b="1">
                 <a:solidFill>
-                  <a:srgbClr val="20201E"/>
+                  <a:srgbClr val="F5F3ED"/>
                 </a:solidFill>
               </a:defRPr>
             </a:pPr>
             <a:r>
               <a:rPr sz="863" b="1">
                 <a:solidFill>
-                  <a:srgbClr val="20201E"/>
+                  <a:srgbClr val="F5F3ED"/>
                 </a:solidFill>
               </a:rPr>
               <a:t>4 unique</a:t>
@@ -4380,14 +4380,14 @@
             <a:pPr algn="l">
               <a:defRPr sz="863" b="1">
                 <a:solidFill>
-                  <a:srgbClr val="20201E"/>
+                  <a:srgbClr val="F5F3ED"/>
                 </a:solidFill>
               </a:defRPr>
             </a:pPr>
             <a:r>
               <a:rPr sz="863" b="1">
                 <a:solidFill>
-                  <a:srgbClr val="20201E"/>
+                  <a:srgbClr val="F5F3ED"/>
                 </a:solidFill>
               </a:rPr>
               <a:t>answer 0–3</a:t>
@@ -4400,7 +4400,7 @@
           <p:cNvPr id="74" name="live-node-4">
             <a:extLst xmlns:a="http://schemas.openxmlformats.org/drawingml/2006/main">
               <a:ext uri="{FF2B5EF4-FFF2-40B4-BE49-F238E27FC236}">
-                <a16:creationId xmlns:a16="http://schemas.microsoft.com/office/drawing/2014/main" id="{5D10B16B-6EB1-40ED-96A9-9EBFE18BBF29}"/>
+                <a16:creationId xmlns:a16="http://schemas.microsoft.com/office/drawing/2014/main" id="{0A93F6AC-FE2C-40EB-8341-61BCD5B6B6A2}"/>
               </a:ext>
             </a:extLst>
           </p:cNvPr>
@@ -4420,11 +4420,11 @@
             </a:avLst>
           </a:prstGeom>
           <a:solidFill xmlns:a="http://schemas.openxmlformats.org/drawingml/2006/main">
-            <a:srgbClr val="E7F1E9"/>
+            <a:srgbClr val="263323"/>
           </a:solidFill>
           <a:ln xmlns:a="http://schemas.openxmlformats.org/drawingml/2006/main" w="13335">
             <a:solidFill>
-              <a:srgbClr val="2C7B45"/>
+              <a:srgbClr val="A3E635"/>
             </a:solidFill>
             <a:prstDash val="solid"/>
           </a:ln>
@@ -4435,7 +4435,7 @@
           <p:cNvPr id="75" name="live-head-4">
             <a:extLst xmlns:a="http://schemas.openxmlformats.org/drawingml/2006/main">
               <a:ext uri="{FF2B5EF4-FFF2-40B4-BE49-F238E27FC236}">
-                <a16:creationId xmlns:a16="http://schemas.microsoft.com/office/drawing/2014/main" id="{8822AAE0-CB72-4096-A2AE-80B717496832}"/>
+                <a16:creationId xmlns:a16="http://schemas.microsoft.com/office/drawing/2014/main" id="{0E36EF40-71DB-4202-BD6C-296DFCB2DC27}"/>
               </a:ext>
             </a:extLst>
           </p:cNvPr>
@@ -4465,14 +4465,14 @@
             <a:pPr algn="l">
               <a:defRPr sz="713" b="1">
                 <a:solidFill>
-                  <a:srgbClr val="2C7B45"/>
+                  <a:srgbClr val="A3E635"/>
                 </a:solidFill>
               </a:defRPr>
             </a:pPr>
             <a:r>
               <a:rPr sz="713" b="1">
                 <a:solidFill>
-                  <a:srgbClr val="2C7B45"/>
+                  <a:srgbClr val="A3E635"/>
                 </a:solidFill>
               </a:rPr>
               <a:t>TRANSACTION</a:t>
@@ -4485,7 +4485,7 @@
           <p:cNvPr id="76" name="live-copy-4">
             <a:extLst xmlns:a="http://schemas.openxmlformats.org/drawingml/2006/main">
               <a:ext uri="{FF2B5EF4-FFF2-40B4-BE49-F238E27FC236}">
-                <a16:creationId xmlns:a16="http://schemas.microsoft.com/office/drawing/2014/main" id="{99DE63E3-450A-4B4C-B84F-BAA087F86A08}"/>
+                <a16:creationId xmlns:a16="http://schemas.microsoft.com/office/drawing/2014/main" id="{F97CD7DA-40DE-4730-A1E1-9ACABC69C45E}"/>
               </a:ext>
             </a:extLst>
           </p:cNvPr>
@@ -4515,14 +4515,14 @@
             <a:pPr algn="ctr">
               <a:defRPr sz="863" b="1">
                 <a:solidFill>
-                  <a:srgbClr val="20201E"/>
+                  <a:srgbClr val="F5F3ED"/>
                 </a:solidFill>
               </a:defRPr>
             </a:pPr>
             <a:r>
               <a:rPr sz="863" b="1">
                 <a:solidFill>
-                  <a:srgbClr val="20201E"/>
+                  <a:srgbClr val="F5F3ED"/>
                 </a:solidFill>
               </a:rPr>
               <a:t>challenge +</a:t>
@@ -4532,14 +4532,14 @@
             <a:pPr algn="ctr">
               <a:defRPr sz="863" b="1">
                 <a:solidFill>
-                  <a:srgbClr val="20201E"/>
+                  <a:srgbClr val="F5F3ED"/>
                 </a:solidFill>
               </a:defRPr>
             </a:pPr>
             <a:r>
               <a:rPr sz="863" b="1">
                 <a:solidFill>
-                  <a:srgbClr val="20201E"/>
+                  <a:srgbClr val="F5F3ED"/>
                 </a:solidFill>
               </a:rPr>
               <a:t>quota − 1</a:t>
@@ -4552,7 +4552,7 @@
           <p:cNvPr id="77" name="demo-note">
             <a:extLst xmlns:a="http://schemas.openxmlformats.org/drawingml/2006/main">
               <a:ext uri="{FF2B5EF4-FFF2-40B4-BE49-F238E27FC236}">
-                <a16:creationId xmlns:a16="http://schemas.microsoft.com/office/drawing/2014/main" id="{11A3D685-B4DF-4FCD-A376-C9C5BDEC766F}"/>
+                <a16:creationId xmlns:a16="http://schemas.microsoft.com/office/drawing/2014/main" id="{865B7321-317B-410E-A74D-13F009BB45BF}"/>
               </a:ext>
             </a:extLst>
           </p:cNvPr>
@@ -4572,11 +4572,11 @@
             </a:avLst>
           </a:prstGeom>
           <a:solidFill xmlns:a="http://schemas.openxmlformats.org/drawingml/2006/main">
-            <a:srgbClr val="ECEAE5"/>
+            <a:srgbClr val="2D2F35"/>
           </a:solidFill>
           <a:ln xmlns:a="http://schemas.openxmlformats.org/drawingml/2006/main" w="9525">
             <a:solidFill>
-              <a:srgbClr val="817F79"/>
+              <a:srgbClr val="9096A1"/>
             </a:solidFill>
             <a:prstDash val="solid"/>
           </a:ln>
@@ -4587,7 +4587,7 @@
           <p:cNvPr id="78" name="demo-note-head">
             <a:extLst xmlns:a="http://schemas.openxmlformats.org/drawingml/2006/main">
               <a:ext uri="{FF2B5EF4-FFF2-40B4-BE49-F238E27FC236}">
-                <a16:creationId xmlns:a16="http://schemas.microsoft.com/office/drawing/2014/main" id="{0F24EC64-771C-4DA1-848C-55F12AB245B5}"/>
+                <a16:creationId xmlns:a16="http://schemas.microsoft.com/office/drawing/2014/main" id="{E0C6E730-0398-4CF9-B83F-35B8A56C0BBB}"/>
               </a:ext>
             </a:extLst>
           </p:cNvPr>
@@ -4617,14 +4617,14 @@
             <a:pPr algn="l">
               <a:defRPr sz="713" b="1">
                 <a:solidFill>
-                  <a:srgbClr val="817F79"/>
+                  <a:srgbClr val="9096A1"/>
                 </a:solidFill>
               </a:defRPr>
             </a:pPr>
             <a:r>
               <a:rPr sz="713" b="1">
                 <a:solidFill>
-                  <a:srgbClr val="817F79"/>
+                  <a:srgbClr val="9096A1"/>
                 </a:solidFill>
               </a:rPr>
               <a:t>DEMO</a:t>
@@ -4637,7 +4637,7 @@
           <p:cNvPr id="79" name="demo-note-copy">
             <a:extLst xmlns:a="http://schemas.openxmlformats.org/drawingml/2006/main">
               <a:ext uri="{FF2B5EF4-FFF2-40B4-BE49-F238E27FC236}">
-                <a16:creationId xmlns:a16="http://schemas.microsoft.com/office/drawing/2014/main" id="{91222B0F-0DFD-409F-9B0F-C3669CC6076F}"/>
+                <a16:creationId xmlns:a16="http://schemas.microsoft.com/office/drawing/2014/main" id="{09BB28B2-F7B6-467F-A61F-913ABD5BF2AF}"/>
               </a:ext>
             </a:extLst>
           </p:cNvPr>
@@ -4667,14 +4667,14 @@
             <a:pPr algn="ctr">
               <a:defRPr sz="750" b="0">
                 <a:solidFill>
-                  <a:srgbClr val="20201E"/>
+                  <a:srgbClr val="F5F3ED"/>
                 </a:solidFill>
               </a:defRPr>
             </a:pPr>
             <a:r>
               <a:rPr sz="750" b="0">
                 <a:solidFill>
-                  <a:srgbClr val="20201E"/>
+                  <a:srgbClr val="F5F3ED"/>
                 </a:solidFill>
               </a:rPr>
               <a:t>same frontend contract; no auth, provider, or DB</a:t>
@@ -4687,7 +4687,7 @@
           <p:cNvPr id="80" name="rollback-link">
             <a:extLst xmlns:a="http://schemas.openxmlformats.org/drawingml/2006/main">
               <a:ext uri="{FF2B5EF4-FFF2-40B4-BE49-F238E27FC236}">
-                <a16:creationId xmlns:a16="http://schemas.microsoft.com/office/drawing/2014/main" id="{ED060286-C297-4CC3-973F-363E3C4691EF}"/>
+                <a16:creationId xmlns:a16="http://schemas.microsoft.com/office/drawing/2014/main" id="{AD2EDC06-4D6F-43C5-B9FF-6821E723F3A2}"/>
               </a:ext>
             </a:extLst>
           </p:cNvPr>
@@ -4707,7 +4707,7 @@
           <a:noFill xmlns:a="http://schemas.openxmlformats.org/drawingml/2006/main"/>
           <a:ln xmlns:a="http://schemas.openxmlformats.org/drawingml/2006/main" w="11430">
             <a:solidFill>
-              <a:srgbClr val="A56509"/>
+              <a:srgbClr val="F2C14E"/>
             </a:solidFill>
             <a:prstDash val="dash"/>
           </a:ln>
@@ -4718,7 +4718,7 @@
           <p:cNvPr id="81" name="rollback">
             <a:extLst xmlns:a="http://schemas.openxmlformats.org/drawingml/2006/main">
               <a:ext uri="{FF2B5EF4-FFF2-40B4-BE49-F238E27FC236}">
-                <a16:creationId xmlns:a16="http://schemas.microsoft.com/office/drawing/2014/main" id="{946824E8-9140-42DB-8431-31A429A9AB20}"/>
+                <a16:creationId xmlns:a16="http://schemas.microsoft.com/office/drawing/2014/main" id="{DDD7FCD8-576E-468B-8132-B657E6E936DF}"/>
               </a:ext>
             </a:extLst>
           </p:cNvPr>
@@ -4748,14 +4748,14 @@
             <a:pPr algn="ctr">
               <a:defRPr sz="863" b="1">
                 <a:solidFill>
-                  <a:srgbClr val="A56509"/>
+                  <a:srgbClr val="F2C14E"/>
                 </a:solidFill>
               </a:defRPr>
             </a:pPr>
             <a:r>
               <a:rPr sz="863" b="1">
                 <a:solidFill>
-                  <a:srgbClr val="A56509"/>
+                  <a:srgbClr val="F2C14E"/>
                 </a:solidFill>
               </a:rPr>
               <a:t>any failure → rollback; quota unchanged</a:t>
@@ -4768,7 +4768,7 @@
           <p:cNvPr id="82" name="footer-rule">
             <a:extLst xmlns:a="http://schemas.openxmlformats.org/drawingml/2006/main">
               <a:ext uri="{FF2B5EF4-FFF2-40B4-BE49-F238E27FC236}">
-                <a16:creationId xmlns:a16="http://schemas.microsoft.com/office/drawing/2014/main" id="{260BBA04-26E7-4F27-94F8-79AA7D655EE0}"/>
+                <a16:creationId xmlns:a16="http://schemas.microsoft.com/office/drawing/2014/main" id="{6CC62291-CBF2-49E1-A4FC-E2DF3CADAA81}"/>
               </a:ext>
             </a:extLst>
           </p:cNvPr>
@@ -4788,7 +4788,7 @@
           <a:noFill xmlns:a="http://schemas.openxmlformats.org/drawingml/2006/main"/>
           <a:ln xmlns:a="http://schemas.openxmlformats.org/drawingml/2006/main" w="13335">
             <a:solidFill>
-              <a:srgbClr val="20201E"/>
+              <a:srgbClr val="F5F3ED"/>
             </a:solidFill>
             <a:prstDash val="solid"/>
           </a:ln>
@@ -4799,7 +4799,7 @@
           <p:cNvPr id="83" name="boundary-head">
             <a:extLst xmlns:a="http://schemas.openxmlformats.org/drawingml/2006/main">
               <a:ext uri="{FF2B5EF4-FFF2-40B4-BE49-F238E27FC236}">
-                <a16:creationId xmlns:a16="http://schemas.microsoft.com/office/drawing/2014/main" id="{82220321-B467-4E72-A33C-FFA7802F3771}"/>
+                <a16:creationId xmlns:a16="http://schemas.microsoft.com/office/drawing/2014/main" id="{483675A4-9526-4FE6-8090-E6DD52CE6E02}"/>
               </a:ext>
             </a:extLst>
           </p:cNvPr>
@@ -4829,14 +4829,14 @@
             <a:pPr algn="l">
               <a:defRPr sz="788" b="1">
                 <a:solidFill>
-                  <a:srgbClr val="2C7B45"/>
+                  <a:srgbClr val="A3E635"/>
                 </a:solidFill>
               </a:defRPr>
             </a:pPr>
             <a:r>
               <a:rPr sz="788" b="1">
                 <a:solidFill>
-                  <a:srgbClr val="2C7B45"/>
+                  <a:srgbClr val="A3E635"/>
                 </a:solidFill>
               </a:rPr>
               <a:t>SUPPORTED</a:t>
@@ -4849,7 +4849,7 @@
           <p:cNvPr id="84" name="boundary-supported">
             <a:extLst xmlns:a="http://schemas.openxmlformats.org/drawingml/2006/main">
               <a:ext uri="{FF2B5EF4-FFF2-40B4-BE49-F238E27FC236}">
-                <a16:creationId xmlns:a16="http://schemas.microsoft.com/office/drawing/2014/main" id="{780C40DB-C262-43E4-ABA4-09624A1C0CD6}"/>
+                <a16:creationId xmlns:a16="http://schemas.microsoft.com/office/drawing/2014/main" id="{A9991169-4703-4F71-9CC5-475108EA6401}"/>
               </a:ext>
             </a:extLst>
           </p:cNvPr>
@@ -4879,14 +4879,14 @@
             <a:pPr algn="l">
               <a:defRPr sz="863" b="1">
                 <a:solidFill>
-                  <a:srgbClr val="20201E"/>
+                  <a:srgbClr val="F5F3ED"/>
                 </a:solidFill>
               </a:defRPr>
             </a:pPr>
             <a:r>
               <a:rPr sz="863" b="1">
                 <a:solidFill>
-                  <a:srgbClr val="20201E"/>
+                  <a:srgbClr val="F5F3ED"/>
                 </a:solidFill>
               </a:rPr>
               <a:t>commit-before-rationale interaction · exact four-option validation · atomic challenge-and-quota write</a:t>
@@ -4899,7 +4899,7 @@
           <p:cNvPr id="85" name="not-head">
             <a:extLst xmlns:a="http://schemas.openxmlformats.org/drawingml/2006/main">
               <a:ext uri="{FF2B5EF4-FFF2-40B4-BE49-F238E27FC236}">
-                <a16:creationId xmlns:a16="http://schemas.microsoft.com/office/drawing/2014/main" id="{BA523D94-CD79-4D45-A13C-8F8744DEB20F}"/>
+                <a16:creationId xmlns:a16="http://schemas.microsoft.com/office/drawing/2014/main" id="{D888A54D-C520-4272-9EA7-DA72A9427A3D}"/>
               </a:ext>
             </a:extLst>
           </p:cNvPr>
@@ -4929,14 +4929,14 @@
             <a:pPr algn="l">
               <a:defRPr sz="788" b="1">
                 <a:solidFill>
-                  <a:srgbClr val="AA4138"/>
+                  <a:srgbClr val="FF6B6B"/>
                 </a:solidFill>
               </a:defRPr>
             </a:pPr>
             <a:r>
               <a:rPr sz="788" b="1">
                 <a:solidFill>
-                  <a:srgbClr val="AA4138"/>
+                  <a:srgbClr val="FF6B6B"/>
                 </a:solidFill>
               </a:rPr>
               <a:t>NOT CLAIMED</a:t>
@@ -4949,7 +4949,7 @@
           <p:cNvPr id="86" name="not-copy">
             <a:extLst xmlns:a="http://schemas.openxmlformats.org/drawingml/2006/main">
               <a:ext uri="{FF2B5EF4-FFF2-40B4-BE49-F238E27FC236}">
-                <a16:creationId xmlns:a16="http://schemas.microsoft.com/office/drawing/2014/main" id="{8E069850-5899-4DA2-8485-1FE673A8840A}"/>
+                <a16:creationId xmlns:a16="http://schemas.microsoft.com/office/drawing/2014/main" id="{9E8C04B2-BEE6-4A8D-AF4B-18A822057F0A}"/>
               </a:ext>
             </a:extLst>
           </p:cNvPr>
@@ -4979,14 +4979,14 @@
             <a:pPr algn="l">
               <a:defRPr sz="788" b="0">
                 <a:solidFill>
-                  <a:srgbClr val="20201E"/>
+                  <a:srgbClr val="F5F3ED"/>
                 </a:solidFill>
               </a:defRPr>
             </a:pPr>
             <a:r>
               <a:rPr sz="788" b="0">
                 <a:solidFill>
-                  <a:srgbClr val="20201E"/>
+                  <a:srgbClr val="F5F3ED"/>
                 </a:solidFill>
               </a:rPr>
               <a:t>learning outcomes, interview performance, question quality, or provider accuracy</a:t>
@@ -4999,7 +4999,7 @@
           <p:cNvPr id="87" name="sources">
             <a:extLst xmlns:a="http://schemas.openxmlformats.org/drawingml/2006/main">
               <a:ext uri="{FF2B5EF4-FFF2-40B4-BE49-F238E27FC236}">
-                <a16:creationId xmlns:a16="http://schemas.microsoft.com/office/drawing/2014/main" id="{6653B466-3CFD-48A5-BDEF-6DFD787E6C21}"/>
+                <a16:creationId xmlns:a16="http://schemas.microsoft.com/office/drawing/2014/main" id="{DA3F8A56-1660-40F3-AC49-6A039B88F2E0}"/>
               </a:ext>
             </a:extLst>
           </p:cNvPr>
@@ -5029,14 +5029,14 @@
             <a:pPr algn="ctr">
               <a:defRPr sz="675" b="0">
                 <a:solidFill>
-                  <a:srgbClr val="6C6B66"/>
+                  <a:srgbClr val="ADB2BC"/>
                 </a:solidFill>
               </a:defRPr>
             </a:pPr>
             <a:r>
               <a:rPr sz="675" b="0">
                 <a:solidFill>
-                  <a:srgbClr val="6C6B66"/>
+                  <a:srgbClr val="ADB2BC"/>
                 </a:solidFill>
               </a:rPr>
               <a:t>Sources: demo.js · MCQChallenge.jsx · ai_generator.py · routes/challenge.py</a:t>
@@ -5047,7 +5047,7 @@
     </p:spTree>
     <p:extLst>
       <p:ext uri="{BB962C8B-B14F-4D97-AF65-F5344CB8AC3E}">
-        <p14:creationId xmlns:p14="http://schemas.microsoft.com/office/powerpoint/2010/main" val="25118143"/>
+        <p14:creationId xmlns:p14="http://schemas.microsoft.com/office/powerpoint/2010/main" val="1931002229"/>
       </p:ext>
     </p:extLst>
   </p:cSld>

</xml_diff>

<commit_message>
Give the decision figure a distinct IDE-inspired palette (#4)
## What changed

- replaced the light shared treatment with a graphite developer-tool
identity
- uses orange for action, electric lime for accepted state, violet for
live mechanics, amber for rollback, and red for unsupported claims
- documented the semantic color roles and retained redundant labels and
structure
- regenerated editable and publication exports plus preflight artifacts

## Why

CodePrep's figure should feel native to a technical interview and coding
environment. The dark IDE-inspired treatment makes it unmistakably
different from the document and provenance figures.

## Validation

- frontend lint, 2 tests, and production build passed
- backend ruff passed; 15 tests passed
- PowerPoint overflow test: passed
- final-size and grayscale inspection: passed
- PDF preflight: zero raster images
</commit_message>
<xml_diff>
--- a/docs/figures/codeprep-decision-flow/editable/codeprep-decision-flow.pptx
+++ b/docs/figures/codeprep-decision-flow/editable/codeprep-decision-flow.pptx
@@ -2,13 +2,13 @@
 <file path=ppt/presentation.xml><?xml version="1.0" encoding="utf-8"?>
 <p:presentation xmlns:p="http://schemas.openxmlformats.org/presentationml/2006/main">
   <p:sldMasterIdLst>
-    <p:sldMasterId xmlns:r="http://schemas.openxmlformats.org/officeDocument/2006/relationships" id="2147483648" r:id="R846335b8b3b54404"/>
+    <p:sldMasterId xmlns:r="http://schemas.openxmlformats.org/officeDocument/2006/relationships" id="2147483648" r:id="R3b37e8978f1d46cb"/>
   </p:sldMasterIdLst>
   <p:notesMasterIdLst>
-    <p:notesMasterId xmlns:r="http://schemas.openxmlformats.org/officeDocument/2006/relationships" r:id="Rc53804bc91f54326"/>
+    <p:notesMasterId xmlns:r="http://schemas.openxmlformats.org/officeDocument/2006/relationships" r:id="R6e9fb6b7921e4036"/>
   </p:notesMasterIdLst>
   <p:sldIdLst>
-    <p:sldId xmlns:r="http://schemas.openxmlformats.org/officeDocument/2006/relationships" id="256" r:id="Rf204236f2e424285"/>
+    <p:sldId xmlns:r="http://schemas.openxmlformats.org/officeDocument/2006/relationships" id="256" r:id="Rfb244082ef22465d"/>
   </p:sldIdLst>
   <p:sldSz cx="12192000" cy="6858000"/>
   <p:notesSz cx="6858000" cy="9144000"/>
@@ -601,7 +601,7 @@
   </p:cSld>
   <p:clrMap bg1="lt1" tx1="dk1" bg2="lt2" tx2="dk2" accent1="accent1" accent2="accent2" accent3="accent3" accent4="accent4" accent5="accent5" accent6="accent6" hlink="hlink" folHlink="folHlink"/>
   <p:sldLayoutIdLst>
-    <p:sldLayoutId xmlns:r="http://schemas.openxmlformats.org/officeDocument/2006/relationships" id="2147483649" r:id="Rbbacf7515d5b4e42"/>
+    <p:sldLayoutId xmlns:r="http://schemas.openxmlformats.org/officeDocument/2006/relationships" id="2147483649" r:id="Re991020a90694708"/>
   </p:sldLayoutIdLst>
   <p:txStyles>
     <p:titleStyle>
@@ -1134,7 +1134,7 @@
     <p:bg>
       <p:bgPr>
         <a:solidFill xmlns:a="http://schemas.openxmlformats.org/drawingml/2006/main">
-          <a:srgbClr val="F5F2EC"/>
+          <a:srgbClr val="17181C"/>
         </a:solidFill>
       </p:bgPr>
     </p:bg>
@@ -1152,7 +1152,7 @@
           <p:cNvPr id="88" name="title">
             <a:extLst xmlns:a="http://schemas.openxmlformats.org/drawingml/2006/main">
               <a:ext uri="{FF2B5EF4-FFF2-40B4-BE49-F238E27FC236}">
-                <a16:creationId xmlns:a16="http://schemas.microsoft.com/office/drawing/2014/main" id="{3B782AA4-2E25-48D1-9739-E2933F56D5A2}"/>
+                <a16:creationId xmlns:a16="http://schemas.microsoft.com/office/drawing/2014/main" id="{4D028F3C-FC7C-4026-B6F1-19851CF09117}"/>
               </a:ext>
             </a:extLst>
           </p:cNvPr>
@@ -1182,14 +1182,14 @@
             <a:pPr algn="l">
               <a:defRPr sz="2550" b="1">
                 <a:solidFill>
-                  <a:srgbClr val="20201E"/>
+                  <a:srgbClr val="F5F3ED"/>
                 </a:solidFill>
               </a:defRPr>
             </a:pPr>
             <a:r>
               <a:rPr sz="2550" b="1">
                 <a:solidFill>
-                  <a:srgbClr val="20201E"/>
+                  <a:srgbClr val="F5F3ED"/>
                 </a:solidFill>
               </a:rPr>
               <a:t>CodePrep turns one answer selection into a visible reasoning state</a:t>
@@ -1202,7 +1202,7 @@
           <p:cNvPr id="2" name="subtitle">
             <a:extLst xmlns:a="http://schemas.openxmlformats.org/drawingml/2006/main">
               <a:ext uri="{FF2B5EF4-FFF2-40B4-BE49-F238E27FC236}">
-                <a16:creationId xmlns:a16="http://schemas.microsoft.com/office/drawing/2014/main" id="{1D229805-0482-4122-961F-DC2C000C8E64}"/>
+                <a16:creationId xmlns:a16="http://schemas.microsoft.com/office/drawing/2014/main" id="{DFD71384-A08C-49B6-8964-E814583960D3}"/>
               </a:ext>
             </a:extLst>
           </p:cNvPr>
@@ -1232,14 +1232,14 @@
             <a:pPr algn="l">
               <a:defRPr sz="1200" b="0">
                 <a:solidFill>
-                  <a:srgbClr val="6C6B66"/>
+                  <a:srgbClr val="ADB2BC"/>
                 </a:solidFill>
               </a:defRPr>
             </a:pPr>
             <a:r>
               <a:rPr sz="1200" b="0">
                 <a:solidFill>
-                  <a:srgbClr val="6C6B66"/>
+                  <a:srgbClr val="ADB2BC"/>
                 </a:solidFill>
               </a:rPr>
               <a:t>The rationale is absent before commitment and appears immediately after selection; live challenge creation adds a separate validated transaction.</a:t>
@@ -1252,7 +1252,7 @@
           <p:cNvPr id="3" name="header-rule">
             <a:extLst xmlns:a="http://schemas.openxmlformats.org/drawingml/2006/main">
               <a:ext uri="{FF2B5EF4-FFF2-40B4-BE49-F238E27FC236}">
-                <a16:creationId xmlns:a16="http://schemas.microsoft.com/office/drawing/2014/main" id="{1196414C-0DA5-448E-97E9-136434B04E40}"/>
+                <a16:creationId xmlns:a16="http://schemas.microsoft.com/office/drawing/2014/main" id="{64ADD15F-F2C4-4572-B3A5-AD85766F5475}"/>
               </a:ext>
             </a:extLst>
           </p:cNvPr>
@@ -1272,7 +1272,7 @@
           <a:noFill xmlns:a="http://schemas.openxmlformats.org/drawingml/2006/main"/>
           <a:ln xmlns:a="http://schemas.openxmlformats.org/drawingml/2006/main" w="14288">
             <a:solidFill>
-              <a:srgbClr val="20201E"/>
+              <a:srgbClr val="F5F3ED"/>
             </a:solidFill>
             <a:prstDash val="solid"/>
           </a:ln>
@@ -1283,7 +1283,7 @@
           <p:cNvPr id="4" name="story-label">
             <a:extLst xmlns:a="http://schemas.openxmlformats.org/drawingml/2006/main">
               <a:ext uri="{FF2B5EF4-FFF2-40B4-BE49-F238E27FC236}">
-                <a16:creationId xmlns:a16="http://schemas.microsoft.com/office/drawing/2014/main" id="{D3FF0B75-C732-4C0C-AE48-7B0C5708AB69}"/>
+                <a16:creationId xmlns:a16="http://schemas.microsoft.com/office/drawing/2014/main" id="{AC63349F-FD2A-4F9A-BBA8-4C9CFDB3F348}"/>
               </a:ext>
             </a:extLst>
           </p:cNvPr>
@@ -1313,14 +1313,14 @@
             <a:pPr algn="l">
               <a:defRPr sz="900" b="1">
                 <a:solidFill>
-                  <a:srgbClr val="C9431C"/>
+                  <a:srgbClr val="FF8A45"/>
                 </a:solidFill>
               </a:defRPr>
             </a:pPr>
             <a:r>
               <a:rPr sz="900" b="1">
                 <a:solidFill>
-                  <a:srgbClr val="C9431C"/>
+                  <a:srgbClr val="FF8A45"/>
                 </a:solidFill>
               </a:rPr>
               <a:t>BEFORE  →  ACTION  →  AFTER</a:t>
@@ -1333,7 +1333,7 @@
           <p:cNvPr id="5" name="commit-arrow">
             <a:extLst xmlns:a="http://schemas.openxmlformats.org/drawingml/2006/main">
               <a:ext uri="{FF2B5EF4-FFF2-40B4-BE49-F238E27FC236}">
-                <a16:creationId xmlns:a16="http://schemas.microsoft.com/office/drawing/2014/main" id="{6E2BBEBA-DC46-4FF1-A79D-33650C4DFCC7}"/>
+                <a16:creationId xmlns:a16="http://schemas.microsoft.com/office/drawing/2014/main" id="{7A06E45C-A64F-4A92-AD25-D035FFE9FF0C}"/>
               </a:ext>
             </a:extLst>
           </p:cNvPr>
@@ -1351,11 +1351,11 @@
             <a:avLst/>
           </a:prstGeom>
           <a:solidFill xmlns:a="http://schemas.openxmlformats.org/drawingml/2006/main">
-            <a:srgbClr val="C9431C"/>
+            <a:srgbClr val="FF8A45"/>
           </a:solidFill>
           <a:ln xmlns:a="http://schemas.openxmlformats.org/drawingml/2006/main" w="0">
             <a:solidFill>
-              <a:srgbClr val="C9431C"/>
+              <a:srgbClr val="FF8A45"/>
             </a:solidFill>
             <a:prstDash val="solid"/>
           </a:ln>
@@ -1366,7 +1366,7 @@
           <p:cNvPr id="6" name="commit-label">
             <a:extLst xmlns:a="http://schemas.openxmlformats.org/drawingml/2006/main">
               <a:ext uri="{FF2B5EF4-FFF2-40B4-BE49-F238E27FC236}">
-                <a16:creationId xmlns:a16="http://schemas.microsoft.com/office/drawing/2014/main" id="{4CFCDAAC-8194-42E1-BB94-43B2221D1651}"/>
+                <a16:creationId xmlns:a16="http://schemas.microsoft.com/office/drawing/2014/main" id="{D9E2C123-371D-4605-93B4-FE26F5CFD04C}"/>
               </a:ext>
             </a:extLst>
           </p:cNvPr>
@@ -1396,14 +1396,14 @@
             <a:pPr algn="ctr">
               <a:defRPr sz="900" b="1">
                 <a:solidFill>
-                  <a:srgbClr val="C9431C"/>
+                  <a:srgbClr val="FF8A45"/>
                 </a:solidFill>
               </a:defRPr>
             </a:pPr>
             <a:r>
               <a:rPr sz="900" b="1">
                 <a:solidFill>
-                  <a:srgbClr val="C9431C"/>
+                  <a:srgbClr val="FF8A45"/>
                 </a:solidFill>
               </a:rPr>
               <a:t>select B</a:t>
@@ -1416,7 +1416,7 @@
           <p:cNvPr id="7" name="commit-value">
             <a:extLst xmlns:a="http://schemas.openxmlformats.org/drawingml/2006/main">
               <a:ext uri="{FF2B5EF4-FFF2-40B4-BE49-F238E27FC236}">
-                <a16:creationId xmlns:a16="http://schemas.microsoft.com/office/drawing/2014/main" id="{0F8C9B68-D3D5-4A1B-B396-475B8136950F}"/>
+                <a16:creationId xmlns:a16="http://schemas.microsoft.com/office/drawing/2014/main" id="{C24390AB-AC11-4956-B0A9-2D644A182805}"/>
               </a:ext>
             </a:extLst>
           </p:cNvPr>
@@ -1446,14 +1446,14 @@
             <a:pPr algn="ctr">
               <a:defRPr sz="825" b="1">
                 <a:solidFill>
-                  <a:srgbClr val="C9431C"/>
+                  <a:srgbClr val="FF8A45"/>
                 </a:solidFill>
               </a:defRPr>
             </a:pPr>
             <a:r>
               <a:rPr sz="825" b="1">
                 <a:solidFill>
-                  <a:srgbClr val="C9431C"/>
+                  <a:srgbClr val="FF8A45"/>
                 </a:solidFill>
               </a:rPr>
               <a:t>O(log n)</a:t>
@@ -1466,7 +1466,7 @@
           <p:cNvPr id="8" name="before-frame">
             <a:extLst xmlns:a="http://schemas.openxmlformats.org/drawingml/2006/main">
               <a:ext uri="{FF2B5EF4-FFF2-40B4-BE49-F238E27FC236}">
-                <a16:creationId xmlns:a16="http://schemas.microsoft.com/office/drawing/2014/main" id="{E1BE9995-A864-4E50-9C71-52785333430F}"/>
+                <a16:creationId xmlns:a16="http://schemas.microsoft.com/office/drawing/2014/main" id="{7501B7F5-C2B6-48C3-BEDE-76394C37AB4B}"/>
               </a:ext>
             </a:extLst>
           </p:cNvPr>
@@ -1486,11 +1486,11 @@
             </a:avLst>
           </a:prstGeom>
           <a:solidFill xmlns:a="http://schemas.openxmlformats.org/drawingml/2006/main">
-            <a:srgbClr val="FFFFFF"/>
+            <a:srgbClr val="23252B"/>
           </a:solidFill>
           <a:ln xmlns:a="http://schemas.openxmlformats.org/drawingml/2006/main" w="11430">
             <a:solidFill>
-              <a:srgbClr val="817F79"/>
+              <a:srgbClr val="9096A1"/>
             </a:solidFill>
             <a:prstDash val="solid"/>
           </a:ln>
@@ -1501,7 +1501,7 @@
           <p:cNvPr id="9" name="before-topbar">
             <a:extLst xmlns:a="http://schemas.openxmlformats.org/drawingml/2006/main">
               <a:ext uri="{FF2B5EF4-FFF2-40B4-BE49-F238E27FC236}">
-                <a16:creationId xmlns:a16="http://schemas.microsoft.com/office/drawing/2014/main" id="{DAC5076A-B89C-4E2F-8E55-0BDE1ED32C60}"/>
+                <a16:creationId xmlns:a16="http://schemas.microsoft.com/office/drawing/2014/main" id="{B4ADB44E-FF68-4C5C-B5EE-63BDB9454B90}"/>
               </a:ext>
             </a:extLst>
           </p:cNvPr>
@@ -1519,11 +1519,11 @@
             <a:avLst/>
           </a:prstGeom>
           <a:solidFill xmlns:a="http://schemas.openxmlformats.org/drawingml/2006/main">
-            <a:srgbClr val="ECEAE5"/>
+            <a:srgbClr val="2D2F35"/>
           </a:solidFill>
           <a:ln xmlns:a="http://schemas.openxmlformats.org/drawingml/2006/main" w="9525">
             <a:solidFill>
-              <a:srgbClr val="817F79"/>
+              <a:srgbClr val="9096A1"/>
             </a:solidFill>
             <a:prstDash val="solid"/>
           </a:ln>
@@ -1534,7 +1534,7 @@
           <p:cNvPr id="10" name="before-state">
             <a:extLst xmlns:a="http://schemas.openxmlformats.org/drawingml/2006/main">
               <a:ext uri="{FF2B5EF4-FFF2-40B4-BE49-F238E27FC236}">
-                <a16:creationId xmlns:a16="http://schemas.microsoft.com/office/drawing/2014/main" id="{E118AF94-DAD7-4C89-81DD-AFD60232F40F}"/>
+                <a16:creationId xmlns:a16="http://schemas.microsoft.com/office/drawing/2014/main" id="{3F60940A-2633-4FF4-8945-BA724DB8A336}"/>
               </a:ext>
             </a:extLst>
           </p:cNvPr>
@@ -1564,14 +1564,14 @@
             <a:pPr algn="l">
               <a:defRPr sz="750" b="1">
                 <a:solidFill>
-                  <a:srgbClr val="817F79"/>
+                  <a:srgbClr val="9096A1"/>
                 </a:solidFill>
               </a:defRPr>
             </a:pPr>
             <a:r>
               <a:rPr sz="750" b="1">
                 <a:solidFill>
-                  <a:srgbClr val="817F79"/>
+                  <a:srgbClr val="9096A1"/>
                 </a:solidFill>
               </a:rPr>
               <a:t>STATE 0 · UNANSWERED</a:t>
@@ -1584,7 +1584,7 @@
           <p:cNvPr id="11" name="before-difficulty">
             <a:extLst xmlns:a="http://schemas.openxmlformats.org/drawingml/2006/main">
               <a:ext uri="{FF2B5EF4-FFF2-40B4-BE49-F238E27FC236}">
-                <a16:creationId xmlns:a16="http://schemas.microsoft.com/office/drawing/2014/main" id="{3DE4E518-550A-4E06-BDC3-EF03B34825DC}"/>
+                <a16:creationId xmlns:a16="http://schemas.microsoft.com/office/drawing/2014/main" id="{60C5F297-0E02-454D-BC0D-8F418CEA607D}"/>
               </a:ext>
             </a:extLst>
           </p:cNvPr>
@@ -1614,14 +1614,14 @@
             <a:pPr algn="r">
               <a:defRPr sz="750" b="1">
                 <a:solidFill>
-                  <a:srgbClr val="C9431C"/>
+                  <a:srgbClr val="FF8A45"/>
                 </a:solidFill>
               </a:defRPr>
             </a:pPr>
             <a:r>
               <a:rPr sz="750" b="1">
                 <a:solidFill>
-                  <a:srgbClr val="C9431C"/>
+                  <a:srgbClr val="FF8A45"/>
                 </a:solidFill>
               </a:rPr>
               <a:t>MEDIUM</a:t>
@@ -1634,7 +1634,7 @@
           <p:cNvPr id="12" name="before-question">
             <a:extLst xmlns:a="http://schemas.openxmlformats.org/drawingml/2006/main">
               <a:ext uri="{FF2B5EF4-FFF2-40B4-BE49-F238E27FC236}">
-                <a16:creationId xmlns:a16="http://schemas.microsoft.com/office/drawing/2014/main" id="{56B96682-321E-4ABE-9945-BBCD9CE0F9D0}"/>
+                <a16:creationId xmlns:a16="http://schemas.microsoft.com/office/drawing/2014/main" id="{7D6617DC-1213-4D4C-850A-200849C176CB}"/>
               </a:ext>
             </a:extLst>
           </p:cNvPr>
@@ -1664,14 +1664,14 @@
             <a:pPr algn="l">
               <a:defRPr sz="1125" b="1">
                 <a:solidFill>
-                  <a:srgbClr val="20201E"/>
+                  <a:srgbClr val="F5F3ED"/>
                 </a:solidFill>
               </a:defRPr>
             </a:pPr>
             <a:r>
               <a:rPr sz="1125" b="1">
                 <a:solidFill>
-                  <a:srgbClr val="20201E"/>
+                  <a:srgbClr val="F5F3ED"/>
                 </a:solidFill>
               </a:rPr>
               <a:t>What is the time complexity of finding a value in a balanced binary search tree?</a:t>
@@ -1684,7 +1684,7 @@
           <p:cNvPr id="13" name="before-instruction">
             <a:extLst xmlns:a="http://schemas.openxmlformats.org/drawingml/2006/main">
               <a:ext uri="{FF2B5EF4-FFF2-40B4-BE49-F238E27FC236}">
-                <a16:creationId xmlns:a16="http://schemas.microsoft.com/office/drawing/2014/main" id="{91170DF6-5DE2-4512-9CCE-886FAA9DD22B}"/>
+                <a16:creationId xmlns:a16="http://schemas.microsoft.com/office/drawing/2014/main" id="{F742E647-D2C9-44FB-8C12-0C90D113640F}"/>
               </a:ext>
             </a:extLst>
           </p:cNvPr>
@@ -1714,14 +1714,14 @@
             <a:pPr algn="l">
               <a:defRPr sz="788" b="0">
                 <a:solidFill>
-                  <a:srgbClr val="6C6B66"/>
+                  <a:srgbClr val="ADB2BC"/>
                 </a:solidFill>
               </a:defRPr>
             </a:pPr>
             <a:r>
               <a:rPr sz="788" b="0">
                 <a:solidFill>
-                  <a:srgbClr val="6C6B66"/>
+                  <a:srgbClr val="ADB2BC"/>
                 </a:solidFill>
               </a:rPr>
               <a:t>Choose one answer.</a:t>
@@ -1734,7 +1734,7 @@
           <p:cNvPr id="14" name="before-option-0">
             <a:extLst xmlns:a="http://schemas.openxmlformats.org/drawingml/2006/main">
               <a:ext uri="{FF2B5EF4-FFF2-40B4-BE49-F238E27FC236}">
-                <a16:creationId xmlns:a16="http://schemas.microsoft.com/office/drawing/2014/main" id="{A74A8837-583B-413F-8E8E-5D50F3835650}"/>
+                <a16:creationId xmlns:a16="http://schemas.microsoft.com/office/drawing/2014/main" id="{7458CD0B-B973-436D-80AA-8692CAA7663D}"/>
               </a:ext>
             </a:extLst>
           </p:cNvPr>
@@ -1752,11 +1752,11 @@
             <a:avLst/>
           </a:prstGeom>
           <a:solidFill xmlns:a="http://schemas.openxmlformats.org/drawingml/2006/main">
-            <a:srgbClr val="FFFFFF"/>
+            <a:srgbClr val="23252B"/>
           </a:solidFill>
           <a:ln xmlns:a="http://schemas.openxmlformats.org/drawingml/2006/main" w="9525">
             <a:solidFill>
-              <a:srgbClr val="C9C6BF"/>
+              <a:srgbClr val="565B66"/>
             </a:solidFill>
             <a:prstDash val="solid"/>
           </a:ln>
@@ -1767,7 +1767,7 @@
           <p:cNvPr id="15" name="before-option-label-0">
             <a:extLst xmlns:a="http://schemas.openxmlformats.org/drawingml/2006/main">
               <a:ext uri="{FF2B5EF4-FFF2-40B4-BE49-F238E27FC236}">
-                <a16:creationId xmlns:a16="http://schemas.microsoft.com/office/drawing/2014/main" id="{1940C9B1-38B7-42DC-893A-5384BD4DC32F}"/>
+                <a16:creationId xmlns:a16="http://schemas.microsoft.com/office/drawing/2014/main" id="{F784B5DC-5D86-42BF-9DA5-83A92CB3237F}"/>
               </a:ext>
             </a:extLst>
           </p:cNvPr>
@@ -1797,14 +1797,14 @@
             <a:pPr algn="l">
               <a:defRPr sz="750" b="1">
                 <a:solidFill>
-                  <a:srgbClr val="817F79"/>
+                  <a:srgbClr val="9096A1"/>
                 </a:solidFill>
               </a:defRPr>
             </a:pPr>
             <a:r>
               <a:rPr sz="750" b="1">
                 <a:solidFill>
-                  <a:srgbClr val="817F79"/>
+                  <a:srgbClr val="9096A1"/>
                 </a:solidFill>
               </a:rPr>
               <a:t>A</a:t>
@@ -1817,7 +1817,7 @@
           <p:cNvPr id="16" name="before-option-copy-0">
             <a:extLst xmlns:a="http://schemas.openxmlformats.org/drawingml/2006/main">
               <a:ext uri="{FF2B5EF4-FFF2-40B4-BE49-F238E27FC236}">
-                <a16:creationId xmlns:a16="http://schemas.microsoft.com/office/drawing/2014/main" id="{61C274E0-B4B7-4121-B845-D91527A18E3B}"/>
+                <a16:creationId xmlns:a16="http://schemas.microsoft.com/office/drawing/2014/main" id="{E42BBAC6-9ECE-49DD-9BBE-5D2DC5F9F4CA}"/>
               </a:ext>
             </a:extLst>
           </p:cNvPr>
@@ -1847,14 +1847,14 @@
             <a:pPr algn="l">
               <a:defRPr sz="825" b="0">
                 <a:solidFill>
-                  <a:srgbClr val="20201E"/>
+                  <a:srgbClr val="F5F3ED"/>
                 </a:solidFill>
               </a:defRPr>
             </a:pPr>
             <a:r>
               <a:rPr sz="825" b="0">
                 <a:solidFill>
-                  <a:srgbClr val="20201E"/>
+                  <a:srgbClr val="F5F3ED"/>
                 </a:solidFill>
               </a:rPr>
               <a:t>O(1)</a:t>
@@ -1867,7 +1867,7 @@
           <p:cNvPr id="17" name="before-option-1">
             <a:extLst xmlns:a="http://schemas.openxmlformats.org/drawingml/2006/main">
               <a:ext uri="{FF2B5EF4-FFF2-40B4-BE49-F238E27FC236}">
-                <a16:creationId xmlns:a16="http://schemas.microsoft.com/office/drawing/2014/main" id="{30EC338E-4B14-4277-972E-C989567307C4}"/>
+                <a16:creationId xmlns:a16="http://schemas.microsoft.com/office/drawing/2014/main" id="{AAD0B17A-4F9B-490E-9975-3AA28A6C8B0E}"/>
               </a:ext>
             </a:extLst>
           </p:cNvPr>
@@ -1885,11 +1885,11 @@
             <a:avLst/>
           </a:prstGeom>
           <a:solidFill xmlns:a="http://schemas.openxmlformats.org/drawingml/2006/main">
-            <a:srgbClr val="FFFFFF"/>
+            <a:srgbClr val="23252B"/>
           </a:solidFill>
           <a:ln xmlns:a="http://schemas.openxmlformats.org/drawingml/2006/main" w="9525">
             <a:solidFill>
-              <a:srgbClr val="C9C6BF"/>
+              <a:srgbClr val="565B66"/>
             </a:solidFill>
             <a:prstDash val="solid"/>
           </a:ln>
@@ -1900,7 +1900,7 @@
           <p:cNvPr id="18" name="before-option-label-1">
             <a:extLst xmlns:a="http://schemas.openxmlformats.org/drawingml/2006/main">
               <a:ext uri="{FF2B5EF4-FFF2-40B4-BE49-F238E27FC236}">
-                <a16:creationId xmlns:a16="http://schemas.microsoft.com/office/drawing/2014/main" id="{F997E857-200E-49D3-9669-E3A50949685E}"/>
+                <a16:creationId xmlns:a16="http://schemas.microsoft.com/office/drawing/2014/main" id="{3920BDD1-D3FB-4B4E-95E1-D08675BA3B51}"/>
               </a:ext>
             </a:extLst>
           </p:cNvPr>
@@ -1930,14 +1930,14 @@
             <a:pPr algn="l">
               <a:defRPr sz="750" b="1">
                 <a:solidFill>
-                  <a:srgbClr val="817F79"/>
+                  <a:srgbClr val="9096A1"/>
                 </a:solidFill>
               </a:defRPr>
             </a:pPr>
             <a:r>
               <a:rPr sz="750" b="1">
                 <a:solidFill>
-                  <a:srgbClr val="817F79"/>
+                  <a:srgbClr val="9096A1"/>
                 </a:solidFill>
               </a:rPr>
               <a:t>B</a:t>
@@ -1950,7 +1950,7 @@
           <p:cNvPr id="19" name="before-option-copy-1">
             <a:extLst xmlns:a="http://schemas.openxmlformats.org/drawingml/2006/main">
               <a:ext uri="{FF2B5EF4-FFF2-40B4-BE49-F238E27FC236}">
-                <a16:creationId xmlns:a16="http://schemas.microsoft.com/office/drawing/2014/main" id="{E0DFE5C5-C4A1-4164-B28F-7C1F1E932972}"/>
+                <a16:creationId xmlns:a16="http://schemas.microsoft.com/office/drawing/2014/main" id="{6ED4B1D0-A431-4DAB-B2DD-9307BEF0E39A}"/>
               </a:ext>
             </a:extLst>
           </p:cNvPr>
@@ -1980,14 +1980,14 @@
             <a:pPr algn="l">
               <a:defRPr sz="825" b="0">
                 <a:solidFill>
-                  <a:srgbClr val="20201E"/>
+                  <a:srgbClr val="F5F3ED"/>
                 </a:solidFill>
               </a:defRPr>
             </a:pPr>
             <a:r>
               <a:rPr sz="825" b="0">
                 <a:solidFill>
-                  <a:srgbClr val="20201E"/>
+                  <a:srgbClr val="F5F3ED"/>
                 </a:solidFill>
               </a:rPr>
               <a:t>O(log n)</a:t>
@@ -2000,7 +2000,7 @@
           <p:cNvPr id="20" name="before-option-2">
             <a:extLst xmlns:a="http://schemas.openxmlformats.org/drawingml/2006/main">
               <a:ext uri="{FF2B5EF4-FFF2-40B4-BE49-F238E27FC236}">
-                <a16:creationId xmlns:a16="http://schemas.microsoft.com/office/drawing/2014/main" id="{735C01F6-855F-422C-BB6E-62BC01432408}"/>
+                <a16:creationId xmlns:a16="http://schemas.microsoft.com/office/drawing/2014/main" id="{D7F0440F-7A7D-4BA0-A0BB-258C52383DDF}"/>
               </a:ext>
             </a:extLst>
           </p:cNvPr>
@@ -2018,11 +2018,11 @@
             <a:avLst/>
           </a:prstGeom>
           <a:solidFill xmlns:a="http://schemas.openxmlformats.org/drawingml/2006/main">
-            <a:srgbClr val="FFFFFF"/>
+            <a:srgbClr val="23252B"/>
           </a:solidFill>
           <a:ln xmlns:a="http://schemas.openxmlformats.org/drawingml/2006/main" w="9525">
             <a:solidFill>
-              <a:srgbClr val="C9C6BF"/>
+              <a:srgbClr val="565B66"/>
             </a:solidFill>
             <a:prstDash val="solid"/>
           </a:ln>
@@ -2033,7 +2033,7 @@
           <p:cNvPr id="21" name="before-option-label-2">
             <a:extLst xmlns:a="http://schemas.openxmlformats.org/drawingml/2006/main">
               <a:ext uri="{FF2B5EF4-FFF2-40B4-BE49-F238E27FC236}">
-                <a16:creationId xmlns:a16="http://schemas.microsoft.com/office/drawing/2014/main" id="{A000ED6B-886A-4CE2-8875-8A23C3704EDA}"/>
+                <a16:creationId xmlns:a16="http://schemas.microsoft.com/office/drawing/2014/main" id="{7A4424BB-F7B4-4686-801F-3929115AD6D1}"/>
               </a:ext>
             </a:extLst>
           </p:cNvPr>
@@ -2063,14 +2063,14 @@
             <a:pPr algn="l">
               <a:defRPr sz="750" b="1">
                 <a:solidFill>
-                  <a:srgbClr val="817F79"/>
+                  <a:srgbClr val="9096A1"/>
                 </a:solidFill>
               </a:defRPr>
             </a:pPr>
             <a:r>
               <a:rPr sz="750" b="1">
                 <a:solidFill>
-                  <a:srgbClr val="817F79"/>
+                  <a:srgbClr val="9096A1"/>
                 </a:solidFill>
               </a:rPr>
               <a:t>C</a:t>
@@ -2083,7 +2083,7 @@
           <p:cNvPr id="22" name="before-option-copy-2">
             <a:extLst xmlns:a="http://schemas.openxmlformats.org/drawingml/2006/main">
               <a:ext uri="{FF2B5EF4-FFF2-40B4-BE49-F238E27FC236}">
-                <a16:creationId xmlns:a16="http://schemas.microsoft.com/office/drawing/2014/main" id="{247179CB-417E-4542-840D-188E11372DD6}"/>
+                <a16:creationId xmlns:a16="http://schemas.microsoft.com/office/drawing/2014/main" id="{3CB41C83-89AD-4BD2-AF98-7ECC924E39E5}"/>
               </a:ext>
             </a:extLst>
           </p:cNvPr>
@@ -2113,14 +2113,14 @@
             <a:pPr algn="l">
               <a:defRPr sz="825" b="0">
                 <a:solidFill>
-                  <a:srgbClr val="20201E"/>
+                  <a:srgbClr val="F5F3ED"/>
                 </a:solidFill>
               </a:defRPr>
             </a:pPr>
             <a:r>
               <a:rPr sz="825" b="0">
                 <a:solidFill>
-                  <a:srgbClr val="20201E"/>
+                  <a:srgbClr val="F5F3ED"/>
                 </a:solidFill>
               </a:rPr>
               <a:t>O(n)</a:t>
@@ -2133,7 +2133,7 @@
           <p:cNvPr id="23" name="before-option-3">
             <a:extLst xmlns:a="http://schemas.openxmlformats.org/drawingml/2006/main">
               <a:ext uri="{FF2B5EF4-FFF2-40B4-BE49-F238E27FC236}">
-                <a16:creationId xmlns:a16="http://schemas.microsoft.com/office/drawing/2014/main" id="{099414CD-DA75-478B-952A-EBAB12C47C84}"/>
+                <a16:creationId xmlns:a16="http://schemas.microsoft.com/office/drawing/2014/main" id="{B589EB79-97BF-4F0F-814D-B23E80541CC2}"/>
               </a:ext>
             </a:extLst>
           </p:cNvPr>
@@ -2151,11 +2151,11 @@
             <a:avLst/>
           </a:prstGeom>
           <a:solidFill xmlns:a="http://schemas.openxmlformats.org/drawingml/2006/main">
-            <a:srgbClr val="FFFFFF"/>
+            <a:srgbClr val="23252B"/>
           </a:solidFill>
           <a:ln xmlns:a="http://schemas.openxmlformats.org/drawingml/2006/main" w="9525">
             <a:solidFill>
-              <a:srgbClr val="C9C6BF"/>
+              <a:srgbClr val="565B66"/>
             </a:solidFill>
             <a:prstDash val="solid"/>
           </a:ln>
@@ -2166,7 +2166,7 @@
           <p:cNvPr id="24" name="before-option-label-3">
             <a:extLst xmlns:a="http://schemas.openxmlformats.org/drawingml/2006/main">
               <a:ext uri="{FF2B5EF4-FFF2-40B4-BE49-F238E27FC236}">
-                <a16:creationId xmlns:a16="http://schemas.microsoft.com/office/drawing/2014/main" id="{D780BFFA-A0B2-48A9-89B5-BCC1EA9C6ED5}"/>
+                <a16:creationId xmlns:a16="http://schemas.microsoft.com/office/drawing/2014/main" id="{3A16B746-B86C-4CDF-8E47-535C096A51B9}"/>
               </a:ext>
             </a:extLst>
           </p:cNvPr>
@@ -2196,14 +2196,14 @@
             <a:pPr algn="l">
               <a:defRPr sz="750" b="1">
                 <a:solidFill>
-                  <a:srgbClr val="817F79"/>
+                  <a:srgbClr val="9096A1"/>
                 </a:solidFill>
               </a:defRPr>
             </a:pPr>
             <a:r>
               <a:rPr sz="750" b="1">
                 <a:solidFill>
-                  <a:srgbClr val="817F79"/>
+                  <a:srgbClr val="9096A1"/>
                 </a:solidFill>
               </a:rPr>
               <a:t>D</a:t>
@@ -2216,7 +2216,7 @@
           <p:cNvPr id="25" name="before-option-copy-3">
             <a:extLst xmlns:a="http://schemas.openxmlformats.org/drawingml/2006/main">
               <a:ext uri="{FF2B5EF4-FFF2-40B4-BE49-F238E27FC236}">
-                <a16:creationId xmlns:a16="http://schemas.microsoft.com/office/drawing/2014/main" id="{F4C82DDD-A794-4388-8EB8-C6EB244C5DFB}"/>
+                <a16:creationId xmlns:a16="http://schemas.microsoft.com/office/drawing/2014/main" id="{2DF18FF2-5259-4761-95E9-DD48A8D506A9}"/>
               </a:ext>
             </a:extLst>
           </p:cNvPr>
@@ -2246,14 +2246,14 @@
             <a:pPr algn="l">
               <a:defRPr sz="825" b="0">
                 <a:solidFill>
-                  <a:srgbClr val="20201E"/>
+                  <a:srgbClr val="F5F3ED"/>
                 </a:solidFill>
               </a:defRPr>
             </a:pPr>
             <a:r>
               <a:rPr sz="825" b="0">
                 <a:solidFill>
-                  <a:srgbClr val="20201E"/>
+                  <a:srgbClr val="F5F3ED"/>
                 </a:solidFill>
               </a:rPr>
               <a:t>O(n log n)</a:t>
@@ -2266,7 +2266,7 @@
           <p:cNvPr id="26" name="before-divider">
             <a:extLst xmlns:a="http://schemas.openxmlformats.org/drawingml/2006/main">
               <a:ext uri="{FF2B5EF4-FFF2-40B4-BE49-F238E27FC236}">
-                <a16:creationId xmlns:a16="http://schemas.microsoft.com/office/drawing/2014/main" id="{FE2A47F6-7FA3-4393-BE25-E03B804B63BB}"/>
+                <a16:creationId xmlns:a16="http://schemas.microsoft.com/office/drawing/2014/main" id="{A49F41C5-5F65-47A5-BFC7-8ACFA94B6FCD}"/>
               </a:ext>
             </a:extLst>
           </p:cNvPr>
@@ -2286,7 +2286,7 @@
           <a:noFill xmlns:a="http://schemas.openxmlformats.org/drawingml/2006/main"/>
           <a:ln xmlns:a="http://schemas.openxmlformats.org/drawingml/2006/main" w="9525">
             <a:solidFill>
-              <a:srgbClr val="C9C6BF"/>
+              <a:srgbClr val="565B66"/>
             </a:solidFill>
             <a:prstDash val="solid"/>
           </a:ln>
@@ -2297,7 +2297,7 @@
           <p:cNvPr id="27" name="before-explanation-label">
             <a:extLst xmlns:a="http://schemas.openxmlformats.org/drawingml/2006/main">
               <a:ext uri="{FF2B5EF4-FFF2-40B4-BE49-F238E27FC236}">
-                <a16:creationId xmlns:a16="http://schemas.microsoft.com/office/drawing/2014/main" id="{402A33E4-E9AA-416C-A95A-5DCF14628EAD}"/>
+                <a16:creationId xmlns:a16="http://schemas.microsoft.com/office/drawing/2014/main" id="{EA1A1D6E-EE9A-449B-9CD4-FC7153ABE67F}"/>
               </a:ext>
             </a:extLst>
           </p:cNvPr>
@@ -2327,14 +2327,14 @@
             <a:pPr algn="l">
               <a:defRPr sz="750" b="1">
                 <a:solidFill>
-                  <a:srgbClr val="817F79"/>
+                  <a:srgbClr val="9096A1"/>
                 </a:solidFill>
               </a:defRPr>
             </a:pPr>
             <a:r>
               <a:rPr sz="750" b="1">
                 <a:solidFill>
-                  <a:srgbClr val="817F79"/>
+                  <a:srgbClr val="9096A1"/>
                 </a:solidFill>
               </a:rPr>
               <a:t>EXPLANATION</a:t>
@@ -2347,7 +2347,7 @@
           <p:cNvPr id="28" name="before-locked">
             <a:extLst xmlns:a="http://schemas.openxmlformats.org/drawingml/2006/main">
               <a:ext uri="{FF2B5EF4-FFF2-40B4-BE49-F238E27FC236}">
-                <a16:creationId xmlns:a16="http://schemas.microsoft.com/office/drawing/2014/main" id="{D6BC94AE-1271-43FD-AC74-91FF00DB1012}"/>
+                <a16:creationId xmlns:a16="http://schemas.microsoft.com/office/drawing/2014/main" id="{D3C0E27F-2361-4BF3-B292-22DBEAFB5B17}"/>
               </a:ext>
             </a:extLst>
           </p:cNvPr>
@@ -2367,11 +2367,11 @@
             </a:avLst>
           </a:prstGeom>
           <a:solidFill xmlns:a="http://schemas.openxmlformats.org/drawingml/2006/main">
-            <a:srgbClr val="ECEAE5"/>
+            <a:srgbClr val="2D2F35"/>
           </a:solidFill>
           <a:ln xmlns:a="http://schemas.openxmlformats.org/drawingml/2006/main" w="9525">
             <a:solidFill>
-              <a:srgbClr val="C9C6BF"/>
+              <a:srgbClr val="565B66"/>
             </a:solidFill>
             <a:prstDash val="solid"/>
           </a:ln>
@@ -2382,7 +2382,7 @@
           <p:cNvPr id="29" name="before-lock">
             <a:extLst xmlns:a="http://schemas.openxmlformats.org/drawingml/2006/main">
               <a:ext uri="{FF2B5EF4-FFF2-40B4-BE49-F238E27FC236}">
-                <a16:creationId xmlns:a16="http://schemas.microsoft.com/office/drawing/2014/main" id="{B57C1832-33E2-47FD-B7F2-0F14B734A445}"/>
+                <a16:creationId xmlns:a16="http://schemas.microsoft.com/office/drawing/2014/main" id="{6903F3DF-1467-424A-986B-F97FC899B0F3}"/>
               </a:ext>
             </a:extLst>
           </p:cNvPr>
@@ -2412,14 +2412,14 @@
             <a:pPr algn="ctr">
               <a:defRPr sz="975" b="1">
                 <a:solidFill>
-                  <a:srgbClr val="817F79"/>
+                  <a:srgbClr val="9096A1"/>
                 </a:solidFill>
               </a:defRPr>
             </a:pPr>
             <a:r>
               <a:rPr sz="975" b="1">
                 <a:solidFill>
-                  <a:srgbClr val="817F79"/>
+                  <a:srgbClr val="9096A1"/>
                 </a:solidFill>
               </a:rPr>
               <a:t>RATIONALE</a:t>
@@ -2429,14 +2429,14 @@
             <a:pPr algn="ctr">
               <a:defRPr sz="975" b="1">
                 <a:solidFill>
-                  <a:srgbClr val="817F79"/>
+                  <a:srgbClr val="9096A1"/>
                 </a:solidFill>
               </a:defRPr>
             </a:pPr>
             <a:r>
               <a:rPr sz="975" b="1">
                 <a:solidFill>
-                  <a:srgbClr val="817F79"/>
+                  <a:srgbClr val="9096A1"/>
                 </a:solidFill>
               </a:rPr>
               <a:t>LOCKED</a:t>
@@ -2449,7 +2449,7 @@
           <p:cNvPr id="30" name="before-lock-copy">
             <a:extLst xmlns:a="http://schemas.openxmlformats.org/drawingml/2006/main">
               <a:ext uri="{FF2B5EF4-FFF2-40B4-BE49-F238E27FC236}">
-                <a16:creationId xmlns:a16="http://schemas.microsoft.com/office/drawing/2014/main" id="{1278D9CE-0FAA-4FED-9DDF-7EB2DC6FC5C0}"/>
+                <a16:creationId xmlns:a16="http://schemas.microsoft.com/office/drawing/2014/main" id="{40D71B62-7994-4ACB-B1CD-9A00B86E9121}"/>
               </a:ext>
             </a:extLst>
           </p:cNvPr>
@@ -2479,14 +2479,14 @@
             <a:pPr algn="ctr">
               <a:defRPr sz="750" b="0">
                 <a:solidFill>
-                  <a:srgbClr val="6C6B66"/>
+                  <a:srgbClr val="ADB2BC"/>
                 </a:solidFill>
               </a:defRPr>
             </a:pPr>
             <a:r>
               <a:rPr sz="750" b="0">
                 <a:solidFill>
-                  <a:srgbClr val="6C6B66"/>
+                  <a:srgbClr val="ADB2BC"/>
                 </a:solidFill>
               </a:rPr>
               <a:t>Select an option to inspect the technical reasoning.</a:t>
@@ -2499,7 +2499,7 @@
           <p:cNvPr id="31" name="before-note">
             <a:extLst xmlns:a="http://schemas.openxmlformats.org/drawingml/2006/main">
               <a:ext uri="{FF2B5EF4-FFF2-40B4-BE49-F238E27FC236}">
-                <a16:creationId xmlns:a16="http://schemas.microsoft.com/office/drawing/2014/main" id="{37068019-91FA-44F3-BA06-BBA8748DC2A9}"/>
+                <a16:creationId xmlns:a16="http://schemas.microsoft.com/office/drawing/2014/main" id="{36609713-A1F3-4785-B488-70884872C44F}"/>
               </a:ext>
             </a:extLst>
           </p:cNvPr>
@@ -2529,14 +2529,14 @@
             <a:pPr algn="ctr">
               <a:defRPr sz="788" b="0">
                 <a:solidFill>
-                  <a:srgbClr val="6C6B66"/>
+                  <a:srgbClr val="ADB2BC"/>
                 </a:solidFill>
               </a:defRPr>
             </a:pPr>
             <a:r>
               <a:rPr sz="788" b="0">
                 <a:solidFill>
-                  <a:srgbClr val="6C6B66"/>
+                  <a:srgbClr val="ADB2BC"/>
                 </a:solidFill>
               </a:rPr>
               <a:t>No concept or explanation is visible.</a:t>
@@ -2549,7 +2549,7 @@
           <p:cNvPr id="32" name="after-frame">
             <a:extLst xmlns:a="http://schemas.openxmlformats.org/drawingml/2006/main">
               <a:ext uri="{FF2B5EF4-FFF2-40B4-BE49-F238E27FC236}">
-                <a16:creationId xmlns:a16="http://schemas.microsoft.com/office/drawing/2014/main" id="{8566C0FA-DF2F-4AAA-A191-D05D3BDBAFFF}"/>
+                <a16:creationId xmlns:a16="http://schemas.microsoft.com/office/drawing/2014/main" id="{EC49A159-E947-46AD-9D70-9089C78674BF}"/>
               </a:ext>
             </a:extLst>
           </p:cNvPr>
@@ -2569,11 +2569,11 @@
             </a:avLst>
           </a:prstGeom>
           <a:solidFill xmlns:a="http://schemas.openxmlformats.org/drawingml/2006/main">
-            <a:srgbClr val="FFFFFF"/>
+            <a:srgbClr val="23252B"/>
           </a:solidFill>
           <a:ln xmlns:a="http://schemas.openxmlformats.org/drawingml/2006/main" w="13335">
             <a:solidFill>
-              <a:srgbClr val="2C7B45"/>
+              <a:srgbClr val="A3E635"/>
             </a:solidFill>
             <a:prstDash val="solid"/>
           </a:ln>
@@ -2584,7 +2584,7 @@
           <p:cNvPr id="33" name="after-topbar">
             <a:extLst xmlns:a="http://schemas.openxmlformats.org/drawingml/2006/main">
               <a:ext uri="{FF2B5EF4-FFF2-40B4-BE49-F238E27FC236}">
-                <a16:creationId xmlns:a16="http://schemas.microsoft.com/office/drawing/2014/main" id="{6200A2FD-2C83-4E8A-A9F6-1CAE5A4A380F}"/>
+                <a16:creationId xmlns:a16="http://schemas.microsoft.com/office/drawing/2014/main" id="{C4AB6019-EE29-499E-A64B-1D4EF59BBF32}"/>
               </a:ext>
             </a:extLst>
           </p:cNvPr>
@@ -2602,11 +2602,11 @@
             <a:avLst/>
           </a:prstGeom>
           <a:solidFill xmlns:a="http://schemas.openxmlformats.org/drawingml/2006/main">
-            <a:srgbClr val="E7F1E9"/>
+            <a:srgbClr val="263323"/>
           </a:solidFill>
           <a:ln xmlns:a="http://schemas.openxmlformats.org/drawingml/2006/main" w="9525">
             <a:solidFill>
-              <a:srgbClr val="2C7B45"/>
+              <a:srgbClr val="A3E635"/>
             </a:solidFill>
             <a:prstDash val="solid"/>
           </a:ln>
@@ -2617,7 +2617,7 @@
           <p:cNvPr id="34" name="after-state">
             <a:extLst xmlns:a="http://schemas.openxmlformats.org/drawingml/2006/main">
               <a:ext uri="{FF2B5EF4-FFF2-40B4-BE49-F238E27FC236}">
-                <a16:creationId xmlns:a16="http://schemas.microsoft.com/office/drawing/2014/main" id="{92AF5C81-A912-410E-9641-A3CF2414BF25}"/>
+                <a16:creationId xmlns:a16="http://schemas.microsoft.com/office/drawing/2014/main" id="{80719152-4D56-43E0-8A67-12400B415C3F}"/>
               </a:ext>
             </a:extLst>
           </p:cNvPr>
@@ -2647,14 +2647,14 @@
             <a:pPr algn="l">
               <a:defRPr sz="750" b="1">
                 <a:solidFill>
-                  <a:srgbClr val="2C7B45"/>
+                  <a:srgbClr val="A3E635"/>
                 </a:solidFill>
               </a:defRPr>
             </a:pPr>
             <a:r>
               <a:rPr sz="750" b="1">
                 <a:solidFill>
-                  <a:srgbClr val="2C7B45"/>
+                  <a:srgbClr val="A3E635"/>
                 </a:solidFill>
               </a:rPr>
               <a:t>STATE 1 · ANSWER COMMITTED</a:t>
@@ -2667,7 +2667,7 @@
           <p:cNvPr id="35" name="after-result">
             <a:extLst xmlns:a="http://schemas.openxmlformats.org/drawingml/2006/main">
               <a:ext uri="{FF2B5EF4-FFF2-40B4-BE49-F238E27FC236}">
-                <a16:creationId xmlns:a16="http://schemas.microsoft.com/office/drawing/2014/main" id="{5426A35E-8CE0-498A-B05C-3315C4F26204}"/>
+                <a16:creationId xmlns:a16="http://schemas.microsoft.com/office/drawing/2014/main" id="{577F6866-BF3E-402A-982B-F61136E07997}"/>
               </a:ext>
             </a:extLst>
           </p:cNvPr>
@@ -2697,14 +2697,14 @@
             <a:pPr algn="r">
               <a:defRPr sz="750" b="1">
                 <a:solidFill>
-                  <a:srgbClr val="2C7B45"/>
+                  <a:srgbClr val="A3E635"/>
                 </a:solidFill>
               </a:defRPr>
             </a:pPr>
             <a:r>
               <a:rPr sz="750" b="1">
                 <a:solidFill>
-                  <a:srgbClr val="2C7B45"/>
+                  <a:srgbClr val="A3E635"/>
                 </a:solidFill>
               </a:rPr>
               <a:t>DECISION ACCEPTED</a:t>
@@ -2717,7 +2717,7 @@
           <p:cNvPr id="36" name="after-question">
             <a:extLst xmlns:a="http://schemas.openxmlformats.org/drawingml/2006/main">
               <a:ext uri="{FF2B5EF4-FFF2-40B4-BE49-F238E27FC236}">
-                <a16:creationId xmlns:a16="http://schemas.microsoft.com/office/drawing/2014/main" id="{927ED984-CFC3-4737-A9F7-216EC3AD6A3E}"/>
+                <a16:creationId xmlns:a16="http://schemas.microsoft.com/office/drawing/2014/main" id="{04CB94CC-E202-4957-A9DA-82D500A6379E}"/>
               </a:ext>
             </a:extLst>
           </p:cNvPr>
@@ -2747,14 +2747,14 @@
             <a:pPr algn="l">
               <a:defRPr sz="1125" b="1">
                 <a:solidFill>
-                  <a:srgbClr val="20201E"/>
+                  <a:srgbClr val="F5F3ED"/>
                 </a:solidFill>
               </a:defRPr>
             </a:pPr>
             <a:r>
               <a:rPr sz="1125" b="1">
                 <a:solidFill>
-                  <a:srgbClr val="20201E"/>
+                  <a:srgbClr val="F5F3ED"/>
                 </a:solidFill>
               </a:rPr>
               <a:t>What is the time complexity of finding a value in a balanced binary search tree?</a:t>
@@ -2767,7 +2767,7 @@
           <p:cNvPr id="37" name="after-option-0">
             <a:extLst xmlns:a="http://schemas.openxmlformats.org/drawingml/2006/main">
               <a:ext uri="{FF2B5EF4-FFF2-40B4-BE49-F238E27FC236}">
-                <a16:creationId xmlns:a16="http://schemas.microsoft.com/office/drawing/2014/main" id="{3CA2E331-C3F7-4DFF-9F79-1590BEBB7E44}"/>
+                <a16:creationId xmlns:a16="http://schemas.microsoft.com/office/drawing/2014/main" id="{E95BD4A8-8E46-446D-97D1-07CAA86E2CB3}"/>
               </a:ext>
             </a:extLst>
           </p:cNvPr>
@@ -2785,11 +2785,11 @@
             <a:avLst/>
           </a:prstGeom>
           <a:solidFill xmlns:a="http://schemas.openxmlformats.org/drawingml/2006/main">
-            <a:srgbClr val="ECEAE5"/>
+            <a:srgbClr val="2D2F35"/>
           </a:solidFill>
           <a:ln xmlns:a="http://schemas.openxmlformats.org/drawingml/2006/main" w="9525">
             <a:solidFill>
-              <a:srgbClr val="C9C6BF"/>
+              <a:srgbClr val="565B66"/>
             </a:solidFill>
             <a:prstDash val="solid"/>
           </a:ln>
@@ -2800,7 +2800,7 @@
           <p:cNvPr id="38" name="after-option-label-0">
             <a:extLst xmlns:a="http://schemas.openxmlformats.org/drawingml/2006/main">
               <a:ext uri="{FF2B5EF4-FFF2-40B4-BE49-F238E27FC236}">
-                <a16:creationId xmlns:a16="http://schemas.microsoft.com/office/drawing/2014/main" id="{400EEA6F-D232-40B4-B7B7-532C55656D44}"/>
+                <a16:creationId xmlns:a16="http://schemas.microsoft.com/office/drawing/2014/main" id="{9FC1918F-DC81-4B33-A9C2-579B9A89BE71}"/>
               </a:ext>
             </a:extLst>
           </p:cNvPr>
@@ -2830,14 +2830,14 @@
             <a:pPr algn="l">
               <a:defRPr sz="750" b="1">
                 <a:solidFill>
-                  <a:srgbClr val="817F79"/>
+                  <a:srgbClr val="9096A1"/>
                 </a:solidFill>
               </a:defRPr>
             </a:pPr>
             <a:r>
               <a:rPr sz="750" b="1">
                 <a:solidFill>
-                  <a:srgbClr val="817F79"/>
+                  <a:srgbClr val="9096A1"/>
                 </a:solidFill>
               </a:rPr>
               <a:t>A</a:t>
@@ -2850,7 +2850,7 @@
           <p:cNvPr id="39" name="after-option-copy-0">
             <a:extLst xmlns:a="http://schemas.openxmlformats.org/drawingml/2006/main">
               <a:ext uri="{FF2B5EF4-FFF2-40B4-BE49-F238E27FC236}">
-                <a16:creationId xmlns:a16="http://schemas.microsoft.com/office/drawing/2014/main" id="{C3DE4639-1A11-43BA-8096-BD6AB0FF008C}"/>
+                <a16:creationId xmlns:a16="http://schemas.microsoft.com/office/drawing/2014/main" id="{7205F2EA-142D-4E55-BE6E-9CC9D76E2541}"/>
               </a:ext>
             </a:extLst>
           </p:cNvPr>
@@ -2880,14 +2880,14 @@
             <a:pPr algn="l">
               <a:defRPr sz="825" b="0">
                 <a:solidFill>
-                  <a:srgbClr val="6C6B66"/>
+                  <a:srgbClr val="ADB2BC"/>
                 </a:solidFill>
               </a:defRPr>
             </a:pPr>
             <a:r>
               <a:rPr sz="825" b="0">
                 <a:solidFill>
-                  <a:srgbClr val="6C6B66"/>
+                  <a:srgbClr val="ADB2BC"/>
                 </a:solidFill>
               </a:rPr>
               <a:t>O(1)</a:t>
@@ -2900,7 +2900,7 @@
           <p:cNvPr id="40" name="after-option-1">
             <a:extLst xmlns:a="http://schemas.openxmlformats.org/drawingml/2006/main">
               <a:ext uri="{FF2B5EF4-FFF2-40B4-BE49-F238E27FC236}">
-                <a16:creationId xmlns:a16="http://schemas.microsoft.com/office/drawing/2014/main" id="{EFAAE2CD-0C25-4170-ADFE-5B372ED64C44}"/>
+                <a16:creationId xmlns:a16="http://schemas.microsoft.com/office/drawing/2014/main" id="{F954A480-3503-4956-8E96-E44658D46ECA}"/>
               </a:ext>
             </a:extLst>
           </p:cNvPr>
@@ -2918,11 +2918,11 @@
             <a:avLst/>
           </a:prstGeom>
           <a:solidFill xmlns:a="http://schemas.openxmlformats.org/drawingml/2006/main">
-            <a:srgbClr val="E7F1E9"/>
+            <a:srgbClr val="263323"/>
           </a:solidFill>
           <a:ln xmlns:a="http://schemas.openxmlformats.org/drawingml/2006/main" w="13335">
             <a:solidFill>
-              <a:srgbClr val="2C7B45"/>
+              <a:srgbClr val="A3E635"/>
             </a:solidFill>
             <a:prstDash val="solid"/>
           </a:ln>
@@ -2933,7 +2933,7 @@
           <p:cNvPr id="41" name="after-option-label-1">
             <a:extLst xmlns:a="http://schemas.openxmlformats.org/drawingml/2006/main">
               <a:ext uri="{FF2B5EF4-FFF2-40B4-BE49-F238E27FC236}">
-                <a16:creationId xmlns:a16="http://schemas.microsoft.com/office/drawing/2014/main" id="{92DF9202-07CE-4782-9187-BA05AA071032}"/>
+                <a16:creationId xmlns:a16="http://schemas.microsoft.com/office/drawing/2014/main" id="{54E6103B-6DA5-4526-A80A-41B97F9D6ED9}"/>
               </a:ext>
             </a:extLst>
           </p:cNvPr>
@@ -2963,14 +2963,14 @@
             <a:pPr algn="l">
               <a:defRPr sz="750" b="1">
                 <a:solidFill>
-                  <a:srgbClr val="2C7B45"/>
+                  <a:srgbClr val="A3E635"/>
                 </a:solidFill>
               </a:defRPr>
             </a:pPr>
             <a:r>
               <a:rPr sz="750" b="1">
                 <a:solidFill>
-                  <a:srgbClr val="2C7B45"/>
+                  <a:srgbClr val="A3E635"/>
                 </a:solidFill>
               </a:rPr>
               <a:t>B</a:t>
@@ -2983,7 +2983,7 @@
           <p:cNvPr id="42" name="after-option-copy-1">
             <a:extLst xmlns:a="http://schemas.openxmlformats.org/drawingml/2006/main">
               <a:ext uri="{FF2B5EF4-FFF2-40B4-BE49-F238E27FC236}">
-                <a16:creationId xmlns:a16="http://schemas.microsoft.com/office/drawing/2014/main" id="{6F45B442-407B-49A5-A394-616DBA6E7E64}"/>
+                <a16:creationId xmlns:a16="http://schemas.microsoft.com/office/drawing/2014/main" id="{B853D1EA-EBBA-4371-94ED-37EEA4FB204E}"/>
               </a:ext>
             </a:extLst>
           </p:cNvPr>
@@ -3013,14 +3013,14 @@
             <a:pPr algn="l">
               <a:defRPr sz="825" b="1">
                 <a:solidFill>
-                  <a:srgbClr val="2C7B45"/>
+                  <a:srgbClr val="A3E635"/>
                 </a:solidFill>
               </a:defRPr>
             </a:pPr>
             <a:r>
               <a:rPr sz="825" b="1">
                 <a:solidFill>
-                  <a:srgbClr val="2C7B45"/>
+                  <a:srgbClr val="A3E635"/>
                 </a:solidFill>
               </a:rPr>
               <a:t>O(log n)</a:t>
@@ -3033,7 +3033,7 @@
           <p:cNvPr id="43" name="after-correct">
             <a:extLst xmlns:a="http://schemas.openxmlformats.org/drawingml/2006/main">
               <a:ext uri="{FF2B5EF4-FFF2-40B4-BE49-F238E27FC236}">
-                <a16:creationId xmlns:a16="http://schemas.microsoft.com/office/drawing/2014/main" id="{BB097B8F-8388-47E1-A520-7D02094AA8EF}"/>
+                <a16:creationId xmlns:a16="http://schemas.microsoft.com/office/drawing/2014/main" id="{D59E72CF-AB71-4D3A-8D26-3B6D539EB4D6}"/>
               </a:ext>
             </a:extLst>
           </p:cNvPr>
@@ -3063,14 +3063,14 @@
             <a:pPr algn="r">
               <a:defRPr sz="675" b="1">
                 <a:solidFill>
-                  <a:srgbClr val="2C7B45"/>
+                  <a:srgbClr val="A3E635"/>
                 </a:solidFill>
               </a:defRPr>
             </a:pPr>
             <a:r>
               <a:rPr sz="675" b="1">
                 <a:solidFill>
-                  <a:srgbClr val="2C7B45"/>
+                  <a:srgbClr val="A3E635"/>
                 </a:solidFill>
               </a:rPr>
               <a:t>CORRECT</a:t>
@@ -3083,7 +3083,7 @@
           <p:cNvPr id="44" name="after-option-2">
             <a:extLst xmlns:a="http://schemas.openxmlformats.org/drawingml/2006/main">
               <a:ext uri="{FF2B5EF4-FFF2-40B4-BE49-F238E27FC236}">
-                <a16:creationId xmlns:a16="http://schemas.microsoft.com/office/drawing/2014/main" id="{878CACB3-529E-4F16-AEB1-20287AA9933A}"/>
+                <a16:creationId xmlns:a16="http://schemas.microsoft.com/office/drawing/2014/main" id="{DAA8BBDF-F8BA-4498-BB98-51E3656E2F77}"/>
               </a:ext>
             </a:extLst>
           </p:cNvPr>
@@ -3101,11 +3101,11 @@
             <a:avLst/>
           </a:prstGeom>
           <a:solidFill xmlns:a="http://schemas.openxmlformats.org/drawingml/2006/main">
-            <a:srgbClr val="ECEAE5"/>
+            <a:srgbClr val="2D2F35"/>
           </a:solidFill>
           <a:ln xmlns:a="http://schemas.openxmlformats.org/drawingml/2006/main" w="9525">
             <a:solidFill>
-              <a:srgbClr val="C9C6BF"/>
+              <a:srgbClr val="565B66"/>
             </a:solidFill>
             <a:prstDash val="solid"/>
           </a:ln>
@@ -3116,7 +3116,7 @@
           <p:cNvPr id="45" name="after-option-label-2">
             <a:extLst xmlns:a="http://schemas.openxmlformats.org/drawingml/2006/main">
               <a:ext uri="{FF2B5EF4-FFF2-40B4-BE49-F238E27FC236}">
-                <a16:creationId xmlns:a16="http://schemas.microsoft.com/office/drawing/2014/main" id="{3440A67A-3200-42CD-9A00-DE4F412CF754}"/>
+                <a16:creationId xmlns:a16="http://schemas.microsoft.com/office/drawing/2014/main" id="{1D15C02B-EBBE-4F9C-8A5D-D6C231A46F90}"/>
               </a:ext>
             </a:extLst>
           </p:cNvPr>
@@ -3146,14 +3146,14 @@
             <a:pPr algn="l">
               <a:defRPr sz="750" b="1">
                 <a:solidFill>
-                  <a:srgbClr val="817F79"/>
+                  <a:srgbClr val="9096A1"/>
                 </a:solidFill>
               </a:defRPr>
             </a:pPr>
             <a:r>
               <a:rPr sz="750" b="1">
                 <a:solidFill>
-                  <a:srgbClr val="817F79"/>
+                  <a:srgbClr val="9096A1"/>
                 </a:solidFill>
               </a:rPr>
               <a:t>C</a:t>
@@ -3166,7 +3166,7 @@
           <p:cNvPr id="46" name="after-option-copy-2">
             <a:extLst xmlns:a="http://schemas.openxmlformats.org/drawingml/2006/main">
               <a:ext uri="{FF2B5EF4-FFF2-40B4-BE49-F238E27FC236}">
-                <a16:creationId xmlns:a16="http://schemas.microsoft.com/office/drawing/2014/main" id="{1F2570DB-8AC7-4D75-94A4-0600DA0FC76A}"/>
+                <a16:creationId xmlns:a16="http://schemas.microsoft.com/office/drawing/2014/main" id="{99B020B8-C610-4B56-9CF0-1D50BD46C4A7}"/>
               </a:ext>
             </a:extLst>
           </p:cNvPr>
@@ -3196,14 +3196,14 @@
             <a:pPr algn="l">
               <a:defRPr sz="825" b="0">
                 <a:solidFill>
-                  <a:srgbClr val="6C6B66"/>
+                  <a:srgbClr val="ADB2BC"/>
                 </a:solidFill>
               </a:defRPr>
             </a:pPr>
             <a:r>
               <a:rPr sz="825" b="0">
                 <a:solidFill>
-                  <a:srgbClr val="6C6B66"/>
+                  <a:srgbClr val="ADB2BC"/>
                 </a:solidFill>
               </a:rPr>
               <a:t>O(n)</a:t>
@@ -3216,7 +3216,7 @@
           <p:cNvPr id="47" name="after-option-3">
             <a:extLst xmlns:a="http://schemas.openxmlformats.org/drawingml/2006/main">
               <a:ext uri="{FF2B5EF4-FFF2-40B4-BE49-F238E27FC236}">
-                <a16:creationId xmlns:a16="http://schemas.microsoft.com/office/drawing/2014/main" id="{650B482C-3851-4065-8554-5CE1B562F146}"/>
+                <a16:creationId xmlns:a16="http://schemas.microsoft.com/office/drawing/2014/main" id="{B5F694FE-D93E-486E-86B8-CF7AB68EFAD8}"/>
               </a:ext>
             </a:extLst>
           </p:cNvPr>
@@ -3234,11 +3234,11 @@
             <a:avLst/>
           </a:prstGeom>
           <a:solidFill xmlns:a="http://schemas.openxmlformats.org/drawingml/2006/main">
-            <a:srgbClr val="ECEAE5"/>
+            <a:srgbClr val="2D2F35"/>
           </a:solidFill>
           <a:ln xmlns:a="http://schemas.openxmlformats.org/drawingml/2006/main" w="9525">
             <a:solidFill>
-              <a:srgbClr val="C9C6BF"/>
+              <a:srgbClr val="565B66"/>
             </a:solidFill>
             <a:prstDash val="solid"/>
           </a:ln>
@@ -3249,7 +3249,7 @@
           <p:cNvPr id="48" name="after-option-label-3">
             <a:extLst xmlns:a="http://schemas.openxmlformats.org/drawingml/2006/main">
               <a:ext uri="{FF2B5EF4-FFF2-40B4-BE49-F238E27FC236}">
-                <a16:creationId xmlns:a16="http://schemas.microsoft.com/office/drawing/2014/main" id="{C9E2F114-F89A-4687-95F5-9C81E665BFA7}"/>
+                <a16:creationId xmlns:a16="http://schemas.microsoft.com/office/drawing/2014/main" id="{C1F6DDD7-C262-46FE-B0AB-EB3B1818FCF7}"/>
               </a:ext>
             </a:extLst>
           </p:cNvPr>
@@ -3279,14 +3279,14 @@
             <a:pPr algn="l">
               <a:defRPr sz="750" b="1">
                 <a:solidFill>
-                  <a:srgbClr val="817F79"/>
+                  <a:srgbClr val="9096A1"/>
                 </a:solidFill>
               </a:defRPr>
             </a:pPr>
             <a:r>
               <a:rPr sz="750" b="1">
                 <a:solidFill>
-                  <a:srgbClr val="817F79"/>
+                  <a:srgbClr val="9096A1"/>
                 </a:solidFill>
               </a:rPr>
               <a:t>D</a:t>
@@ -3299,7 +3299,7 @@
           <p:cNvPr id="49" name="after-option-copy-3">
             <a:extLst xmlns:a="http://schemas.openxmlformats.org/drawingml/2006/main">
               <a:ext uri="{FF2B5EF4-FFF2-40B4-BE49-F238E27FC236}">
-                <a16:creationId xmlns:a16="http://schemas.microsoft.com/office/drawing/2014/main" id="{1F9EEB01-E920-4A42-88B4-0A473B9A623C}"/>
+                <a16:creationId xmlns:a16="http://schemas.microsoft.com/office/drawing/2014/main" id="{BE51A20B-CAA2-4E46-BE6F-7B0B5C63EF11}"/>
               </a:ext>
             </a:extLst>
           </p:cNvPr>
@@ -3329,14 +3329,14 @@
             <a:pPr algn="l">
               <a:defRPr sz="825" b="0">
                 <a:solidFill>
-                  <a:srgbClr val="6C6B66"/>
+                  <a:srgbClr val="ADB2BC"/>
                 </a:solidFill>
               </a:defRPr>
             </a:pPr>
             <a:r>
               <a:rPr sz="825" b="0">
                 <a:solidFill>
-                  <a:srgbClr val="6C6B66"/>
+                  <a:srgbClr val="ADB2BC"/>
                 </a:solidFill>
               </a:rPr>
               <a:t>O(n log n)</a:t>
@@ -3349,7 +3349,7 @@
           <p:cNvPr id="50" name="after-divider">
             <a:extLst xmlns:a="http://schemas.openxmlformats.org/drawingml/2006/main">
               <a:ext uri="{FF2B5EF4-FFF2-40B4-BE49-F238E27FC236}">
-                <a16:creationId xmlns:a16="http://schemas.microsoft.com/office/drawing/2014/main" id="{7D053966-8525-4130-924F-2ECE79D74DA7}"/>
+                <a16:creationId xmlns:a16="http://schemas.microsoft.com/office/drawing/2014/main" id="{92A763ED-4E43-47EA-B5B0-3371FF0A25E7}"/>
               </a:ext>
             </a:extLst>
           </p:cNvPr>
@@ -3369,7 +3369,7 @@
           <a:noFill xmlns:a="http://schemas.openxmlformats.org/drawingml/2006/main"/>
           <a:ln xmlns:a="http://schemas.openxmlformats.org/drawingml/2006/main" w="9525">
             <a:solidFill>
-              <a:srgbClr val="C9C6BF"/>
+              <a:srgbClr val="565B66"/>
             </a:solidFill>
             <a:prstDash val="solid"/>
           </a:ln>
@@ -3380,7 +3380,7 @@
           <p:cNvPr id="51" name="after-explanation-label">
             <a:extLst xmlns:a="http://schemas.openxmlformats.org/drawingml/2006/main">
               <a:ext uri="{FF2B5EF4-FFF2-40B4-BE49-F238E27FC236}">
-                <a16:creationId xmlns:a16="http://schemas.microsoft.com/office/drawing/2014/main" id="{B7197935-F988-46B1-9E49-455896A7A3AB}"/>
+                <a16:creationId xmlns:a16="http://schemas.microsoft.com/office/drawing/2014/main" id="{53C2E748-867D-4AC1-BEB4-02371F2CD9D8}"/>
               </a:ext>
             </a:extLst>
           </p:cNvPr>
@@ -3410,14 +3410,14 @@
             <a:pPr algn="l">
               <a:defRPr sz="750" b="1">
                 <a:solidFill>
-                  <a:srgbClr val="2C7B45"/>
+                  <a:srgbClr val="A3E635"/>
                 </a:solidFill>
               </a:defRPr>
             </a:pPr>
             <a:r>
               <a:rPr sz="750" b="1">
                 <a:solidFill>
-                  <a:srgbClr val="2C7B45"/>
+                  <a:srgbClr val="A3E635"/>
                 </a:solidFill>
               </a:rPr>
               <a:t>RATIONALE REVEALED</a:t>
@@ -3430,7 +3430,7 @@
           <p:cNvPr id="52" name="after-concept-label">
             <a:extLst xmlns:a="http://schemas.openxmlformats.org/drawingml/2006/main">
               <a:ext uri="{FF2B5EF4-FFF2-40B4-BE49-F238E27FC236}">
-                <a16:creationId xmlns:a16="http://schemas.microsoft.com/office/drawing/2014/main" id="{896839AE-F077-438F-A920-5DDA1FA12C8C}"/>
+                <a16:creationId xmlns:a16="http://schemas.microsoft.com/office/drawing/2014/main" id="{04E7BC2A-A2E0-4C17-9F29-3549BD113388}"/>
               </a:ext>
             </a:extLst>
           </p:cNvPr>
@@ -3460,14 +3460,14 @@
             <a:pPr algn="l">
               <a:defRPr sz="675" b="1">
                 <a:solidFill>
-                  <a:srgbClr val="6C6B66"/>
+                  <a:srgbClr val="ADB2BC"/>
                 </a:solidFill>
               </a:defRPr>
             </a:pPr>
             <a:r>
               <a:rPr sz="675" b="1">
                 <a:solidFill>
-                  <a:srgbClr val="6C6B66"/>
+                  <a:srgbClr val="ADB2BC"/>
                 </a:solidFill>
               </a:rPr>
               <a:t>WHAT THIS TESTS</a:t>
@@ -3480,7 +3480,7 @@
           <p:cNvPr id="53" name="after-concept">
             <a:extLst xmlns:a="http://schemas.openxmlformats.org/drawingml/2006/main">
               <a:ext uri="{FF2B5EF4-FFF2-40B4-BE49-F238E27FC236}">
-                <a16:creationId xmlns:a16="http://schemas.microsoft.com/office/drawing/2014/main" id="{30A25600-118C-4F55-8DFD-C3BADFE0E819}"/>
+                <a16:creationId xmlns:a16="http://schemas.microsoft.com/office/drawing/2014/main" id="{6BB80D71-65D1-4870-91F2-F9809F730480}"/>
               </a:ext>
             </a:extLst>
           </p:cNvPr>
@@ -3510,14 +3510,14 @@
             <a:pPr algn="l">
               <a:defRPr sz="938" b="1">
                 <a:solidFill>
-                  <a:srgbClr val="20201E"/>
+                  <a:srgbClr val="F5F3ED"/>
                 </a:solidFill>
               </a:defRPr>
             </a:pPr>
             <a:r>
               <a:rPr sz="938" b="1">
                 <a:solidFill>
-                  <a:srgbClr val="20201E"/>
+                  <a:srgbClr val="F5F3ED"/>
                 </a:solidFill>
               </a:rPr>
               <a:t>Balanced-tree search height</a:t>
@@ -3530,7 +3530,7 @@
           <p:cNvPr id="54" name="after-reason-rule">
             <a:extLst xmlns:a="http://schemas.openxmlformats.org/drawingml/2006/main">
               <a:ext uri="{FF2B5EF4-FFF2-40B4-BE49-F238E27FC236}">
-                <a16:creationId xmlns:a16="http://schemas.microsoft.com/office/drawing/2014/main" id="{E504D6BB-F8DF-4A13-8DF0-DD07D4E97FCC}"/>
+                <a16:creationId xmlns:a16="http://schemas.microsoft.com/office/drawing/2014/main" id="{3CE858AD-6C28-4149-8D6C-6D0C36A807EA}"/>
               </a:ext>
             </a:extLst>
           </p:cNvPr>
@@ -3550,7 +3550,7 @@
           <a:noFill xmlns:a="http://schemas.openxmlformats.org/drawingml/2006/main"/>
           <a:ln xmlns:a="http://schemas.openxmlformats.org/drawingml/2006/main" w="9525">
             <a:solidFill>
-              <a:srgbClr val="C9C6BF"/>
+              <a:srgbClr val="565B66"/>
             </a:solidFill>
             <a:prstDash val="solid"/>
           </a:ln>
@@ -3561,7 +3561,7 @@
           <p:cNvPr id="55" name="after-explanation">
             <a:extLst xmlns:a="http://schemas.openxmlformats.org/drawingml/2006/main">
               <a:ext uri="{FF2B5EF4-FFF2-40B4-BE49-F238E27FC236}">
-                <a16:creationId xmlns:a16="http://schemas.microsoft.com/office/drawing/2014/main" id="{9363D768-4F05-4373-99F5-4CEBE3BDBC5E}"/>
+                <a16:creationId xmlns:a16="http://schemas.microsoft.com/office/drawing/2014/main" id="{52FBA9BC-7290-4661-B942-017F04BE937A}"/>
               </a:ext>
             </a:extLst>
           </p:cNvPr>
@@ -3591,14 +3591,14 @@
             <a:pPr algn="l">
               <a:defRPr sz="840" b="0">
                 <a:solidFill>
-                  <a:srgbClr val="20201E"/>
+                  <a:srgbClr val="F5F3ED"/>
                 </a:solidFill>
               </a:defRPr>
             </a:pPr>
             <a:r>
               <a:rPr sz="840" b="0">
                 <a:solidFill>
-                  <a:srgbClr val="20201E"/>
+                  <a:srgbClr val="F5F3ED"/>
                 </a:solidFill>
               </a:rPr>
               <a:t>Each comparison discards roughly half of the remaining subtree, so search follows one root-to-leaf path of height O(log n).</a:t>
@@ -3611,7 +3611,7 @@
           <p:cNvPr id="56" name="after-note">
             <a:extLst xmlns:a="http://schemas.openxmlformats.org/drawingml/2006/main">
               <a:ext uri="{FF2B5EF4-FFF2-40B4-BE49-F238E27FC236}">
-                <a16:creationId xmlns:a16="http://schemas.microsoft.com/office/drawing/2014/main" id="{B253C3DC-215F-4F9B-9C8B-B649AADD7103}"/>
+                <a16:creationId xmlns:a16="http://schemas.microsoft.com/office/drawing/2014/main" id="{D8D0DFF5-DB3D-45C2-A114-C8833A059539}"/>
               </a:ext>
             </a:extLst>
           </p:cNvPr>
@@ -3641,14 +3641,14 @@
             <a:pPr algn="l">
               <a:defRPr sz="750" b="0">
                 <a:solidFill>
-                  <a:srgbClr val="6C6B66"/>
+                  <a:srgbClr val="ADB2BC"/>
                 </a:solidFill>
               </a:defRPr>
             </a:pPr>
             <a:r>
               <a:rPr sz="750" b="0">
                 <a:solidFill>
-                  <a:srgbClr val="6C6B66"/>
+                  <a:srgbClr val="ADB2BC"/>
                 </a:solidFill>
               </a:rPr>
               <a:t>The same selection also enables challenge-quality feedback.</a:t>
@@ -3661,7 +3661,7 @@
           <p:cNvPr id="57" name="live-label">
             <a:extLst xmlns:a="http://schemas.openxmlformats.org/drawingml/2006/main">
               <a:ext uri="{FF2B5EF4-FFF2-40B4-BE49-F238E27FC236}">
-                <a16:creationId xmlns:a16="http://schemas.microsoft.com/office/drawing/2014/main" id="{E355A7AB-6E79-47EE-BA77-D577B469D5F0}"/>
+                <a16:creationId xmlns:a16="http://schemas.microsoft.com/office/drawing/2014/main" id="{5B20658E-ADC5-414D-87BD-7C1B057025CF}"/>
               </a:ext>
             </a:extLst>
           </p:cNvPr>
@@ -3691,14 +3691,14 @@
             <a:pPr algn="l">
               <a:defRPr sz="900" b="1">
                 <a:solidFill>
-                  <a:srgbClr val="315D8B"/>
+                  <a:srgbClr val="A78BFA"/>
                 </a:solidFill>
               </a:defRPr>
             </a:pPr>
             <a:r>
               <a:rPr sz="900" b="1">
                 <a:solidFill>
-                  <a:srgbClr val="315D8B"/>
+                  <a:srgbClr val="A78BFA"/>
                 </a:solidFill>
               </a:rPr>
               <a:t>LIVE CHALLENGE CREATION · SEPARATE FROM THE INTERACTION ABOVE</a:t>
@@ -3711,7 +3711,7 @@
           <p:cNvPr id="58" name="live-arrow-0">
             <a:extLst xmlns:a="http://schemas.openxmlformats.org/drawingml/2006/main">
               <a:ext uri="{FF2B5EF4-FFF2-40B4-BE49-F238E27FC236}">
-                <a16:creationId xmlns:a16="http://schemas.microsoft.com/office/drawing/2014/main" id="{D90ECE00-61C5-4156-B395-F1F90991AEE4}"/>
+                <a16:creationId xmlns:a16="http://schemas.microsoft.com/office/drawing/2014/main" id="{6B4BBE21-8C89-4896-A5C8-3F5C4380641C}"/>
               </a:ext>
             </a:extLst>
           </p:cNvPr>
@@ -3729,11 +3729,11 @@
             <a:avLst/>
           </a:prstGeom>
           <a:solidFill xmlns:a="http://schemas.openxmlformats.org/drawingml/2006/main">
-            <a:srgbClr val="315D8B"/>
+            <a:srgbClr val="A78BFA"/>
           </a:solidFill>
           <a:ln xmlns:a="http://schemas.openxmlformats.org/drawingml/2006/main" w="0">
             <a:solidFill>
-              <a:srgbClr val="315D8B"/>
+              <a:srgbClr val="A78BFA"/>
             </a:solidFill>
             <a:prstDash val="solid"/>
           </a:ln>
@@ -3744,7 +3744,7 @@
           <p:cNvPr id="59" name="live-arrow-1">
             <a:extLst xmlns:a="http://schemas.openxmlformats.org/drawingml/2006/main">
               <a:ext uri="{FF2B5EF4-FFF2-40B4-BE49-F238E27FC236}">
-                <a16:creationId xmlns:a16="http://schemas.microsoft.com/office/drawing/2014/main" id="{B7339BC8-52E1-446C-8D81-B283FAC23743}"/>
+                <a16:creationId xmlns:a16="http://schemas.microsoft.com/office/drawing/2014/main" id="{A0C0A60C-8660-4F61-90A3-B265F50231F1}"/>
               </a:ext>
             </a:extLst>
           </p:cNvPr>
@@ -3762,11 +3762,11 @@
             <a:avLst/>
           </a:prstGeom>
           <a:solidFill xmlns:a="http://schemas.openxmlformats.org/drawingml/2006/main">
-            <a:srgbClr val="315D8B"/>
+            <a:srgbClr val="A78BFA"/>
           </a:solidFill>
           <a:ln xmlns:a="http://schemas.openxmlformats.org/drawingml/2006/main" w="0">
             <a:solidFill>
-              <a:srgbClr val="315D8B"/>
+              <a:srgbClr val="A78BFA"/>
             </a:solidFill>
             <a:prstDash val="solid"/>
           </a:ln>
@@ -3777,7 +3777,7 @@
           <p:cNvPr id="60" name="live-arrow-2">
             <a:extLst xmlns:a="http://schemas.openxmlformats.org/drawingml/2006/main">
               <a:ext uri="{FF2B5EF4-FFF2-40B4-BE49-F238E27FC236}">
-                <a16:creationId xmlns:a16="http://schemas.microsoft.com/office/drawing/2014/main" id="{D384C871-E354-475B-A70C-8780AF54F55D}"/>
+                <a16:creationId xmlns:a16="http://schemas.microsoft.com/office/drawing/2014/main" id="{5847261F-FC46-4630-937A-5BFCC7C241A7}"/>
               </a:ext>
             </a:extLst>
           </p:cNvPr>
@@ -3795,11 +3795,11 @@
             <a:avLst/>
           </a:prstGeom>
           <a:solidFill xmlns:a="http://schemas.openxmlformats.org/drawingml/2006/main">
-            <a:srgbClr val="315D8B"/>
+            <a:srgbClr val="A78BFA"/>
           </a:solidFill>
           <a:ln xmlns:a="http://schemas.openxmlformats.org/drawingml/2006/main" w="0">
             <a:solidFill>
-              <a:srgbClr val="315D8B"/>
+              <a:srgbClr val="A78BFA"/>
             </a:solidFill>
             <a:prstDash val="solid"/>
           </a:ln>
@@ -3810,7 +3810,7 @@
           <p:cNvPr id="61" name="live-arrow-3">
             <a:extLst xmlns:a="http://schemas.openxmlformats.org/drawingml/2006/main">
               <a:ext uri="{FF2B5EF4-FFF2-40B4-BE49-F238E27FC236}">
-                <a16:creationId xmlns:a16="http://schemas.microsoft.com/office/drawing/2014/main" id="{4C7D2695-1DD1-498D-B24D-0DB647DA1988}"/>
+                <a16:creationId xmlns:a16="http://schemas.microsoft.com/office/drawing/2014/main" id="{B7C650A4-F3FF-45E9-9511-E2EC4F554989}"/>
               </a:ext>
             </a:extLst>
           </p:cNvPr>
@@ -3828,11 +3828,11 @@
             <a:avLst/>
           </a:prstGeom>
           <a:solidFill xmlns:a="http://schemas.openxmlformats.org/drawingml/2006/main">
-            <a:srgbClr val="2C7B45"/>
+            <a:srgbClr val="A3E635"/>
           </a:solidFill>
           <a:ln xmlns:a="http://schemas.openxmlformats.org/drawingml/2006/main" w="0">
             <a:solidFill>
-              <a:srgbClr val="2C7B45"/>
+              <a:srgbClr val="A3E635"/>
             </a:solidFill>
             <a:prstDash val="solid"/>
           </a:ln>
@@ -3843,7 +3843,7 @@
           <p:cNvPr id="62" name="live-node-0">
             <a:extLst xmlns:a="http://schemas.openxmlformats.org/drawingml/2006/main">
               <a:ext uri="{FF2B5EF4-FFF2-40B4-BE49-F238E27FC236}">
-                <a16:creationId xmlns:a16="http://schemas.microsoft.com/office/drawing/2014/main" id="{CBED2B95-CA61-4754-AA36-83D71E9ECAB7}"/>
+                <a16:creationId xmlns:a16="http://schemas.microsoft.com/office/drawing/2014/main" id="{E5CCF8B6-81AA-4555-B050-0E168262A4F2}"/>
               </a:ext>
             </a:extLst>
           </p:cNvPr>
@@ -3863,11 +3863,11 @@
             </a:avLst>
           </a:prstGeom>
           <a:solidFill xmlns:a="http://schemas.openxmlformats.org/drawingml/2006/main">
-            <a:srgbClr val="E6EDF4"/>
+            <a:srgbClr val="302B46"/>
           </a:solidFill>
           <a:ln xmlns:a="http://schemas.openxmlformats.org/drawingml/2006/main" w="9525">
             <a:solidFill>
-              <a:srgbClr val="315D8B"/>
+              <a:srgbClr val="A78BFA"/>
             </a:solidFill>
             <a:prstDash val="solid"/>
           </a:ln>
@@ -3878,7 +3878,7 @@
           <p:cNvPr id="63" name="live-head-0">
             <a:extLst xmlns:a="http://schemas.openxmlformats.org/drawingml/2006/main">
               <a:ext uri="{FF2B5EF4-FFF2-40B4-BE49-F238E27FC236}">
-                <a16:creationId xmlns:a16="http://schemas.microsoft.com/office/drawing/2014/main" id="{CDE037DB-9B2E-4291-92EE-53F7D7E05A9B}"/>
+                <a16:creationId xmlns:a16="http://schemas.microsoft.com/office/drawing/2014/main" id="{7CDA7DB6-D1DC-480B-B587-5B8B01705F05}"/>
               </a:ext>
             </a:extLst>
           </p:cNvPr>
@@ -3908,14 +3908,14 @@
             <a:pPr algn="l">
               <a:defRPr sz="713" b="1">
                 <a:solidFill>
-                  <a:srgbClr val="315D8B"/>
+                  <a:srgbClr val="A78BFA"/>
                 </a:solidFill>
               </a:defRPr>
             </a:pPr>
             <a:r>
               <a:rPr sz="713" b="1">
                 <a:solidFill>
-                  <a:srgbClr val="315D8B"/>
+                  <a:srgbClr val="A78BFA"/>
                 </a:solidFill>
               </a:rPr>
               <a:t>SESSION</a:t>
@@ -3928,7 +3928,7 @@
           <p:cNvPr id="64" name="live-copy-0">
             <a:extLst xmlns:a="http://schemas.openxmlformats.org/drawingml/2006/main">
               <a:ext uri="{FF2B5EF4-FFF2-40B4-BE49-F238E27FC236}">
-                <a16:creationId xmlns:a16="http://schemas.microsoft.com/office/drawing/2014/main" id="{6006E04B-C9FB-4158-826F-A59493140AFB}"/>
+                <a16:creationId xmlns:a16="http://schemas.microsoft.com/office/drawing/2014/main" id="{3F43CA5A-99F8-4C96-A6DE-81DC4D1C9978}"/>
               </a:ext>
             </a:extLst>
           </p:cNvPr>
@@ -3958,14 +3958,14 @@
             <a:pPr algn="l">
               <a:defRPr sz="863" b="1">
                 <a:solidFill>
-                  <a:srgbClr val="20201E"/>
+                  <a:srgbClr val="F5F3ED"/>
                 </a:solidFill>
               </a:defRPr>
             </a:pPr>
             <a:r>
               <a:rPr sz="863" b="1">
                 <a:solidFill>
-                  <a:srgbClr val="20201E"/>
+                  <a:srgbClr val="F5F3ED"/>
                 </a:solidFill>
               </a:rPr>
               <a:t>Clerk user</a:t>
@@ -3978,7 +3978,7 @@
           <p:cNvPr id="65" name="live-node-1">
             <a:extLst xmlns:a="http://schemas.openxmlformats.org/drawingml/2006/main">
               <a:ext uri="{FF2B5EF4-FFF2-40B4-BE49-F238E27FC236}">
-                <a16:creationId xmlns:a16="http://schemas.microsoft.com/office/drawing/2014/main" id="{DE68ADAF-A1AC-44C8-854D-B6641F058052}"/>
+                <a16:creationId xmlns:a16="http://schemas.microsoft.com/office/drawing/2014/main" id="{262572B9-8830-45FC-B7A3-357A06149272}"/>
               </a:ext>
             </a:extLst>
           </p:cNvPr>
@@ -3998,11 +3998,11 @@
             </a:avLst>
           </a:prstGeom>
           <a:solidFill xmlns:a="http://schemas.openxmlformats.org/drawingml/2006/main">
-            <a:srgbClr val="E6EDF4"/>
+            <a:srgbClr val="302B46"/>
           </a:solidFill>
           <a:ln xmlns:a="http://schemas.openxmlformats.org/drawingml/2006/main" w="9525">
             <a:solidFill>
-              <a:srgbClr val="315D8B"/>
+              <a:srgbClr val="A78BFA"/>
             </a:solidFill>
             <a:prstDash val="solid"/>
           </a:ln>
@@ -4013,7 +4013,7 @@
           <p:cNvPr id="66" name="live-head-1">
             <a:extLst xmlns:a="http://schemas.openxmlformats.org/drawingml/2006/main">
               <a:ext uri="{FF2B5EF4-FFF2-40B4-BE49-F238E27FC236}">
-                <a16:creationId xmlns:a16="http://schemas.microsoft.com/office/drawing/2014/main" id="{534EE618-D3B7-45F7-A93E-D82801FE853F}"/>
+                <a16:creationId xmlns:a16="http://schemas.microsoft.com/office/drawing/2014/main" id="{52D9E2AC-6048-418E-B24B-2CB7E524C4BC}"/>
               </a:ext>
             </a:extLst>
           </p:cNvPr>
@@ -4043,14 +4043,14 @@
             <a:pPr algn="l">
               <a:defRPr sz="713" b="1">
                 <a:solidFill>
-                  <a:srgbClr val="315D8B"/>
+                  <a:srgbClr val="A78BFA"/>
                 </a:solidFill>
               </a:defRPr>
             </a:pPr>
             <a:r>
               <a:rPr sz="713" b="1">
                 <a:solidFill>
-                  <a:srgbClr val="315D8B"/>
+                  <a:srgbClr val="A78BFA"/>
                 </a:solidFill>
               </a:rPr>
               <a:t>QUOTA</a:t>
@@ -4063,7 +4063,7 @@
           <p:cNvPr id="67" name="live-copy-1">
             <a:extLst xmlns:a="http://schemas.openxmlformats.org/drawingml/2006/main">
               <a:ext uri="{FF2B5EF4-FFF2-40B4-BE49-F238E27FC236}">
-                <a16:creationId xmlns:a16="http://schemas.microsoft.com/office/drawing/2014/main" id="{20D107BB-3525-43B6-B489-1FA0409ABF95}"/>
+                <a16:creationId xmlns:a16="http://schemas.microsoft.com/office/drawing/2014/main" id="{CF9789AA-05EC-4A5F-825F-92942CEA828B}"/>
               </a:ext>
             </a:extLst>
           </p:cNvPr>
@@ -4093,14 +4093,14 @@
             <a:pPr algn="l">
               <a:defRPr sz="863" b="1">
                 <a:solidFill>
-                  <a:srgbClr val="20201E"/>
+                  <a:srgbClr val="F5F3ED"/>
                 </a:solidFill>
               </a:defRPr>
             </a:pPr>
             <a:r>
               <a:rPr sz="863" b="1">
                 <a:solidFill>
-                  <a:srgbClr val="20201E"/>
+                  <a:srgbClr val="F5F3ED"/>
                 </a:solidFill>
               </a:rPr>
               <a:t>&gt; 0</a:t>
@@ -4113,7 +4113,7 @@
           <p:cNvPr id="68" name="live-node-2">
             <a:extLst xmlns:a="http://schemas.openxmlformats.org/drawingml/2006/main">
               <a:ext uri="{FF2B5EF4-FFF2-40B4-BE49-F238E27FC236}">
-                <a16:creationId xmlns:a16="http://schemas.microsoft.com/office/drawing/2014/main" id="{9FAE554E-7B03-4941-821B-23F0C87DA0C0}"/>
+                <a16:creationId xmlns:a16="http://schemas.microsoft.com/office/drawing/2014/main" id="{8C2013AF-8AE6-4BB0-A039-5AF5E01F29E2}"/>
               </a:ext>
             </a:extLst>
           </p:cNvPr>
@@ -4133,11 +4133,11 @@
             </a:avLst>
           </a:prstGeom>
           <a:solidFill xmlns:a="http://schemas.openxmlformats.org/drawingml/2006/main">
-            <a:srgbClr val="E6EDF4"/>
+            <a:srgbClr val="302B46"/>
           </a:solidFill>
           <a:ln xmlns:a="http://schemas.openxmlformats.org/drawingml/2006/main" w="9525">
             <a:solidFill>
-              <a:srgbClr val="315D8B"/>
+              <a:srgbClr val="A78BFA"/>
             </a:solidFill>
             <a:prstDash val="solid"/>
           </a:ln>
@@ -4148,7 +4148,7 @@
           <p:cNvPr id="69" name="live-head-2">
             <a:extLst xmlns:a="http://schemas.openxmlformats.org/drawingml/2006/main">
               <a:ext uri="{FF2B5EF4-FFF2-40B4-BE49-F238E27FC236}">
-                <a16:creationId xmlns:a16="http://schemas.microsoft.com/office/drawing/2014/main" id="{4C8B3F57-A6D4-4ED5-9D9F-F4B9F908BB87}"/>
+                <a16:creationId xmlns:a16="http://schemas.microsoft.com/office/drawing/2014/main" id="{0A2C57FA-BDE8-4FED-A7D8-4A4CD4EB2E3C}"/>
               </a:ext>
             </a:extLst>
           </p:cNvPr>
@@ -4178,14 +4178,14 @@
             <a:pPr algn="l">
               <a:defRPr sz="713" b="1">
                 <a:solidFill>
-                  <a:srgbClr val="315D8B"/>
+                  <a:srgbClr val="A78BFA"/>
                 </a:solidFill>
               </a:defRPr>
             </a:pPr>
             <a:r>
               <a:rPr sz="713" b="1">
                 <a:solidFill>
-                  <a:srgbClr val="315D8B"/>
+                  <a:srgbClr val="A78BFA"/>
                 </a:solidFill>
               </a:rPr>
               <a:t>PROVIDER</a:t>
@@ -4198,7 +4198,7 @@
           <p:cNvPr id="70" name="live-copy-2">
             <a:extLst xmlns:a="http://schemas.openxmlformats.org/drawingml/2006/main">
               <a:ext uri="{FF2B5EF4-FFF2-40B4-BE49-F238E27FC236}">
-                <a16:creationId xmlns:a16="http://schemas.microsoft.com/office/drawing/2014/main" id="{1991A850-39E8-4825-8FD3-BBC0A79AFB7B}"/>
+                <a16:creationId xmlns:a16="http://schemas.microsoft.com/office/drawing/2014/main" id="{53332E5B-79A1-41C6-B784-5CC23190D3D3}"/>
               </a:ext>
             </a:extLst>
           </p:cNvPr>
@@ -4228,14 +4228,14 @@
             <a:pPr algn="l">
               <a:defRPr sz="863" b="1">
                 <a:solidFill>
-                  <a:srgbClr val="20201E"/>
+                  <a:srgbClr val="F5F3ED"/>
                 </a:solidFill>
               </a:defRPr>
             </a:pPr>
             <a:r>
               <a:rPr sz="863" b="1">
                 <a:solidFill>
-                  <a:srgbClr val="20201E"/>
+                  <a:srgbClr val="F5F3ED"/>
                 </a:solidFill>
               </a:rPr>
               <a:t>one JSON</a:t>
@@ -4248,7 +4248,7 @@
           <p:cNvPr id="71" name="live-node-3">
             <a:extLst xmlns:a="http://schemas.openxmlformats.org/drawingml/2006/main">
               <a:ext uri="{FF2B5EF4-FFF2-40B4-BE49-F238E27FC236}">
-                <a16:creationId xmlns:a16="http://schemas.microsoft.com/office/drawing/2014/main" id="{25378AED-5886-46BD-9DC1-132A44EEF26A}"/>
+                <a16:creationId xmlns:a16="http://schemas.microsoft.com/office/drawing/2014/main" id="{4424E2CC-40EA-43F5-BE51-C35FFC6F6050}"/>
               </a:ext>
             </a:extLst>
           </p:cNvPr>
@@ -4268,11 +4268,11 @@
             </a:avLst>
           </a:prstGeom>
           <a:solidFill xmlns:a="http://schemas.openxmlformats.org/drawingml/2006/main">
-            <a:srgbClr val="E6EDF4"/>
+            <a:srgbClr val="302B46"/>
           </a:solidFill>
           <a:ln xmlns:a="http://schemas.openxmlformats.org/drawingml/2006/main" w="9525">
             <a:solidFill>
-              <a:srgbClr val="315D8B"/>
+              <a:srgbClr val="A78BFA"/>
             </a:solidFill>
             <a:prstDash val="solid"/>
           </a:ln>
@@ -4283,7 +4283,7 @@
           <p:cNvPr id="72" name="live-head-3">
             <a:extLst xmlns:a="http://schemas.openxmlformats.org/drawingml/2006/main">
               <a:ext uri="{FF2B5EF4-FFF2-40B4-BE49-F238E27FC236}">
-                <a16:creationId xmlns:a16="http://schemas.microsoft.com/office/drawing/2014/main" id="{28D5CE41-A512-4AA4-9D29-834222CF0F9F}"/>
+                <a16:creationId xmlns:a16="http://schemas.microsoft.com/office/drawing/2014/main" id="{CFF8517A-7B53-4C57-AE18-00D3C12D3BC6}"/>
               </a:ext>
             </a:extLst>
           </p:cNvPr>
@@ -4313,14 +4313,14 @@
             <a:pPr algn="l">
               <a:defRPr sz="713" b="1">
                 <a:solidFill>
-                  <a:srgbClr val="315D8B"/>
+                  <a:srgbClr val="A78BFA"/>
                 </a:solidFill>
               </a:defRPr>
             </a:pPr>
             <a:r>
               <a:rPr sz="713" b="1">
                 <a:solidFill>
-                  <a:srgbClr val="315D8B"/>
+                  <a:srgbClr val="A78BFA"/>
                 </a:solidFill>
               </a:rPr>
               <a:t>PYDANTIC</a:t>
@@ -4333,7 +4333,7 @@
           <p:cNvPr id="73" name="live-copy-3">
             <a:extLst xmlns:a="http://schemas.openxmlformats.org/drawingml/2006/main">
               <a:ext uri="{FF2B5EF4-FFF2-40B4-BE49-F238E27FC236}">
-                <a16:creationId xmlns:a16="http://schemas.microsoft.com/office/drawing/2014/main" id="{D772FC07-E7FA-42A5-85BA-E10624A75D89}"/>
+                <a16:creationId xmlns:a16="http://schemas.microsoft.com/office/drawing/2014/main" id="{06E88955-89A5-4527-908F-B36C916CCB2B}"/>
               </a:ext>
             </a:extLst>
           </p:cNvPr>
@@ -4363,14 +4363,14 @@
             <a:pPr algn="l">
               <a:defRPr sz="863" b="1">
                 <a:solidFill>
-                  <a:srgbClr val="20201E"/>
+                  <a:srgbClr val="F5F3ED"/>
                 </a:solidFill>
               </a:defRPr>
             </a:pPr>
             <a:r>
               <a:rPr sz="863" b="1">
                 <a:solidFill>
-                  <a:srgbClr val="20201E"/>
+                  <a:srgbClr val="F5F3ED"/>
                 </a:solidFill>
               </a:rPr>
               <a:t>4 unique</a:t>
@@ -4380,14 +4380,14 @@
             <a:pPr algn="l">
               <a:defRPr sz="863" b="1">
                 <a:solidFill>
-                  <a:srgbClr val="20201E"/>
+                  <a:srgbClr val="F5F3ED"/>
                 </a:solidFill>
               </a:defRPr>
             </a:pPr>
             <a:r>
               <a:rPr sz="863" b="1">
                 <a:solidFill>
-                  <a:srgbClr val="20201E"/>
+                  <a:srgbClr val="F5F3ED"/>
                 </a:solidFill>
               </a:rPr>
               <a:t>answer 0–3</a:t>
@@ -4400,7 +4400,7 @@
           <p:cNvPr id="74" name="live-node-4">
             <a:extLst xmlns:a="http://schemas.openxmlformats.org/drawingml/2006/main">
               <a:ext uri="{FF2B5EF4-FFF2-40B4-BE49-F238E27FC236}">
-                <a16:creationId xmlns:a16="http://schemas.microsoft.com/office/drawing/2014/main" id="{5D10B16B-6EB1-40ED-96A9-9EBFE18BBF29}"/>
+                <a16:creationId xmlns:a16="http://schemas.microsoft.com/office/drawing/2014/main" id="{0A93F6AC-FE2C-40EB-8341-61BCD5B6B6A2}"/>
               </a:ext>
             </a:extLst>
           </p:cNvPr>
@@ -4420,11 +4420,11 @@
             </a:avLst>
           </a:prstGeom>
           <a:solidFill xmlns:a="http://schemas.openxmlformats.org/drawingml/2006/main">
-            <a:srgbClr val="E7F1E9"/>
+            <a:srgbClr val="263323"/>
           </a:solidFill>
           <a:ln xmlns:a="http://schemas.openxmlformats.org/drawingml/2006/main" w="13335">
             <a:solidFill>
-              <a:srgbClr val="2C7B45"/>
+              <a:srgbClr val="A3E635"/>
             </a:solidFill>
             <a:prstDash val="solid"/>
           </a:ln>
@@ -4435,7 +4435,7 @@
           <p:cNvPr id="75" name="live-head-4">
             <a:extLst xmlns:a="http://schemas.openxmlformats.org/drawingml/2006/main">
               <a:ext uri="{FF2B5EF4-FFF2-40B4-BE49-F238E27FC236}">
-                <a16:creationId xmlns:a16="http://schemas.microsoft.com/office/drawing/2014/main" id="{8822AAE0-CB72-4096-A2AE-80B717496832}"/>
+                <a16:creationId xmlns:a16="http://schemas.microsoft.com/office/drawing/2014/main" id="{0E36EF40-71DB-4202-BD6C-296DFCB2DC27}"/>
               </a:ext>
             </a:extLst>
           </p:cNvPr>
@@ -4465,14 +4465,14 @@
             <a:pPr algn="l">
               <a:defRPr sz="713" b="1">
                 <a:solidFill>
-                  <a:srgbClr val="2C7B45"/>
+                  <a:srgbClr val="A3E635"/>
                 </a:solidFill>
               </a:defRPr>
             </a:pPr>
             <a:r>
               <a:rPr sz="713" b="1">
                 <a:solidFill>
-                  <a:srgbClr val="2C7B45"/>
+                  <a:srgbClr val="A3E635"/>
                 </a:solidFill>
               </a:rPr>
               <a:t>TRANSACTION</a:t>
@@ -4485,7 +4485,7 @@
           <p:cNvPr id="76" name="live-copy-4">
             <a:extLst xmlns:a="http://schemas.openxmlformats.org/drawingml/2006/main">
               <a:ext uri="{FF2B5EF4-FFF2-40B4-BE49-F238E27FC236}">
-                <a16:creationId xmlns:a16="http://schemas.microsoft.com/office/drawing/2014/main" id="{99DE63E3-450A-4B4C-B84F-BAA087F86A08}"/>
+                <a16:creationId xmlns:a16="http://schemas.microsoft.com/office/drawing/2014/main" id="{F97CD7DA-40DE-4730-A1E1-9ACABC69C45E}"/>
               </a:ext>
             </a:extLst>
           </p:cNvPr>
@@ -4515,14 +4515,14 @@
             <a:pPr algn="ctr">
               <a:defRPr sz="863" b="1">
                 <a:solidFill>
-                  <a:srgbClr val="20201E"/>
+                  <a:srgbClr val="F5F3ED"/>
                 </a:solidFill>
               </a:defRPr>
             </a:pPr>
             <a:r>
               <a:rPr sz="863" b="1">
                 <a:solidFill>
-                  <a:srgbClr val="20201E"/>
+                  <a:srgbClr val="F5F3ED"/>
                 </a:solidFill>
               </a:rPr>
               <a:t>challenge +</a:t>
@@ -4532,14 +4532,14 @@
             <a:pPr algn="ctr">
               <a:defRPr sz="863" b="1">
                 <a:solidFill>
-                  <a:srgbClr val="20201E"/>
+                  <a:srgbClr val="F5F3ED"/>
                 </a:solidFill>
               </a:defRPr>
             </a:pPr>
             <a:r>
               <a:rPr sz="863" b="1">
                 <a:solidFill>
-                  <a:srgbClr val="20201E"/>
+                  <a:srgbClr val="F5F3ED"/>
                 </a:solidFill>
               </a:rPr>
               <a:t>quota − 1</a:t>
@@ -4552,7 +4552,7 @@
           <p:cNvPr id="77" name="demo-note">
             <a:extLst xmlns:a="http://schemas.openxmlformats.org/drawingml/2006/main">
               <a:ext uri="{FF2B5EF4-FFF2-40B4-BE49-F238E27FC236}">
-                <a16:creationId xmlns:a16="http://schemas.microsoft.com/office/drawing/2014/main" id="{11A3D685-B4DF-4FCD-A376-C9C5BDEC766F}"/>
+                <a16:creationId xmlns:a16="http://schemas.microsoft.com/office/drawing/2014/main" id="{865B7321-317B-410E-A74D-13F009BB45BF}"/>
               </a:ext>
             </a:extLst>
           </p:cNvPr>
@@ -4572,11 +4572,11 @@
             </a:avLst>
           </a:prstGeom>
           <a:solidFill xmlns:a="http://schemas.openxmlformats.org/drawingml/2006/main">
-            <a:srgbClr val="ECEAE5"/>
+            <a:srgbClr val="2D2F35"/>
           </a:solidFill>
           <a:ln xmlns:a="http://schemas.openxmlformats.org/drawingml/2006/main" w="9525">
             <a:solidFill>
-              <a:srgbClr val="817F79"/>
+              <a:srgbClr val="9096A1"/>
             </a:solidFill>
             <a:prstDash val="solid"/>
           </a:ln>
@@ -4587,7 +4587,7 @@
           <p:cNvPr id="78" name="demo-note-head">
             <a:extLst xmlns:a="http://schemas.openxmlformats.org/drawingml/2006/main">
               <a:ext uri="{FF2B5EF4-FFF2-40B4-BE49-F238E27FC236}">
-                <a16:creationId xmlns:a16="http://schemas.microsoft.com/office/drawing/2014/main" id="{0F24EC64-771C-4DA1-848C-55F12AB245B5}"/>
+                <a16:creationId xmlns:a16="http://schemas.microsoft.com/office/drawing/2014/main" id="{E0C6E730-0398-4CF9-B83F-35B8A56C0BBB}"/>
               </a:ext>
             </a:extLst>
           </p:cNvPr>
@@ -4617,14 +4617,14 @@
             <a:pPr algn="l">
               <a:defRPr sz="713" b="1">
                 <a:solidFill>
-                  <a:srgbClr val="817F79"/>
+                  <a:srgbClr val="9096A1"/>
                 </a:solidFill>
               </a:defRPr>
             </a:pPr>
             <a:r>
               <a:rPr sz="713" b="1">
                 <a:solidFill>
-                  <a:srgbClr val="817F79"/>
+                  <a:srgbClr val="9096A1"/>
                 </a:solidFill>
               </a:rPr>
               <a:t>DEMO</a:t>
@@ -4637,7 +4637,7 @@
           <p:cNvPr id="79" name="demo-note-copy">
             <a:extLst xmlns:a="http://schemas.openxmlformats.org/drawingml/2006/main">
               <a:ext uri="{FF2B5EF4-FFF2-40B4-BE49-F238E27FC236}">
-                <a16:creationId xmlns:a16="http://schemas.microsoft.com/office/drawing/2014/main" id="{91222B0F-0DFD-409F-9B0F-C3669CC6076F}"/>
+                <a16:creationId xmlns:a16="http://schemas.microsoft.com/office/drawing/2014/main" id="{09BB28B2-F7B6-467F-A61F-913ABD5BF2AF}"/>
               </a:ext>
             </a:extLst>
           </p:cNvPr>
@@ -4667,14 +4667,14 @@
             <a:pPr algn="ctr">
               <a:defRPr sz="750" b="0">
                 <a:solidFill>
-                  <a:srgbClr val="20201E"/>
+                  <a:srgbClr val="F5F3ED"/>
                 </a:solidFill>
               </a:defRPr>
             </a:pPr>
             <a:r>
               <a:rPr sz="750" b="0">
                 <a:solidFill>
-                  <a:srgbClr val="20201E"/>
+                  <a:srgbClr val="F5F3ED"/>
                 </a:solidFill>
               </a:rPr>
               <a:t>same frontend contract; no auth, provider, or DB</a:t>
@@ -4687,7 +4687,7 @@
           <p:cNvPr id="80" name="rollback-link">
             <a:extLst xmlns:a="http://schemas.openxmlformats.org/drawingml/2006/main">
               <a:ext uri="{FF2B5EF4-FFF2-40B4-BE49-F238E27FC236}">
-                <a16:creationId xmlns:a16="http://schemas.microsoft.com/office/drawing/2014/main" id="{ED060286-C297-4CC3-973F-363E3C4691EF}"/>
+                <a16:creationId xmlns:a16="http://schemas.microsoft.com/office/drawing/2014/main" id="{AD2EDC06-4D6F-43C5-B9FF-6821E723F3A2}"/>
               </a:ext>
             </a:extLst>
           </p:cNvPr>
@@ -4707,7 +4707,7 @@
           <a:noFill xmlns:a="http://schemas.openxmlformats.org/drawingml/2006/main"/>
           <a:ln xmlns:a="http://schemas.openxmlformats.org/drawingml/2006/main" w="11430">
             <a:solidFill>
-              <a:srgbClr val="A56509"/>
+              <a:srgbClr val="F2C14E"/>
             </a:solidFill>
             <a:prstDash val="dash"/>
           </a:ln>
@@ -4718,7 +4718,7 @@
           <p:cNvPr id="81" name="rollback">
             <a:extLst xmlns:a="http://schemas.openxmlformats.org/drawingml/2006/main">
               <a:ext uri="{FF2B5EF4-FFF2-40B4-BE49-F238E27FC236}">
-                <a16:creationId xmlns:a16="http://schemas.microsoft.com/office/drawing/2014/main" id="{946824E8-9140-42DB-8431-31A429A9AB20}"/>
+                <a16:creationId xmlns:a16="http://schemas.microsoft.com/office/drawing/2014/main" id="{DDD7FCD8-576E-468B-8132-B657E6E936DF}"/>
               </a:ext>
             </a:extLst>
           </p:cNvPr>
@@ -4748,14 +4748,14 @@
             <a:pPr algn="ctr">
               <a:defRPr sz="863" b="1">
                 <a:solidFill>
-                  <a:srgbClr val="A56509"/>
+                  <a:srgbClr val="F2C14E"/>
                 </a:solidFill>
               </a:defRPr>
             </a:pPr>
             <a:r>
               <a:rPr sz="863" b="1">
                 <a:solidFill>
-                  <a:srgbClr val="A56509"/>
+                  <a:srgbClr val="F2C14E"/>
                 </a:solidFill>
               </a:rPr>
               <a:t>any failure → rollback; quota unchanged</a:t>
@@ -4768,7 +4768,7 @@
           <p:cNvPr id="82" name="footer-rule">
             <a:extLst xmlns:a="http://schemas.openxmlformats.org/drawingml/2006/main">
               <a:ext uri="{FF2B5EF4-FFF2-40B4-BE49-F238E27FC236}">
-                <a16:creationId xmlns:a16="http://schemas.microsoft.com/office/drawing/2014/main" id="{260BBA04-26E7-4F27-94F8-79AA7D655EE0}"/>
+                <a16:creationId xmlns:a16="http://schemas.microsoft.com/office/drawing/2014/main" id="{6CC62291-CBF2-49E1-A4FC-E2DF3CADAA81}"/>
               </a:ext>
             </a:extLst>
           </p:cNvPr>
@@ -4788,7 +4788,7 @@
           <a:noFill xmlns:a="http://schemas.openxmlformats.org/drawingml/2006/main"/>
           <a:ln xmlns:a="http://schemas.openxmlformats.org/drawingml/2006/main" w="13335">
             <a:solidFill>
-              <a:srgbClr val="20201E"/>
+              <a:srgbClr val="F5F3ED"/>
             </a:solidFill>
             <a:prstDash val="solid"/>
           </a:ln>
@@ -4799,7 +4799,7 @@
           <p:cNvPr id="83" name="boundary-head">
             <a:extLst xmlns:a="http://schemas.openxmlformats.org/drawingml/2006/main">
               <a:ext uri="{FF2B5EF4-FFF2-40B4-BE49-F238E27FC236}">
-                <a16:creationId xmlns:a16="http://schemas.microsoft.com/office/drawing/2014/main" id="{82220321-B467-4E72-A33C-FFA7802F3771}"/>
+                <a16:creationId xmlns:a16="http://schemas.microsoft.com/office/drawing/2014/main" id="{483675A4-9526-4FE6-8090-E6DD52CE6E02}"/>
               </a:ext>
             </a:extLst>
           </p:cNvPr>
@@ -4829,14 +4829,14 @@
             <a:pPr algn="l">
               <a:defRPr sz="788" b="1">
                 <a:solidFill>
-                  <a:srgbClr val="2C7B45"/>
+                  <a:srgbClr val="A3E635"/>
                 </a:solidFill>
               </a:defRPr>
             </a:pPr>
             <a:r>
               <a:rPr sz="788" b="1">
                 <a:solidFill>
-                  <a:srgbClr val="2C7B45"/>
+                  <a:srgbClr val="A3E635"/>
                 </a:solidFill>
               </a:rPr>
               <a:t>SUPPORTED</a:t>
@@ -4849,7 +4849,7 @@
           <p:cNvPr id="84" name="boundary-supported">
             <a:extLst xmlns:a="http://schemas.openxmlformats.org/drawingml/2006/main">
               <a:ext uri="{FF2B5EF4-FFF2-40B4-BE49-F238E27FC236}">
-                <a16:creationId xmlns:a16="http://schemas.microsoft.com/office/drawing/2014/main" id="{780C40DB-C262-43E4-ABA4-09624A1C0CD6}"/>
+                <a16:creationId xmlns:a16="http://schemas.microsoft.com/office/drawing/2014/main" id="{A9991169-4703-4F71-9CC5-475108EA6401}"/>
               </a:ext>
             </a:extLst>
           </p:cNvPr>
@@ -4879,14 +4879,14 @@
             <a:pPr algn="l">
               <a:defRPr sz="863" b="1">
                 <a:solidFill>
-                  <a:srgbClr val="20201E"/>
+                  <a:srgbClr val="F5F3ED"/>
                 </a:solidFill>
               </a:defRPr>
             </a:pPr>
             <a:r>
               <a:rPr sz="863" b="1">
                 <a:solidFill>
-                  <a:srgbClr val="20201E"/>
+                  <a:srgbClr val="F5F3ED"/>
                 </a:solidFill>
               </a:rPr>
               <a:t>commit-before-rationale interaction · exact four-option validation · atomic challenge-and-quota write</a:t>
@@ -4899,7 +4899,7 @@
           <p:cNvPr id="85" name="not-head">
             <a:extLst xmlns:a="http://schemas.openxmlformats.org/drawingml/2006/main">
               <a:ext uri="{FF2B5EF4-FFF2-40B4-BE49-F238E27FC236}">
-                <a16:creationId xmlns:a16="http://schemas.microsoft.com/office/drawing/2014/main" id="{BA523D94-CD79-4D45-A13C-8F8744DEB20F}"/>
+                <a16:creationId xmlns:a16="http://schemas.microsoft.com/office/drawing/2014/main" id="{D888A54D-C520-4272-9EA7-DA72A9427A3D}"/>
               </a:ext>
             </a:extLst>
           </p:cNvPr>
@@ -4929,14 +4929,14 @@
             <a:pPr algn="l">
               <a:defRPr sz="788" b="1">
                 <a:solidFill>
-                  <a:srgbClr val="AA4138"/>
+                  <a:srgbClr val="FF6B6B"/>
                 </a:solidFill>
               </a:defRPr>
             </a:pPr>
             <a:r>
               <a:rPr sz="788" b="1">
                 <a:solidFill>
-                  <a:srgbClr val="AA4138"/>
+                  <a:srgbClr val="FF6B6B"/>
                 </a:solidFill>
               </a:rPr>
               <a:t>NOT CLAIMED</a:t>
@@ -4949,7 +4949,7 @@
           <p:cNvPr id="86" name="not-copy">
             <a:extLst xmlns:a="http://schemas.openxmlformats.org/drawingml/2006/main">
               <a:ext uri="{FF2B5EF4-FFF2-40B4-BE49-F238E27FC236}">
-                <a16:creationId xmlns:a16="http://schemas.microsoft.com/office/drawing/2014/main" id="{8E069850-5899-4DA2-8485-1FE673A8840A}"/>
+                <a16:creationId xmlns:a16="http://schemas.microsoft.com/office/drawing/2014/main" id="{9E8C04B2-BEE6-4A8D-AF4B-18A822057F0A}"/>
               </a:ext>
             </a:extLst>
           </p:cNvPr>
@@ -4979,14 +4979,14 @@
             <a:pPr algn="l">
               <a:defRPr sz="788" b="0">
                 <a:solidFill>
-                  <a:srgbClr val="20201E"/>
+                  <a:srgbClr val="F5F3ED"/>
                 </a:solidFill>
               </a:defRPr>
             </a:pPr>
             <a:r>
               <a:rPr sz="788" b="0">
                 <a:solidFill>
-                  <a:srgbClr val="20201E"/>
+                  <a:srgbClr val="F5F3ED"/>
                 </a:solidFill>
               </a:rPr>
               <a:t>learning outcomes, interview performance, question quality, or provider accuracy</a:t>
@@ -4999,7 +4999,7 @@
           <p:cNvPr id="87" name="sources">
             <a:extLst xmlns:a="http://schemas.openxmlformats.org/drawingml/2006/main">
               <a:ext uri="{FF2B5EF4-FFF2-40B4-BE49-F238E27FC236}">
-                <a16:creationId xmlns:a16="http://schemas.microsoft.com/office/drawing/2014/main" id="{6653B466-3CFD-48A5-BDEF-6DFD787E6C21}"/>
+                <a16:creationId xmlns:a16="http://schemas.microsoft.com/office/drawing/2014/main" id="{DA3F8A56-1660-40F3-AC49-6A039B88F2E0}"/>
               </a:ext>
             </a:extLst>
           </p:cNvPr>
@@ -5029,14 +5029,14 @@
             <a:pPr algn="ctr">
               <a:defRPr sz="675" b="0">
                 <a:solidFill>
-                  <a:srgbClr val="6C6B66"/>
+                  <a:srgbClr val="ADB2BC"/>
                 </a:solidFill>
               </a:defRPr>
             </a:pPr>
             <a:r>
               <a:rPr sz="675" b="0">
                 <a:solidFill>
-                  <a:srgbClr val="6C6B66"/>
+                  <a:srgbClr val="ADB2BC"/>
                 </a:solidFill>
               </a:rPr>
               <a:t>Sources: demo.js · MCQChallenge.jsx · ai_generator.py · routes/challenge.py</a:t>
@@ -5047,7 +5047,7 @@
     </p:spTree>
     <p:extLst>
       <p:ext uri="{BB962C8B-B14F-4D97-AF65-F5344CB8AC3E}">
-        <p14:creationId xmlns:p14="http://schemas.microsoft.com/office/powerpoint/2010/main" val="25118143"/>
+        <p14:creationId xmlns:p14="http://schemas.microsoft.com/office/powerpoint/2010/main" val="1931002229"/>
       </p:ext>
     </p:extLst>
   </p:cSld>

</xml_diff>

<commit_message>
Align CodePrep figure with the product theme (#7)
## What changed

- replaced the invented dark IDE treatment with CodePrep's actual warm
off-white, rust, charcoal, and green tokens
- retained the sequence lifelines, alternate demo/live paths, validation
gate, and transaction boundary
- regenerated editable, vector, raster, provenance, and preflight
artifacts

## Why

The prior dark theme contradicted the product UI. This revision makes
the figure feel native to CodePrep while using the restrained grouping
and hierarchy of strong robotics-paper system diagrams.

## Validation

- PowerPoint overflow check
- 716 px final-size and grayscale review
- vector-only PDF preflight
- provenance checksums verified
</commit_message>
<xml_diff>
--- a/docs/figures/codeprep-decision-flow/editable/codeprep-decision-flow.pptx
+++ b/docs/figures/codeprep-decision-flow/editable/codeprep-decision-flow.pptx
@@ -2,13 +2,13 @@
 <file path=ppt/presentation.xml><?xml version="1.0" encoding="utf-8"?>
 <p:presentation xmlns:p="http://schemas.openxmlformats.org/presentationml/2006/main">
   <p:sldMasterIdLst>
-    <p:sldMasterId xmlns:r="http://schemas.openxmlformats.org/officeDocument/2006/relationships" id="2147483648" r:id="R5d0b771b95a84739"/>
+    <p:sldMasterId xmlns:r="http://schemas.openxmlformats.org/officeDocument/2006/relationships" id="2147483648" r:id="R3b3c648a57094204"/>
   </p:sldMasterIdLst>
   <p:notesMasterIdLst>
-    <p:notesMasterId xmlns:r="http://schemas.openxmlformats.org/officeDocument/2006/relationships" r:id="R0a34114f4f5041d8"/>
+    <p:notesMasterId xmlns:r="http://schemas.openxmlformats.org/officeDocument/2006/relationships" r:id="Rfbbaf8815d0845c1"/>
   </p:notesMasterIdLst>
   <p:sldIdLst>
-    <p:sldId xmlns:r="http://schemas.openxmlformats.org/officeDocument/2006/relationships" id="256" r:id="R562cfbb4ccad4b49"/>
+    <p:sldId xmlns:r="http://schemas.openxmlformats.org/officeDocument/2006/relationships" id="256" r:id="R705fb06b2cde451d"/>
   </p:sldIdLst>
   <p:sldSz cx="12192000" cy="6858000"/>
   <p:notesSz cx="6858000" cy="9144000"/>
@@ -601,7 +601,7 @@
   </p:cSld>
   <p:clrMap bg1="lt1" tx1="dk1" bg2="lt2" tx2="dk2" accent1="accent1" accent2="accent2" accent3="accent3" accent4="accent4" accent5="accent5" accent6="accent6" hlink="hlink" folHlink="folHlink"/>
   <p:sldLayoutIdLst>
-    <p:sldLayoutId xmlns:r="http://schemas.openxmlformats.org/officeDocument/2006/relationships" id="2147483649" r:id="R4b1f8af04481440f"/>
+    <p:sldLayoutId xmlns:r="http://schemas.openxmlformats.org/officeDocument/2006/relationships" id="2147483649" r:id="Rf741c57dd3a248b2"/>
   </p:sldLayoutIdLst>
   <p:txStyles>
     <p:titleStyle>
@@ -1134,7 +1134,7 @@
     <p:bg>
       <p:bgPr>
         <a:solidFill xmlns:a="http://schemas.openxmlformats.org/drawingml/2006/main">
-          <a:srgbClr val="14161A"/>
+          <a:srgbClr val="F4F4F1"/>
         </a:solidFill>
       </p:bgPr>
     </p:bg>
@@ -1152,7 +1152,7 @@
           <p:cNvPr id="72" name="kicker">
             <a:extLst xmlns:a="http://schemas.openxmlformats.org/drawingml/2006/main">
               <a:ext uri="{FF2B5EF4-FFF2-40B4-BE49-F238E27FC236}">
-                <a16:creationId xmlns:a16="http://schemas.microsoft.com/office/drawing/2014/main" id="{4D6F2E8C-573F-4DB7-B1B8-F0A262817C9B}"/>
+                <a16:creationId xmlns:a16="http://schemas.microsoft.com/office/drawing/2014/main" id="{B6AE85CD-FB95-47BF-BBB4-1F7D7414C79C}"/>
               </a:ext>
             </a:extLst>
           </p:cNvPr>
@@ -1182,14 +1182,14 @@
             <a:pPr algn="l">
               <a:defRPr sz="788" b="1">
                 <a:solidFill>
-                  <a:srgbClr val="FF8A45"/>
+                  <a:srgbClr val="C73D1D"/>
                 </a:solidFill>
               </a:defRPr>
             </a:pPr>
             <a:r>
               <a:rPr sz="788" b="1">
                 <a:solidFill>
-                  <a:srgbClr val="FF8A45"/>
+                  <a:srgbClr val="C73D1D"/>
                 </a:solidFill>
               </a:rPr>
               <a:t>REQUEST SEQUENCE · DEMO AND LIVE</a:t>
@@ -1202,7 +1202,7 @@
           <p:cNvPr id="2" name="title">
             <a:extLst xmlns:a="http://schemas.openxmlformats.org/drawingml/2006/main">
               <a:ext uri="{FF2B5EF4-FFF2-40B4-BE49-F238E27FC236}">
-                <a16:creationId xmlns:a16="http://schemas.microsoft.com/office/drawing/2014/main" id="{EF219533-51E8-4A47-8F0C-EE10466854EA}"/>
+                <a16:creationId xmlns:a16="http://schemas.microsoft.com/office/drawing/2014/main" id="{576ECB7E-5F96-4464-B0CB-8053B529195F}"/>
               </a:ext>
             </a:extLst>
           </p:cNvPr>
@@ -1232,14 +1232,14 @@
             <a:pPr algn="l">
               <a:defRPr sz="2025" b="1">
                 <a:solidFill>
-                  <a:srgbClr val="F4F2EC"/>
+                  <a:srgbClr val="1C1D1F"/>
                 </a:solidFill>
               </a:defRPr>
             </a:pPr>
             <a:r>
               <a:rPr sz="2025" b="1">
                 <a:solidFill>
-                  <a:srgbClr val="F4F2EC"/>
+                  <a:srgbClr val="1C1D1F"/>
                 </a:solidFill>
               </a:rPr>
               <a:t>CodePrep commits a challenge and its quota update together</a:t>
@@ -1252,7 +1252,7 @@
           <p:cNvPr id="3" name="subtitle">
             <a:extLst xmlns:a="http://schemas.openxmlformats.org/drawingml/2006/main">
               <a:ext uri="{FF2B5EF4-FFF2-40B4-BE49-F238E27FC236}">
-                <a16:creationId xmlns:a16="http://schemas.microsoft.com/office/drawing/2014/main" id="{656CB842-D50F-4DBB-BE80-C77CD2CF4ECA}"/>
+                <a16:creationId xmlns:a16="http://schemas.microsoft.com/office/drawing/2014/main" id="{EF3F5751-D532-43F0-836A-B8AD7702EF23}"/>
               </a:ext>
             </a:extLst>
           </p:cNvPr>
@@ -1282,14 +1282,14 @@
             <a:pPr algn="l">
               <a:defRPr sz="960" b="0">
                 <a:solidFill>
-                  <a:srgbClr val="AEB4BF"/>
+                  <a:srgbClr val="6C6E73"/>
                 </a:solidFill>
               </a:defRPr>
             </a:pPr>
             <a:r>
               <a:rPr sz="960" b="0">
                 <a:solidFill>
-                  <a:srgbClr val="AEB4BF"/>
+                  <a:srgbClr val="6C6E73"/>
                 </a:solidFill>
               </a:rPr>
               <a:t>The browser contract is shared; authentication, model inference, validation, and persistence exist only on the live path.</a:t>
@@ -1302,7 +1302,7 @@
           <p:cNvPr id="4" name="route">
             <a:extLst xmlns:a="http://schemas.openxmlformats.org/drawingml/2006/main">
               <a:ext uri="{FF2B5EF4-FFF2-40B4-BE49-F238E27FC236}">
-                <a16:creationId xmlns:a16="http://schemas.microsoft.com/office/drawing/2014/main" id="{8709A845-8E41-450F-A9B7-B48FFB8826B3}"/>
+                <a16:creationId xmlns:a16="http://schemas.microsoft.com/office/drawing/2014/main" id="{5FCED089-1ADF-4650-88BE-51FFB5EC4CFC}"/>
               </a:ext>
             </a:extLst>
           </p:cNvPr>
@@ -1332,14 +1332,14 @@
             <a:pPr algn="r">
               <a:defRPr sz="750" b="1">
                 <a:solidFill>
-                  <a:srgbClr val="A78BFA"/>
+                  <a:srgbClr val="C73D1D"/>
                 </a:solidFill>
               </a:defRPr>
             </a:pPr>
             <a:r>
               <a:rPr sz="750" b="1">
                 <a:solidFill>
-                  <a:srgbClr val="A78BFA"/>
+                  <a:srgbClr val="C73D1D"/>
                 </a:solidFill>
               </a:rPr>
               <a:t>POST /api/generate-challenge</a:t>
@@ -1352,7 +1352,7 @@
           <p:cNvPr id="5" name="demo-band">
             <a:extLst xmlns:a="http://schemas.openxmlformats.org/drawingml/2006/main">
               <a:ext uri="{FF2B5EF4-FFF2-40B4-BE49-F238E27FC236}">
-                <a16:creationId xmlns:a16="http://schemas.microsoft.com/office/drawing/2014/main" id="{2A36E771-10D1-435F-9B3E-0E921D4D87B7}"/>
+                <a16:creationId xmlns:a16="http://schemas.microsoft.com/office/drawing/2014/main" id="{1268E068-C8E5-439C-AAE4-01CAC8DF55B1}"/>
               </a:ext>
             </a:extLst>
           </p:cNvPr>
@@ -1370,11 +1370,11 @@
             <a:avLst/>
           </a:prstGeom>
           <a:solidFill xmlns:a="http://schemas.openxmlformats.org/drawingml/2006/main">
-            <a:srgbClr val="1B2026"/>
+            <a:srgbClr val="F0F0EC"/>
           </a:solidFill>
           <a:ln xmlns:a="http://schemas.openxmlformats.org/drawingml/2006/main" w="7620">
             <a:solidFill>
-              <a:srgbClr val="5A606B"/>
+              <a:srgbClr val="D5D6D2"/>
             </a:solidFill>
             <a:prstDash val="solid"/>
           </a:ln>
@@ -1385,7 +1385,7 @@
           <p:cNvPr id="6" name="live-band">
             <a:extLst xmlns:a="http://schemas.openxmlformats.org/drawingml/2006/main">
               <a:ext uri="{FF2B5EF4-FFF2-40B4-BE49-F238E27FC236}">
-                <a16:creationId xmlns:a16="http://schemas.microsoft.com/office/drawing/2014/main" id="{A1E68149-B5F9-45DB-A794-70B3C55F0F21}"/>
+                <a16:creationId xmlns:a16="http://schemas.microsoft.com/office/drawing/2014/main" id="{B5EA34C3-A8AB-4454-857B-590F20941932}"/>
               </a:ext>
             </a:extLst>
           </p:cNvPr>
@@ -1403,11 +1403,11 @@
             <a:avLst/>
           </a:prstGeom>
           <a:solidFill xmlns:a="http://schemas.openxmlformats.org/drawingml/2006/main">
-            <a:srgbClr val="191A20"/>
+            <a:srgbClr val="FFFFFF"/>
           </a:solidFill>
           <a:ln xmlns:a="http://schemas.openxmlformats.org/drawingml/2006/main" w="10478">
             <a:solidFill>
-              <a:srgbClr val="A78BFA"/>
+              <a:srgbClr val="C73D1D"/>
             </a:solidFill>
             <a:prstDash val="solid"/>
           </a:ln>
@@ -1418,7 +1418,7 @@
           <p:cNvPr id="7" name="demo-band-label">
             <a:extLst xmlns:a="http://schemas.openxmlformats.org/drawingml/2006/main">
               <a:ext uri="{FF2B5EF4-FFF2-40B4-BE49-F238E27FC236}">
-                <a16:creationId xmlns:a16="http://schemas.microsoft.com/office/drawing/2014/main" id="{5441D10F-82EA-4964-AEC1-1E1B454E55BA}"/>
+                <a16:creationId xmlns:a16="http://schemas.microsoft.com/office/drawing/2014/main" id="{B4DC5970-E339-4440-9014-C39608F7959F}"/>
               </a:ext>
             </a:extLst>
           </p:cNvPr>
@@ -1448,14 +1448,14 @@
             <a:pPr algn="l">
               <a:defRPr sz="788" b="1">
                 <a:solidFill>
-                  <a:srgbClr val="5EEAD4"/>
+                  <a:srgbClr val="1C1D1F"/>
                 </a:solidFill>
               </a:defRPr>
             </a:pPr>
             <a:r>
               <a:rPr sz="788" b="1">
                 <a:solidFill>
-                  <a:srgbClr val="5EEAD4"/>
+                  <a:srgbClr val="1C1D1F"/>
                 </a:solidFill>
               </a:rPr>
               <a:t>ALT · DEMO</a:t>
@@ -1468,7 +1468,7 @@
           <p:cNvPr id="8" name="demo-band-note">
             <a:extLst xmlns:a="http://schemas.openxmlformats.org/drawingml/2006/main">
               <a:ext uri="{FF2B5EF4-FFF2-40B4-BE49-F238E27FC236}">
-                <a16:creationId xmlns:a16="http://schemas.microsoft.com/office/drawing/2014/main" id="{5A6CFFB9-E86A-4C24-90AC-BAFD0D7C5296}"/>
+                <a16:creationId xmlns:a16="http://schemas.microsoft.com/office/drawing/2014/main" id="{B4B23C2B-2B4A-4750-B9C7-DF185849CA4A}"/>
               </a:ext>
             </a:extLst>
           </p:cNvPr>
@@ -1498,14 +1498,14 @@
             <a:pPr algn="r">
               <a:defRPr sz="713" b="0">
                 <a:solidFill>
-                  <a:srgbClr val="AEB4BF"/>
+                  <a:srgbClr val="6C6E73"/>
                 </a:solidFill>
               </a:defRPr>
             </a:pPr>
             <a:r>
               <a:rPr sz="713" b="0">
                 <a:solidFill>
-                  <a:srgbClr val="AEB4BF"/>
+                  <a:srgbClr val="6C6E73"/>
                 </a:solidFill>
               </a:rPr>
               <a:t>local response · no auth · no model · no database</a:t>
@@ -1518,7 +1518,7 @@
           <p:cNvPr id="9" name="live-band-label">
             <a:extLst xmlns:a="http://schemas.openxmlformats.org/drawingml/2006/main">
               <a:ext uri="{FF2B5EF4-FFF2-40B4-BE49-F238E27FC236}">
-                <a16:creationId xmlns:a16="http://schemas.microsoft.com/office/drawing/2014/main" id="{E3C2E7FA-18AC-48AE-9919-EDCFA47D20CC}"/>
+                <a16:creationId xmlns:a16="http://schemas.microsoft.com/office/drawing/2014/main" id="{529F2225-E782-4296-8504-FB45EC66E850}"/>
               </a:ext>
             </a:extLst>
           </p:cNvPr>
@@ -1548,14 +1548,14 @@
             <a:pPr algn="l">
               <a:defRPr sz="788" b="1">
                 <a:solidFill>
-                  <a:srgbClr val="A78BFA"/>
+                  <a:srgbClr val="1C1D1F"/>
                 </a:solidFill>
               </a:defRPr>
             </a:pPr>
             <a:r>
               <a:rPr sz="788" b="1">
                 <a:solidFill>
-                  <a:srgbClr val="A78BFA"/>
+                  <a:srgbClr val="1C1D1F"/>
                 </a:solidFill>
               </a:rPr>
               <a:t>ALT · LIVE</a:t>
@@ -1568,7 +1568,7 @@
           <p:cNvPr id="10" name="browser-head">
             <a:extLst xmlns:a="http://schemas.openxmlformats.org/drawingml/2006/main">
               <a:ext uri="{FF2B5EF4-FFF2-40B4-BE49-F238E27FC236}">
-                <a16:creationId xmlns:a16="http://schemas.microsoft.com/office/drawing/2014/main" id="{625E5708-F79D-4040-8913-457C9F2F1B85}"/>
+                <a16:creationId xmlns:a16="http://schemas.microsoft.com/office/drawing/2014/main" id="{7D6E96F7-EF61-4B87-A62A-316D01603E93}"/>
               </a:ext>
             </a:extLst>
           </p:cNvPr>
@@ -1588,11 +1588,11 @@
             </a:avLst>
           </a:prstGeom>
           <a:solidFill xmlns:a="http://schemas.openxmlformats.org/drawingml/2006/main">
-            <a:srgbClr val="1F2228"/>
+            <a:srgbClr val="FAFAF8"/>
           </a:solidFill>
           <a:ln xmlns:a="http://schemas.openxmlformats.org/drawingml/2006/main" w="13335">
             <a:solidFill>
-              <a:srgbClr val="FF8A45"/>
+              <a:srgbClr val="C73D1D"/>
             </a:solidFill>
             <a:prstDash val="solid"/>
           </a:ln>
@@ -1603,7 +1603,7 @@
           <p:cNvPr id="11" name="browser-label">
             <a:extLst xmlns:a="http://schemas.openxmlformats.org/drawingml/2006/main">
               <a:ext uri="{FF2B5EF4-FFF2-40B4-BE49-F238E27FC236}">
-                <a16:creationId xmlns:a16="http://schemas.microsoft.com/office/drawing/2014/main" id="{0FC672E4-A47D-4A24-B89E-F4FE03ABC4E9}"/>
+                <a16:creationId xmlns:a16="http://schemas.microsoft.com/office/drawing/2014/main" id="{A7D71CB9-FFB8-4023-92A8-58C596B1BF8D}"/>
               </a:ext>
             </a:extLst>
           </p:cNvPr>
@@ -1633,14 +1633,14 @@
             <a:pPr algn="ctr">
               <a:defRPr sz="938" b="1">
                 <a:solidFill>
-                  <a:srgbClr val="FF8A45"/>
+                  <a:srgbClr val="C73D1D"/>
                 </a:solidFill>
               </a:defRPr>
             </a:pPr>
             <a:r>
               <a:rPr sz="938" b="1">
                 <a:solidFill>
-                  <a:srgbClr val="FF8A45"/>
+                  <a:srgbClr val="C73D1D"/>
                 </a:solidFill>
               </a:rPr>
               <a:t>Browser</a:t>
@@ -1653,7 +1653,7 @@
           <p:cNvPr id="12" name="browser-sub">
             <a:extLst xmlns:a="http://schemas.openxmlformats.org/drawingml/2006/main">
               <a:ext uri="{FF2B5EF4-FFF2-40B4-BE49-F238E27FC236}">
-                <a16:creationId xmlns:a16="http://schemas.microsoft.com/office/drawing/2014/main" id="{3AFEF690-6858-48D2-B6E5-EB34E1440A6B}"/>
+                <a16:creationId xmlns:a16="http://schemas.microsoft.com/office/drawing/2014/main" id="{A1D672EA-8EDD-486F-AC3E-380E77D2533B}"/>
               </a:ext>
             </a:extLst>
           </p:cNvPr>
@@ -1683,14 +1683,14 @@
             <a:pPr algn="ctr">
               <a:defRPr sz="660" b="0">
                 <a:solidFill>
-                  <a:srgbClr val="AEB4BF"/>
+                  <a:srgbClr val="6C6E73"/>
                 </a:solidFill>
               </a:defRPr>
             </a:pPr>
             <a:r>
               <a:rPr sz="660" b="0">
                 <a:solidFill>
-                  <a:srgbClr val="AEB4BF"/>
+                  <a:srgbClr val="6C6E73"/>
                 </a:solidFill>
               </a:rPr>
               <a:t>React workspace</a:t>
@@ -1703,7 +1703,7 @@
           <p:cNvPr id="13" name="browser-lifeline">
             <a:extLst xmlns:a="http://schemas.openxmlformats.org/drawingml/2006/main">
               <a:ext uri="{FF2B5EF4-FFF2-40B4-BE49-F238E27FC236}">
-                <a16:creationId xmlns:a16="http://schemas.microsoft.com/office/drawing/2014/main" id="{4AB123ED-7031-4B8E-B31C-8A2B4E59D7C8}"/>
+                <a16:creationId xmlns:a16="http://schemas.microsoft.com/office/drawing/2014/main" id="{245B3A1F-4223-4F41-9A61-B4391852EC05}"/>
               </a:ext>
             </a:extLst>
           </p:cNvPr>
@@ -1723,7 +1723,7 @@
           <a:noFill xmlns:a="http://schemas.openxmlformats.org/drawingml/2006/main"/>
           <a:ln xmlns:a="http://schemas.openxmlformats.org/drawingml/2006/main" w="10478">
             <a:solidFill>
-              <a:srgbClr val="FF8A45"/>
+              <a:srgbClr val="C73D1D"/>
             </a:solidFill>
             <a:prstDash val="dash"/>
           </a:ln>
@@ -1734,7 +1734,7 @@
           <p:cNvPr id="14" name="adapter-head">
             <a:extLst xmlns:a="http://schemas.openxmlformats.org/drawingml/2006/main">
               <a:ext uri="{FF2B5EF4-FFF2-40B4-BE49-F238E27FC236}">
-                <a16:creationId xmlns:a16="http://schemas.microsoft.com/office/drawing/2014/main" id="{52FAA1E0-831A-45B0-AE17-F238027D52CC}"/>
+                <a16:creationId xmlns:a16="http://schemas.microsoft.com/office/drawing/2014/main" id="{6C597C91-E8DF-4904-974C-A19BD3ABCA64}"/>
               </a:ext>
             </a:extLst>
           </p:cNvPr>
@@ -1754,11 +1754,11 @@
             </a:avLst>
           </a:prstGeom>
           <a:solidFill xmlns:a="http://schemas.openxmlformats.org/drawingml/2006/main">
-            <a:srgbClr val="1F2228"/>
+            <a:srgbClr val="FAFAF8"/>
           </a:solidFill>
           <a:ln xmlns:a="http://schemas.openxmlformats.org/drawingml/2006/main" w="13335">
             <a:solidFill>
-              <a:srgbClr val="FF8A45"/>
+              <a:srgbClr val="C73D1D"/>
             </a:solidFill>
             <a:prstDash val="solid"/>
           </a:ln>
@@ -1769,7 +1769,7 @@
           <p:cNvPr id="15" name="adapter-label">
             <a:extLst xmlns:a="http://schemas.openxmlformats.org/drawingml/2006/main">
               <a:ext uri="{FF2B5EF4-FFF2-40B4-BE49-F238E27FC236}">
-                <a16:creationId xmlns:a16="http://schemas.microsoft.com/office/drawing/2014/main" id="{5A74995F-CF4B-4743-910C-851685F40DC0}"/>
+                <a16:creationId xmlns:a16="http://schemas.microsoft.com/office/drawing/2014/main" id="{2EC8F1C6-D41D-4974-AF8D-4B77AE5EF623}"/>
               </a:ext>
             </a:extLst>
           </p:cNvPr>
@@ -1799,14 +1799,14 @@
             <a:pPr algn="ctr">
               <a:defRPr sz="938" b="1">
                 <a:solidFill>
-                  <a:srgbClr val="FF8A45"/>
+                  <a:srgbClr val="C73D1D"/>
                 </a:solidFill>
               </a:defRPr>
             </a:pPr>
             <a:r>
               <a:rPr sz="938" b="1">
                 <a:solidFill>
-                  <a:srgbClr val="FF8A45"/>
+                  <a:srgbClr val="C73D1D"/>
                 </a:solidFill>
               </a:rPr>
               <a:t>API adapter</a:t>
@@ -1819,7 +1819,7 @@
           <p:cNvPr id="16" name="adapter-sub">
             <a:extLst xmlns:a="http://schemas.openxmlformats.org/drawingml/2006/main">
               <a:ext uri="{FF2B5EF4-FFF2-40B4-BE49-F238E27FC236}">
-                <a16:creationId xmlns:a16="http://schemas.microsoft.com/office/drawing/2014/main" id="{064789ED-1CE2-4FCA-82A1-3505C545A70B}"/>
+                <a16:creationId xmlns:a16="http://schemas.microsoft.com/office/drawing/2014/main" id="{8F08DE44-747E-47FA-B713-F5A31C3B4A6F}"/>
               </a:ext>
             </a:extLst>
           </p:cNvPr>
@@ -1849,14 +1849,14 @@
             <a:pPr algn="ctr">
               <a:defRPr sz="660" b="0">
                 <a:solidFill>
-                  <a:srgbClr val="AEB4BF"/>
+                  <a:srgbClr val="6C6E73"/>
                 </a:solidFill>
               </a:defRPr>
             </a:pPr>
             <a:r>
               <a:rPr sz="660" b="0">
                 <a:solidFill>
-                  <a:srgbClr val="AEB4BF"/>
+                  <a:srgbClr val="6C6E73"/>
                 </a:solidFill>
               </a:rPr>
               <a:t>demo or live</a:t>
@@ -1869,7 +1869,7 @@
           <p:cNvPr id="17" name="adapter-lifeline">
             <a:extLst xmlns:a="http://schemas.openxmlformats.org/drawingml/2006/main">
               <a:ext uri="{FF2B5EF4-FFF2-40B4-BE49-F238E27FC236}">
-                <a16:creationId xmlns:a16="http://schemas.microsoft.com/office/drawing/2014/main" id="{7403CD98-0F66-43F0-AF3E-38B99A528C0D}"/>
+                <a16:creationId xmlns:a16="http://schemas.microsoft.com/office/drawing/2014/main" id="{B3952BB8-54E0-4C9A-BAA5-A42737282956}"/>
               </a:ext>
             </a:extLst>
           </p:cNvPr>
@@ -1889,7 +1889,7 @@
           <a:noFill xmlns:a="http://schemas.openxmlformats.org/drawingml/2006/main"/>
           <a:ln xmlns:a="http://schemas.openxmlformats.org/drawingml/2006/main" w="10478">
             <a:solidFill>
-              <a:srgbClr val="FF8A45"/>
+              <a:srgbClr val="C73D1D"/>
             </a:solidFill>
             <a:prstDash val="dash"/>
           </a:ln>
@@ -1900,7 +1900,7 @@
           <p:cNvPr id="18" name="clerk-head">
             <a:extLst xmlns:a="http://schemas.openxmlformats.org/drawingml/2006/main">
               <a:ext uri="{FF2B5EF4-FFF2-40B4-BE49-F238E27FC236}">
-                <a16:creationId xmlns:a16="http://schemas.microsoft.com/office/drawing/2014/main" id="{A55496AF-2A86-4898-B331-8032CE4D5E38}"/>
+                <a16:creationId xmlns:a16="http://schemas.microsoft.com/office/drawing/2014/main" id="{D1B5CE4A-BF93-4788-BC0E-FBA3223FC6A6}"/>
               </a:ext>
             </a:extLst>
           </p:cNvPr>
@@ -1920,11 +1920,11 @@
             </a:avLst>
           </a:prstGeom>
           <a:solidFill xmlns:a="http://schemas.openxmlformats.org/drawingml/2006/main">
-            <a:srgbClr val="1F2228"/>
+            <a:srgbClr val="FAFAF8"/>
           </a:solidFill>
           <a:ln xmlns:a="http://schemas.openxmlformats.org/drawingml/2006/main" w="13335">
             <a:solidFill>
-              <a:srgbClr val="5EEAD4"/>
+              <a:srgbClr val="1C1D1F"/>
             </a:solidFill>
             <a:prstDash val="solid"/>
           </a:ln>
@@ -1935,7 +1935,7 @@
           <p:cNvPr id="19" name="clerk-label">
             <a:extLst xmlns:a="http://schemas.openxmlformats.org/drawingml/2006/main">
               <a:ext uri="{FF2B5EF4-FFF2-40B4-BE49-F238E27FC236}">
-                <a16:creationId xmlns:a16="http://schemas.microsoft.com/office/drawing/2014/main" id="{85BDD460-258C-4279-AEEF-EC02C0CD977D}"/>
+                <a16:creationId xmlns:a16="http://schemas.microsoft.com/office/drawing/2014/main" id="{EFD9AC26-CF42-4ED1-B432-86787ABB7EFC}"/>
               </a:ext>
             </a:extLst>
           </p:cNvPr>
@@ -1965,14 +1965,14 @@
             <a:pPr algn="ctr">
               <a:defRPr sz="938" b="1">
                 <a:solidFill>
-                  <a:srgbClr val="5EEAD4"/>
+                  <a:srgbClr val="1C1D1F"/>
                 </a:solidFill>
               </a:defRPr>
             </a:pPr>
             <a:r>
               <a:rPr sz="938" b="1">
                 <a:solidFill>
-                  <a:srgbClr val="5EEAD4"/>
+                  <a:srgbClr val="1C1D1F"/>
                 </a:solidFill>
               </a:rPr>
               <a:t>Clerk</a:t>
@@ -1985,7 +1985,7 @@
           <p:cNvPr id="20" name="clerk-sub">
             <a:extLst xmlns:a="http://schemas.openxmlformats.org/drawingml/2006/main">
               <a:ext uri="{FF2B5EF4-FFF2-40B4-BE49-F238E27FC236}">
-                <a16:creationId xmlns:a16="http://schemas.microsoft.com/office/drawing/2014/main" id="{F6CAE714-133B-4C52-A47A-2370AC3E3B9B}"/>
+                <a16:creationId xmlns:a16="http://schemas.microsoft.com/office/drawing/2014/main" id="{E7516157-6413-409B-B03C-522989E62BB2}"/>
               </a:ext>
             </a:extLst>
           </p:cNvPr>
@@ -2015,14 +2015,14 @@
             <a:pPr algn="ctr">
               <a:defRPr sz="660" b="0">
                 <a:solidFill>
-                  <a:srgbClr val="AEB4BF"/>
+                  <a:srgbClr val="6C6E73"/>
                 </a:solidFill>
               </a:defRPr>
             </a:pPr>
             <a:r>
               <a:rPr sz="660" b="0">
                 <a:solidFill>
-                  <a:srgbClr val="AEB4BF"/>
+                  <a:srgbClr val="6C6E73"/>
                 </a:solidFill>
               </a:rPr>
               <a:t>session + webhook</a:t>
@@ -2035,7 +2035,7 @@
           <p:cNvPr id="21" name="clerk-lifeline">
             <a:extLst xmlns:a="http://schemas.openxmlformats.org/drawingml/2006/main">
               <a:ext uri="{FF2B5EF4-FFF2-40B4-BE49-F238E27FC236}">
-                <a16:creationId xmlns:a16="http://schemas.microsoft.com/office/drawing/2014/main" id="{5C0745CA-F72C-42E2-A6B3-51407D7642E1}"/>
+                <a16:creationId xmlns:a16="http://schemas.microsoft.com/office/drawing/2014/main" id="{A8849EBA-DFA4-4EAD-9A78-0F5C8DB72FE7}"/>
               </a:ext>
             </a:extLst>
           </p:cNvPr>
@@ -2055,7 +2055,7 @@
           <a:noFill xmlns:a="http://schemas.openxmlformats.org/drawingml/2006/main"/>
           <a:ln xmlns:a="http://schemas.openxmlformats.org/drawingml/2006/main" w="10478">
             <a:solidFill>
-              <a:srgbClr val="5EEAD4"/>
+              <a:srgbClr val="1C1D1F"/>
             </a:solidFill>
             <a:prstDash val="dash"/>
           </a:ln>
@@ -2066,7 +2066,7 @@
           <p:cNvPr id="22" name="api-head">
             <a:extLst xmlns:a="http://schemas.openxmlformats.org/drawingml/2006/main">
               <a:ext uri="{FF2B5EF4-FFF2-40B4-BE49-F238E27FC236}">
-                <a16:creationId xmlns:a16="http://schemas.microsoft.com/office/drawing/2014/main" id="{CDBEE372-98F2-4292-A1AA-23A91172E313}"/>
+                <a16:creationId xmlns:a16="http://schemas.microsoft.com/office/drawing/2014/main" id="{67B11E72-061A-4A97-B76A-41CD445938AE}"/>
               </a:ext>
             </a:extLst>
           </p:cNvPr>
@@ -2086,11 +2086,11 @@
             </a:avLst>
           </a:prstGeom>
           <a:solidFill xmlns:a="http://schemas.openxmlformats.org/drawingml/2006/main">
-            <a:srgbClr val="1F2228"/>
+            <a:srgbClr val="FAFAF8"/>
           </a:solidFill>
           <a:ln xmlns:a="http://schemas.openxmlformats.org/drawingml/2006/main" w="13335">
             <a:solidFill>
-              <a:srgbClr val="A78BFA"/>
+              <a:srgbClr val="1C1D1F"/>
             </a:solidFill>
             <a:prstDash val="solid"/>
           </a:ln>
@@ -2101,7 +2101,7 @@
           <p:cNvPr id="23" name="api-label">
             <a:extLst xmlns:a="http://schemas.openxmlformats.org/drawingml/2006/main">
               <a:ext uri="{FF2B5EF4-FFF2-40B4-BE49-F238E27FC236}">
-                <a16:creationId xmlns:a16="http://schemas.microsoft.com/office/drawing/2014/main" id="{FB291847-52DD-494E-B7BA-80F49259A1B9}"/>
+                <a16:creationId xmlns:a16="http://schemas.microsoft.com/office/drawing/2014/main" id="{0533C709-B5EE-4EE2-B824-33A404673186}"/>
               </a:ext>
             </a:extLst>
           </p:cNvPr>
@@ -2131,14 +2131,14 @@
             <a:pPr algn="ctr">
               <a:defRPr sz="938" b="1">
                 <a:solidFill>
-                  <a:srgbClr val="A78BFA"/>
+                  <a:srgbClr val="1C1D1F"/>
                 </a:solidFill>
               </a:defRPr>
             </a:pPr>
             <a:r>
               <a:rPr sz="938" b="1">
                 <a:solidFill>
-                  <a:srgbClr val="A78BFA"/>
+                  <a:srgbClr val="1C1D1F"/>
                 </a:solidFill>
               </a:rPr>
               <a:t>FastAPI</a:t>
@@ -2151,7 +2151,7 @@
           <p:cNvPr id="24" name="api-sub">
             <a:extLst xmlns:a="http://schemas.openxmlformats.org/drawingml/2006/main">
               <a:ext uri="{FF2B5EF4-FFF2-40B4-BE49-F238E27FC236}">
-                <a16:creationId xmlns:a16="http://schemas.microsoft.com/office/drawing/2014/main" id="{7C80D43D-5785-455D-B983-31AB452B9C39}"/>
+                <a16:creationId xmlns:a16="http://schemas.microsoft.com/office/drawing/2014/main" id="{D952DB38-5C12-45D3-AB72-7512552F289F}"/>
               </a:ext>
             </a:extLst>
           </p:cNvPr>
@@ -2181,14 +2181,14 @@
             <a:pPr algn="ctr">
               <a:defRPr sz="660" b="0">
                 <a:solidFill>
-                  <a:srgbClr val="AEB4BF"/>
+                  <a:srgbClr val="6C6E73"/>
                 </a:solidFill>
               </a:defRPr>
             </a:pPr>
             <a:r>
               <a:rPr sz="660" b="0">
                 <a:solidFill>
-                  <a:srgbClr val="AEB4BF"/>
+                  <a:srgbClr val="6C6E73"/>
                 </a:solidFill>
               </a:rPr>
               <a:t>auth + quota + route</a:t>
@@ -2201,7 +2201,7 @@
           <p:cNvPr id="25" name="api-lifeline">
             <a:extLst xmlns:a="http://schemas.openxmlformats.org/drawingml/2006/main">
               <a:ext uri="{FF2B5EF4-FFF2-40B4-BE49-F238E27FC236}">
-                <a16:creationId xmlns:a16="http://schemas.microsoft.com/office/drawing/2014/main" id="{62DC526C-328F-4E68-BE5B-ABD451C322EB}"/>
+                <a16:creationId xmlns:a16="http://schemas.microsoft.com/office/drawing/2014/main" id="{89AA5954-7440-4E78-8426-973CB0F6CC68}"/>
               </a:ext>
             </a:extLst>
           </p:cNvPr>
@@ -2221,7 +2221,7 @@
           <a:noFill xmlns:a="http://schemas.openxmlformats.org/drawingml/2006/main"/>
           <a:ln xmlns:a="http://schemas.openxmlformats.org/drawingml/2006/main" w="10478">
             <a:solidFill>
-              <a:srgbClr val="A78BFA"/>
+              <a:srgbClr val="1C1D1F"/>
             </a:solidFill>
             <a:prstDash val="dash"/>
           </a:ln>
@@ -2232,7 +2232,7 @@
           <p:cNvPr id="26" name="hf-head">
             <a:extLst xmlns:a="http://schemas.openxmlformats.org/drawingml/2006/main">
               <a:ext uri="{FF2B5EF4-FFF2-40B4-BE49-F238E27FC236}">
-                <a16:creationId xmlns:a16="http://schemas.microsoft.com/office/drawing/2014/main" id="{EBAE26C4-DE31-4204-986B-CFF4C8F717C0}"/>
+                <a16:creationId xmlns:a16="http://schemas.microsoft.com/office/drawing/2014/main" id="{DBD23998-E49B-429A-8F6B-CB4E04AD26C0}"/>
               </a:ext>
             </a:extLst>
           </p:cNvPr>
@@ -2252,11 +2252,11 @@
             </a:avLst>
           </a:prstGeom>
           <a:solidFill xmlns:a="http://schemas.openxmlformats.org/drawingml/2006/main">
-            <a:srgbClr val="1F2228"/>
+            <a:srgbClr val="FAFAF8"/>
           </a:solidFill>
           <a:ln xmlns:a="http://schemas.openxmlformats.org/drawingml/2006/main" w="13335">
             <a:solidFill>
-              <a:srgbClr val="A78BFA"/>
+              <a:srgbClr val="1C1D1F"/>
             </a:solidFill>
             <a:prstDash val="solid"/>
           </a:ln>
@@ -2267,7 +2267,7 @@
           <p:cNvPr id="27" name="hf-label">
             <a:extLst xmlns:a="http://schemas.openxmlformats.org/drawingml/2006/main">
               <a:ext uri="{FF2B5EF4-FFF2-40B4-BE49-F238E27FC236}">
-                <a16:creationId xmlns:a16="http://schemas.microsoft.com/office/drawing/2014/main" id="{B89B7079-799A-4D0D-A59C-9E9303A3BB7F}"/>
+                <a16:creationId xmlns:a16="http://schemas.microsoft.com/office/drawing/2014/main" id="{5651D9E2-E357-4849-8F8A-BF303D7857C3}"/>
               </a:ext>
             </a:extLst>
           </p:cNvPr>
@@ -2297,14 +2297,14 @@
             <a:pPr algn="ctr">
               <a:defRPr sz="938" b="1">
                 <a:solidFill>
-                  <a:srgbClr val="A78BFA"/>
+                  <a:srgbClr val="1C1D1F"/>
                 </a:solidFill>
               </a:defRPr>
             </a:pPr>
             <a:r>
               <a:rPr sz="938" b="1">
                 <a:solidFill>
-                  <a:srgbClr val="A78BFA"/>
+                  <a:srgbClr val="1C1D1F"/>
                 </a:solidFill>
               </a:rPr>
               <a:t>HF inference</a:t>
@@ -2317,7 +2317,7 @@
           <p:cNvPr id="28" name="hf-sub">
             <a:extLst xmlns:a="http://schemas.openxmlformats.org/drawingml/2006/main">
               <a:ext uri="{FF2B5EF4-FFF2-40B4-BE49-F238E27FC236}">
-                <a16:creationId xmlns:a16="http://schemas.microsoft.com/office/drawing/2014/main" id="{104BEADC-CB80-4AB3-816A-0CA09D7B1EF9}"/>
+                <a16:creationId xmlns:a16="http://schemas.microsoft.com/office/drawing/2014/main" id="{6D8761A6-F839-40A3-8E3D-7D1CFB80DC49}"/>
               </a:ext>
             </a:extLst>
           </p:cNvPr>
@@ -2347,14 +2347,14 @@
             <a:pPr algn="ctr">
               <a:defRPr sz="660" b="0">
                 <a:solidFill>
-                  <a:srgbClr val="AEB4BF"/>
+                  <a:srgbClr val="6C6E73"/>
                 </a:solidFill>
               </a:defRPr>
             </a:pPr>
             <a:r>
               <a:rPr sz="660" b="0">
                 <a:solidFill>
-                  <a:srgbClr val="AEB4BF"/>
+                  <a:srgbClr val="6C6E73"/>
                 </a:solidFill>
               </a:rPr>
               <a:t>JSON candidate</a:t>
@@ -2367,7 +2367,7 @@
           <p:cNvPr id="29" name="hf-lifeline">
             <a:extLst xmlns:a="http://schemas.openxmlformats.org/drawingml/2006/main">
               <a:ext uri="{FF2B5EF4-FFF2-40B4-BE49-F238E27FC236}">
-                <a16:creationId xmlns:a16="http://schemas.microsoft.com/office/drawing/2014/main" id="{3041C898-2F8D-40B7-AC5C-65B65F4BFA0D}"/>
+                <a16:creationId xmlns:a16="http://schemas.microsoft.com/office/drawing/2014/main" id="{EC435382-7992-4F95-B3E0-A47EE9E8534B}"/>
               </a:ext>
             </a:extLst>
           </p:cNvPr>
@@ -2387,7 +2387,7 @@
           <a:noFill xmlns:a="http://schemas.openxmlformats.org/drawingml/2006/main"/>
           <a:ln xmlns:a="http://schemas.openxmlformats.org/drawingml/2006/main" w="10478">
             <a:solidFill>
-              <a:srgbClr val="A78BFA"/>
+              <a:srgbClr val="1C1D1F"/>
             </a:solidFill>
             <a:prstDash val="dash"/>
           </a:ln>
@@ -2398,7 +2398,7 @@
           <p:cNvPr id="30" name="db-head">
             <a:extLst xmlns:a="http://schemas.openxmlformats.org/drawingml/2006/main">
               <a:ext uri="{FF2B5EF4-FFF2-40B4-BE49-F238E27FC236}">
-                <a16:creationId xmlns:a16="http://schemas.microsoft.com/office/drawing/2014/main" id="{9BB7D1ED-562C-4F2E-93F4-1D98EB22236F}"/>
+                <a16:creationId xmlns:a16="http://schemas.microsoft.com/office/drawing/2014/main" id="{D02F88B7-0CE7-4FFB-A3CB-B9FF707373D9}"/>
               </a:ext>
             </a:extLst>
           </p:cNvPr>
@@ -2418,11 +2418,11 @@
             </a:avLst>
           </a:prstGeom>
           <a:solidFill xmlns:a="http://schemas.openxmlformats.org/drawingml/2006/main">
-            <a:srgbClr val="1F2228"/>
+            <a:srgbClr val="FAFAF8"/>
           </a:solidFill>
           <a:ln xmlns:a="http://schemas.openxmlformats.org/drawingml/2006/main" w="13335">
             <a:solidFill>
-              <a:srgbClr val="A3E635"/>
+              <a:srgbClr val="2F7D3E"/>
             </a:solidFill>
             <a:prstDash val="solid"/>
           </a:ln>
@@ -2433,7 +2433,7 @@
           <p:cNvPr id="31" name="db-label">
             <a:extLst xmlns:a="http://schemas.openxmlformats.org/drawingml/2006/main">
               <a:ext uri="{FF2B5EF4-FFF2-40B4-BE49-F238E27FC236}">
-                <a16:creationId xmlns:a16="http://schemas.microsoft.com/office/drawing/2014/main" id="{AFD78A4F-78DB-488D-AEBD-A15377D304BE}"/>
+                <a16:creationId xmlns:a16="http://schemas.microsoft.com/office/drawing/2014/main" id="{2D39E154-680F-4BB0-A76B-FFF3BC935B87}"/>
               </a:ext>
             </a:extLst>
           </p:cNvPr>
@@ -2463,14 +2463,14 @@
             <a:pPr algn="ctr">
               <a:defRPr sz="938" b="1">
                 <a:solidFill>
-                  <a:srgbClr val="A3E635"/>
+                  <a:srgbClr val="2F7D3E"/>
                 </a:solidFill>
               </a:defRPr>
             </a:pPr>
             <a:r>
               <a:rPr sz="938" b="1">
                 <a:solidFill>
-                  <a:srgbClr val="A3E635"/>
+                  <a:srgbClr val="2F7D3E"/>
                 </a:solidFill>
               </a:rPr>
               <a:t>SQL database</a:t>
@@ -2483,7 +2483,7 @@
           <p:cNvPr id="32" name="db-sub">
             <a:extLst xmlns:a="http://schemas.openxmlformats.org/drawingml/2006/main">
               <a:ext uri="{FF2B5EF4-FFF2-40B4-BE49-F238E27FC236}">
-                <a16:creationId xmlns:a16="http://schemas.microsoft.com/office/drawing/2014/main" id="{3609A468-DB27-4A47-BE8F-A26BE5881462}"/>
+                <a16:creationId xmlns:a16="http://schemas.microsoft.com/office/drawing/2014/main" id="{0BCCD448-48F6-4EF9-A0E6-03015E1EA830}"/>
               </a:ext>
             </a:extLst>
           </p:cNvPr>
@@ -2513,14 +2513,14 @@
             <a:pPr algn="ctr">
               <a:defRPr sz="660" b="0">
                 <a:solidFill>
-                  <a:srgbClr val="AEB4BF"/>
+                  <a:srgbClr val="6C6E73"/>
                 </a:solidFill>
               </a:defRPr>
             </a:pPr>
             <a:r>
               <a:rPr sz="660" b="0">
                 <a:solidFill>
-                  <a:srgbClr val="AEB4BF"/>
+                  <a:srgbClr val="6C6E73"/>
                 </a:solidFill>
               </a:rPr>
               <a:t>challenges + quotas</a:t>
@@ -2533,7 +2533,7 @@
           <p:cNvPr id="33" name="db-lifeline">
             <a:extLst xmlns:a="http://schemas.openxmlformats.org/drawingml/2006/main">
               <a:ext uri="{FF2B5EF4-FFF2-40B4-BE49-F238E27FC236}">
-                <a16:creationId xmlns:a16="http://schemas.microsoft.com/office/drawing/2014/main" id="{C67F5268-8CCC-4B95-8456-213730377848}"/>
+                <a16:creationId xmlns:a16="http://schemas.microsoft.com/office/drawing/2014/main" id="{BD798013-80E5-4BE3-AB88-19B4EBAEA343}"/>
               </a:ext>
             </a:extLst>
           </p:cNvPr>
@@ -2553,7 +2553,7 @@
           <a:noFill xmlns:a="http://schemas.openxmlformats.org/drawingml/2006/main"/>
           <a:ln xmlns:a="http://schemas.openxmlformats.org/drawingml/2006/main" w="10478">
             <a:solidFill>
-              <a:srgbClr val="A3E635"/>
+              <a:srgbClr val="2F7D3E"/>
             </a:solidFill>
             <a:prstDash val="dash"/>
           </a:ln>
@@ -2564,7 +2564,7 @@
           <p:cNvPr id="34" name="demo-request-arrow">
             <a:extLst xmlns:a="http://schemas.openxmlformats.org/drawingml/2006/main">
               <a:ext uri="{FF2B5EF4-FFF2-40B4-BE49-F238E27FC236}">
-                <a16:creationId xmlns:a16="http://schemas.microsoft.com/office/drawing/2014/main" id="{B3396561-B480-4ACA-B561-A57BBA284EF8}"/>
+                <a16:creationId xmlns:a16="http://schemas.microsoft.com/office/drawing/2014/main" id="{C6C8F6C2-38FB-43BC-8CC5-1EE93FAD7575}"/>
               </a:ext>
             </a:extLst>
           </p:cNvPr>
@@ -2582,11 +2582,11 @@
             <a:avLst/>
           </a:prstGeom>
           <a:solidFill xmlns:a="http://schemas.openxmlformats.org/drawingml/2006/main">
-            <a:srgbClr val="FF8A45"/>
+            <a:srgbClr val="C73D1D"/>
           </a:solidFill>
           <a:ln xmlns:a="http://schemas.openxmlformats.org/drawingml/2006/main" w="0">
             <a:solidFill>
-              <a:srgbClr val="FF8A45"/>
+              <a:srgbClr val="C73D1D"/>
             </a:solidFill>
             <a:prstDash val="solid"/>
           </a:ln>
@@ -2597,7 +2597,7 @@
           <p:cNvPr id="35" name="demo-request-label">
             <a:extLst xmlns:a="http://schemas.openxmlformats.org/drawingml/2006/main">
               <a:ext uri="{FF2B5EF4-FFF2-40B4-BE49-F238E27FC236}">
-                <a16:creationId xmlns:a16="http://schemas.microsoft.com/office/drawing/2014/main" id="{A8C790B6-31C0-49BD-942A-BA8B7CD63B60}"/>
+                <a16:creationId xmlns:a16="http://schemas.microsoft.com/office/drawing/2014/main" id="{F0DD2804-8E68-4CC6-89D8-2AC2C537EC3C}"/>
               </a:ext>
             </a:extLst>
           </p:cNvPr>
@@ -2627,14 +2627,14 @@
             <a:pPr algn="ctr">
               <a:defRPr sz="788" b="1">
                 <a:solidFill>
-                  <a:srgbClr val="FF8A45"/>
+                  <a:srgbClr val="C73D1D"/>
                 </a:solidFill>
               </a:defRPr>
             </a:pPr>
             <a:r>
               <a:rPr sz="788" b="1">
                 <a:solidFill>
-                  <a:srgbClr val="FF8A45"/>
+                  <a:srgbClr val="C73D1D"/>
                 </a:solidFill>
               </a:rPr>
               <a:t>makeRequest()</a:t>
@@ -2647,7 +2647,7 @@
           <p:cNvPr id="36" name="demo-request-detail">
             <a:extLst xmlns:a="http://schemas.openxmlformats.org/drawingml/2006/main">
               <a:ext uri="{FF2B5EF4-FFF2-40B4-BE49-F238E27FC236}">
-                <a16:creationId xmlns:a16="http://schemas.microsoft.com/office/drawing/2014/main" id="{60FD3ED2-4100-49BD-9DF6-06E628EEF1E2}"/>
+                <a16:creationId xmlns:a16="http://schemas.microsoft.com/office/drawing/2014/main" id="{D08EFF7C-C148-4BCE-955F-09DF61171B37}"/>
               </a:ext>
             </a:extLst>
           </p:cNvPr>
@@ -2677,14 +2677,14 @@
             <a:pPr algn="ctr">
               <a:defRPr sz="660" b="0">
                 <a:solidFill>
-                  <a:srgbClr val="AEB4BF"/>
+                  <a:srgbClr val="6C6E73"/>
                 </a:solidFill>
               </a:defRPr>
             </a:pPr>
             <a:r>
               <a:rPr sz="660" b="0">
                 <a:solidFill>
-                  <a:srgbClr val="AEB4BF"/>
+                  <a:srgbClr val="6C6E73"/>
                 </a:solidFill>
               </a:rPr>
               <a:t>shared frontend contract</a:t>
@@ -2697,7 +2697,7 @@
           <p:cNvPr id="37" name="demo-response-arrow">
             <a:extLst xmlns:a="http://schemas.openxmlformats.org/drawingml/2006/main">
               <a:ext uri="{FF2B5EF4-FFF2-40B4-BE49-F238E27FC236}">
-                <a16:creationId xmlns:a16="http://schemas.microsoft.com/office/drawing/2014/main" id="{41BF2B99-8D87-430C-988B-F90D3056A968}"/>
+                <a16:creationId xmlns:a16="http://schemas.microsoft.com/office/drawing/2014/main" id="{1E85FA31-295D-4EFE-9B38-5DCE62D23581}"/>
               </a:ext>
             </a:extLst>
           </p:cNvPr>
@@ -2715,11 +2715,11 @@
             <a:avLst/>
           </a:prstGeom>
           <a:solidFill xmlns:a="http://schemas.openxmlformats.org/drawingml/2006/main">
-            <a:srgbClr val="5EEAD4"/>
+            <a:srgbClr val="2F7D3E"/>
           </a:solidFill>
           <a:ln xmlns:a="http://schemas.openxmlformats.org/drawingml/2006/main" w="0">
             <a:solidFill>
-              <a:srgbClr val="5EEAD4"/>
+              <a:srgbClr val="2F7D3E"/>
             </a:solidFill>
             <a:prstDash val="solid"/>
           </a:ln>
@@ -2730,7 +2730,7 @@
           <p:cNvPr id="38" name="demo-response-label">
             <a:extLst xmlns:a="http://schemas.openxmlformats.org/drawingml/2006/main">
               <a:ext uri="{FF2B5EF4-FFF2-40B4-BE49-F238E27FC236}">
-                <a16:creationId xmlns:a16="http://schemas.microsoft.com/office/drawing/2014/main" id="{7A8F702A-63D8-49C3-B046-7757F337E4D6}"/>
+                <a16:creationId xmlns:a16="http://schemas.microsoft.com/office/drawing/2014/main" id="{84D2A51C-1909-4BFF-A576-2235A01A3CE4}"/>
               </a:ext>
             </a:extLst>
           </p:cNvPr>
@@ -2760,14 +2760,14 @@
             <a:pPr algn="ctr">
               <a:defRPr sz="788" b="1">
                 <a:solidFill>
-                  <a:srgbClr val="5EEAD4"/>
+                  <a:srgbClr val="2F7D3E"/>
                 </a:solidFill>
               </a:defRPr>
             </a:pPr>
             <a:r>
               <a:rPr sz="788" b="1">
                 <a:solidFill>
-                  <a:srgbClr val="5EEAD4"/>
+                  <a:srgbClr val="2F7D3E"/>
                 </a:solidFill>
               </a:rPr>
               <a:t>deterministic Challenge</a:t>
@@ -2780,7 +2780,7 @@
           <p:cNvPr id="39" name="demo-response-detail">
             <a:extLst xmlns:a="http://schemas.openxmlformats.org/drawingml/2006/main">
               <a:ext uri="{FF2B5EF4-FFF2-40B4-BE49-F238E27FC236}">
-                <a16:creationId xmlns:a16="http://schemas.microsoft.com/office/drawing/2014/main" id="{2341807E-F59F-4700-92C2-CE3350E57045}"/>
+                <a16:creationId xmlns:a16="http://schemas.microsoft.com/office/drawing/2014/main" id="{1185D2CD-E648-4260-B8B2-111B035BB2EC}"/>
               </a:ext>
             </a:extLst>
           </p:cNvPr>
@@ -2810,14 +2810,14 @@
             <a:pPr algn="ctr">
               <a:defRPr sz="660" b="0">
                 <a:solidFill>
-                  <a:srgbClr val="AEB4BF"/>
+                  <a:srgbClr val="6C6E73"/>
                 </a:solidFill>
               </a:defRPr>
             </a:pPr>
             <a:r>
               <a:rPr sz="660" b="0">
                 <a:solidFill>
-                  <a:srgbClr val="AEB4BF"/>
+                  <a:srgbClr val="6C6E73"/>
                 </a:solidFill>
               </a:rPr>
               <a:t>fixture response</a:t>
@@ -2830,7 +2830,7 @@
           <p:cNvPr id="40" name="live-request-arrow">
             <a:extLst xmlns:a="http://schemas.openxmlformats.org/drawingml/2006/main">
               <a:ext uri="{FF2B5EF4-FFF2-40B4-BE49-F238E27FC236}">
-                <a16:creationId xmlns:a16="http://schemas.microsoft.com/office/drawing/2014/main" id="{E1390399-B0D8-49FA-BF47-6145C83B1E2D}"/>
+                <a16:creationId xmlns:a16="http://schemas.microsoft.com/office/drawing/2014/main" id="{2A6DCE73-EE34-4B93-A9B4-1C3DF7046B2F}"/>
               </a:ext>
             </a:extLst>
           </p:cNvPr>
@@ -2848,11 +2848,11 @@
             <a:avLst/>
           </a:prstGeom>
           <a:solidFill xmlns:a="http://schemas.openxmlformats.org/drawingml/2006/main">
-            <a:srgbClr val="FF8A45"/>
+            <a:srgbClr val="C73D1D"/>
           </a:solidFill>
           <a:ln xmlns:a="http://schemas.openxmlformats.org/drawingml/2006/main" w="0">
             <a:solidFill>
-              <a:srgbClr val="FF8A45"/>
+              <a:srgbClr val="C73D1D"/>
             </a:solidFill>
             <a:prstDash val="solid"/>
           </a:ln>
@@ -2863,7 +2863,7 @@
           <p:cNvPr id="41" name="live-request-label">
             <a:extLst xmlns:a="http://schemas.openxmlformats.org/drawingml/2006/main">
               <a:ext uri="{FF2B5EF4-FFF2-40B4-BE49-F238E27FC236}">
-                <a16:creationId xmlns:a16="http://schemas.microsoft.com/office/drawing/2014/main" id="{CAA384DD-15A1-4FE7-9488-63AE8BF9D440}"/>
+                <a16:creationId xmlns:a16="http://schemas.microsoft.com/office/drawing/2014/main" id="{A791742B-0F64-43D5-BB1D-01B96B8B3D27}"/>
               </a:ext>
             </a:extLst>
           </p:cNvPr>
@@ -2893,14 +2893,14 @@
             <a:pPr algn="ctr">
               <a:defRPr sz="788" b="1">
                 <a:solidFill>
-                  <a:srgbClr val="FF8A45"/>
+                  <a:srgbClr val="C73D1D"/>
                 </a:solidFill>
               </a:defRPr>
             </a:pPr>
             <a:r>
               <a:rPr sz="788" b="1">
                 <a:solidFill>
-                  <a:srgbClr val="FF8A45"/>
+                  <a:srgbClr val="C73D1D"/>
                 </a:solidFill>
               </a:rPr>
               <a:t>makeRequest()</a:t>
@@ -2913,7 +2913,7 @@
           <p:cNvPr id="42" name="live-request-detail">
             <a:extLst xmlns:a="http://schemas.openxmlformats.org/drawingml/2006/main">
               <a:ext uri="{FF2B5EF4-FFF2-40B4-BE49-F238E27FC236}">
-                <a16:creationId xmlns:a16="http://schemas.microsoft.com/office/drawing/2014/main" id="{6D436933-65D8-4027-93BA-E79E8D41165F}"/>
+                <a16:creationId xmlns:a16="http://schemas.microsoft.com/office/drawing/2014/main" id="{6A6D303D-D8BB-4DFF-AD9D-E76A62956E01}"/>
               </a:ext>
             </a:extLst>
           </p:cNvPr>
@@ -2943,14 +2943,14 @@
             <a:pPr algn="ctr">
               <a:defRPr sz="660" b="0">
                 <a:solidFill>
-                  <a:srgbClr val="AEB4BF"/>
+                  <a:srgbClr val="6C6E73"/>
                 </a:solidFill>
               </a:defRPr>
             </a:pPr>
             <a:r>
               <a:rPr sz="660" b="0">
                 <a:solidFill>
-                  <a:srgbClr val="AEB4BF"/>
+                  <a:srgbClr val="6C6E73"/>
                 </a:solidFill>
               </a:rPr>
               <a:t>runtime mode = live</a:t>
@@ -2963,7 +2963,7 @@
           <p:cNvPr id="43" name="live-token-arrow">
             <a:extLst xmlns:a="http://schemas.openxmlformats.org/drawingml/2006/main">
               <a:ext uri="{FF2B5EF4-FFF2-40B4-BE49-F238E27FC236}">
-                <a16:creationId xmlns:a16="http://schemas.microsoft.com/office/drawing/2014/main" id="{83B4D474-D2AE-4344-94C1-44886BF7C9B1}"/>
+                <a16:creationId xmlns:a16="http://schemas.microsoft.com/office/drawing/2014/main" id="{1B8C5CEF-14CD-442B-A49D-EA8E4006F839}"/>
               </a:ext>
             </a:extLst>
           </p:cNvPr>
@@ -2981,11 +2981,11 @@
             <a:avLst/>
           </a:prstGeom>
           <a:solidFill xmlns:a="http://schemas.openxmlformats.org/drawingml/2006/main">
-            <a:srgbClr val="FF8A45"/>
+            <a:srgbClr val="C73D1D"/>
           </a:solidFill>
           <a:ln xmlns:a="http://schemas.openxmlformats.org/drawingml/2006/main" w="0">
             <a:solidFill>
-              <a:srgbClr val="FF8A45"/>
+              <a:srgbClr val="C73D1D"/>
             </a:solidFill>
             <a:prstDash val="solid"/>
           </a:ln>
@@ -2996,7 +2996,7 @@
           <p:cNvPr id="44" name="live-token-label">
             <a:extLst xmlns:a="http://schemas.openxmlformats.org/drawingml/2006/main">
               <a:ext uri="{FF2B5EF4-FFF2-40B4-BE49-F238E27FC236}">
-                <a16:creationId xmlns:a16="http://schemas.microsoft.com/office/drawing/2014/main" id="{B8EAA903-CBA7-48E7-8A34-EC78C5C89650}"/>
+                <a16:creationId xmlns:a16="http://schemas.microsoft.com/office/drawing/2014/main" id="{65649D88-09E6-4FB0-89B0-4BDA499936A6}"/>
               </a:ext>
             </a:extLst>
           </p:cNvPr>
@@ -3026,14 +3026,14 @@
             <a:pPr algn="ctr">
               <a:defRPr sz="788" b="1">
                 <a:solidFill>
-                  <a:srgbClr val="FF8A45"/>
+                  <a:srgbClr val="C73D1D"/>
                 </a:solidFill>
               </a:defRPr>
             </a:pPr>
             <a:r>
               <a:rPr sz="788" b="1">
                 <a:solidFill>
-                  <a:srgbClr val="FF8A45"/>
+                  <a:srgbClr val="C73D1D"/>
                 </a:solidFill>
               </a:rPr>
               <a:t>session token</a:t>
@@ -3046,7 +3046,7 @@
           <p:cNvPr id="45" name="live-token-detail">
             <a:extLst xmlns:a="http://schemas.openxmlformats.org/drawingml/2006/main">
               <a:ext uri="{FF2B5EF4-FFF2-40B4-BE49-F238E27FC236}">
-                <a16:creationId xmlns:a16="http://schemas.microsoft.com/office/drawing/2014/main" id="{6AA0219B-AD5E-4AEC-A702-B21AB33EF1C6}"/>
+                <a16:creationId xmlns:a16="http://schemas.microsoft.com/office/drawing/2014/main" id="{59EF6247-199D-4CAB-AAC8-D08B752FF05A}"/>
               </a:ext>
             </a:extLst>
           </p:cNvPr>
@@ -3076,14 +3076,14 @@
             <a:pPr algn="ctr">
               <a:defRPr sz="660" b="0">
                 <a:solidFill>
-                  <a:srgbClr val="AEB4BF"/>
+                  <a:srgbClr val="6C6E73"/>
                 </a:solidFill>
               </a:defRPr>
             </a:pPr>
             <a:r>
               <a:rPr sz="660" b="0">
                 <a:solidFill>
-                  <a:srgbClr val="AEB4BF"/>
+                  <a:srgbClr val="6C6E73"/>
                 </a:solidFill>
               </a:rPr>
               <a:t>Bearer JWT</a:t>
@@ -3096,7 +3096,7 @@
           <p:cNvPr id="46" name="live-auth-arrow">
             <a:extLst xmlns:a="http://schemas.openxmlformats.org/drawingml/2006/main">
               <a:ext uri="{FF2B5EF4-FFF2-40B4-BE49-F238E27FC236}">
-                <a16:creationId xmlns:a16="http://schemas.microsoft.com/office/drawing/2014/main" id="{DB1AD15C-2D76-48CD-8396-3F01C6F8C3C2}"/>
+                <a16:creationId xmlns:a16="http://schemas.microsoft.com/office/drawing/2014/main" id="{EDFEDC64-5464-4686-AFB9-BAE91FDEBBD6}"/>
               </a:ext>
             </a:extLst>
           </p:cNvPr>
@@ -3114,11 +3114,11 @@
             <a:avLst/>
           </a:prstGeom>
           <a:solidFill xmlns:a="http://schemas.openxmlformats.org/drawingml/2006/main">
-            <a:srgbClr val="5EEAD4"/>
+            <a:srgbClr val="1C1D1F"/>
           </a:solidFill>
           <a:ln xmlns:a="http://schemas.openxmlformats.org/drawingml/2006/main" w="0">
             <a:solidFill>
-              <a:srgbClr val="5EEAD4"/>
+              <a:srgbClr val="1C1D1F"/>
             </a:solidFill>
             <a:prstDash val="solid"/>
           </a:ln>
@@ -3129,7 +3129,7 @@
           <p:cNvPr id="47" name="live-auth-label">
             <a:extLst xmlns:a="http://schemas.openxmlformats.org/drawingml/2006/main">
               <a:ext uri="{FF2B5EF4-FFF2-40B4-BE49-F238E27FC236}">
-                <a16:creationId xmlns:a16="http://schemas.microsoft.com/office/drawing/2014/main" id="{CACEDBC9-B451-4E61-AAE1-AB008F454089}"/>
+                <a16:creationId xmlns:a16="http://schemas.microsoft.com/office/drawing/2014/main" id="{48BAF973-361A-4A3C-81D3-F8A069F286BC}"/>
               </a:ext>
             </a:extLst>
           </p:cNvPr>
@@ -3159,14 +3159,14 @@
             <a:pPr algn="ctr">
               <a:defRPr sz="788" b="1">
                 <a:solidFill>
-                  <a:srgbClr val="5EEAD4"/>
+                  <a:srgbClr val="1C1D1F"/>
                 </a:solidFill>
               </a:defRPr>
             </a:pPr>
             <a:r>
               <a:rPr sz="788" b="1">
                 <a:solidFill>
-                  <a:srgbClr val="5EEAD4"/>
+                  <a:srgbClr val="1C1D1F"/>
                 </a:solidFill>
               </a:rPr>
               <a:t>verified user</a:t>
@@ -3179,7 +3179,7 @@
           <p:cNvPr id="48" name="live-auth-detail">
             <a:extLst xmlns:a="http://schemas.openxmlformats.org/drawingml/2006/main">
               <a:ext uri="{FF2B5EF4-FFF2-40B4-BE49-F238E27FC236}">
-                <a16:creationId xmlns:a16="http://schemas.microsoft.com/office/drawing/2014/main" id="{94D4BBE5-D4A5-48CA-B5F9-8FEEAF5FCD04}"/>
+                <a16:creationId xmlns:a16="http://schemas.microsoft.com/office/drawing/2014/main" id="{48E8BE22-8D72-40C8-A00D-FC30A2E4208A}"/>
               </a:ext>
             </a:extLst>
           </p:cNvPr>
@@ -3209,14 +3209,14 @@
             <a:pPr algn="ctr">
               <a:defRPr sz="660" b="0">
                 <a:solidFill>
-                  <a:srgbClr val="AEB4BF"/>
+                  <a:srgbClr val="6C6E73"/>
                 </a:solidFill>
               </a:defRPr>
             </a:pPr>
             <a:r>
               <a:rPr sz="660" b="0">
                 <a:solidFill>
-                  <a:srgbClr val="AEB4BF"/>
+                  <a:srgbClr val="6C6E73"/>
                 </a:solidFill>
               </a:rPr>
               <a:t>authorized party checked</a:t>
@@ -3229,7 +3229,7 @@
           <p:cNvPr id="49" name="quota-read-arrow">
             <a:extLst xmlns:a="http://schemas.openxmlformats.org/drawingml/2006/main">
               <a:ext uri="{FF2B5EF4-FFF2-40B4-BE49-F238E27FC236}">
-                <a16:creationId xmlns:a16="http://schemas.microsoft.com/office/drawing/2014/main" id="{39000BCC-6DB0-4706-A03F-AEF61A6D5A1E}"/>
+                <a16:creationId xmlns:a16="http://schemas.microsoft.com/office/drawing/2014/main" id="{2A802B05-2220-478D-8E71-3C67D8347C02}"/>
               </a:ext>
             </a:extLst>
           </p:cNvPr>
@@ -3247,11 +3247,11 @@
             <a:avLst/>
           </a:prstGeom>
           <a:solidFill xmlns:a="http://schemas.openxmlformats.org/drawingml/2006/main">
-            <a:srgbClr val="A78BFA"/>
+            <a:srgbClr val="1C1D1F"/>
           </a:solidFill>
           <a:ln xmlns:a="http://schemas.openxmlformats.org/drawingml/2006/main" w="0">
             <a:solidFill>
-              <a:srgbClr val="A78BFA"/>
+              <a:srgbClr val="1C1D1F"/>
             </a:solidFill>
             <a:prstDash val="solid"/>
           </a:ln>
@@ -3262,7 +3262,7 @@
           <p:cNvPr id="50" name="quota-read-label">
             <a:extLst xmlns:a="http://schemas.openxmlformats.org/drawingml/2006/main">
               <a:ext uri="{FF2B5EF4-FFF2-40B4-BE49-F238E27FC236}">
-                <a16:creationId xmlns:a16="http://schemas.microsoft.com/office/drawing/2014/main" id="{AAE66068-8D75-4465-9E8F-7F59E0639F0A}"/>
+                <a16:creationId xmlns:a16="http://schemas.microsoft.com/office/drawing/2014/main" id="{0CC03573-41CB-4F6A-BCBF-436170E0F65B}"/>
               </a:ext>
             </a:extLst>
           </p:cNvPr>
@@ -3292,14 +3292,14 @@
             <a:pPr algn="ctr">
               <a:defRPr sz="788" b="1">
                 <a:solidFill>
-                  <a:srgbClr val="A78BFA"/>
+                  <a:srgbClr val="1C1D1F"/>
                 </a:solidFill>
               </a:defRPr>
             </a:pPr>
             <a:r>
               <a:rPr sz="788" b="1">
                 <a:solidFill>
-                  <a:srgbClr val="A78BFA"/>
+                  <a:srgbClr val="1C1D1F"/>
                 </a:solidFill>
               </a:rPr>
               <a:t>load / reset quota</a:t>
@@ -3312,7 +3312,7 @@
           <p:cNvPr id="51" name="quota-read-detail">
             <a:extLst xmlns:a="http://schemas.openxmlformats.org/drawingml/2006/main">
               <a:ext uri="{FF2B5EF4-FFF2-40B4-BE49-F238E27FC236}">
-                <a16:creationId xmlns:a16="http://schemas.microsoft.com/office/drawing/2014/main" id="{E2CCE1ED-DD84-426D-9BFD-51344AF13C4B}"/>
+                <a16:creationId xmlns:a16="http://schemas.microsoft.com/office/drawing/2014/main" id="{346E99AD-0CFA-4832-995A-CE31A37298D5}"/>
               </a:ext>
             </a:extLst>
           </p:cNvPr>
@@ -3342,14 +3342,14 @@
             <a:pPr algn="ctr">
               <a:defRPr sz="660" b="0">
                 <a:solidFill>
-                  <a:srgbClr val="AEB4BF"/>
+                  <a:srgbClr val="6C6E73"/>
                 </a:solidFill>
               </a:defRPr>
             </a:pPr>
             <a:r>
               <a:rPr sz="660" b="0">
                 <a:solidFill>
-                  <a:srgbClr val="AEB4BF"/>
+                  <a:srgbClr val="6C6E73"/>
                 </a:solidFill>
               </a:rPr>
               <a:t>50 daily · 429 when empty</a:t>
@@ -3362,7 +3362,7 @@
           <p:cNvPr id="52" name="model-request-arrow">
             <a:extLst xmlns:a="http://schemas.openxmlformats.org/drawingml/2006/main">
               <a:ext uri="{FF2B5EF4-FFF2-40B4-BE49-F238E27FC236}">
-                <a16:creationId xmlns:a16="http://schemas.microsoft.com/office/drawing/2014/main" id="{BAF48B8C-2049-43B6-8CE3-33242BCF68B9}"/>
+                <a16:creationId xmlns:a16="http://schemas.microsoft.com/office/drawing/2014/main" id="{7F189EFA-E049-4644-8EB6-C47818B29DD2}"/>
               </a:ext>
             </a:extLst>
           </p:cNvPr>
@@ -3380,11 +3380,11 @@
             <a:avLst/>
           </a:prstGeom>
           <a:solidFill xmlns:a="http://schemas.openxmlformats.org/drawingml/2006/main">
-            <a:srgbClr val="A78BFA"/>
+            <a:srgbClr val="1C1D1F"/>
           </a:solidFill>
           <a:ln xmlns:a="http://schemas.openxmlformats.org/drawingml/2006/main" w="0">
             <a:solidFill>
-              <a:srgbClr val="A78BFA"/>
+              <a:srgbClr val="1C1D1F"/>
             </a:solidFill>
             <a:prstDash val="solid"/>
           </a:ln>
@@ -3395,7 +3395,7 @@
           <p:cNvPr id="53" name="model-request-label">
             <a:extLst xmlns:a="http://schemas.openxmlformats.org/drawingml/2006/main">
               <a:ext uri="{FF2B5EF4-FFF2-40B4-BE49-F238E27FC236}">
-                <a16:creationId xmlns:a16="http://schemas.microsoft.com/office/drawing/2014/main" id="{62146039-5E70-4B9C-9218-8768035BB0EF}"/>
+                <a16:creationId xmlns:a16="http://schemas.microsoft.com/office/drawing/2014/main" id="{6B933553-79B3-4714-84B3-73CCAC4116D4}"/>
               </a:ext>
             </a:extLst>
           </p:cNvPr>
@@ -3425,14 +3425,14 @@
             <a:pPr algn="ctr">
               <a:defRPr sz="788" b="1">
                 <a:solidFill>
-                  <a:srgbClr val="A78BFA"/>
+                  <a:srgbClr val="1C1D1F"/>
                 </a:solidFill>
               </a:defRPr>
             </a:pPr>
             <a:r>
               <a:rPr sz="788" b="1">
                 <a:solidFill>
-                  <a:srgbClr val="A78BFA"/>
+                  <a:srgbClr val="1C1D1F"/>
                 </a:solidFill>
               </a:rPr>
               <a:t>request JSON</a:t>
@@ -3445,7 +3445,7 @@
           <p:cNvPr id="54" name="model-request-detail">
             <a:extLst xmlns:a="http://schemas.openxmlformats.org/drawingml/2006/main">
               <a:ext uri="{FF2B5EF4-FFF2-40B4-BE49-F238E27FC236}">
-                <a16:creationId xmlns:a16="http://schemas.microsoft.com/office/drawing/2014/main" id="{F0C157C5-36A5-4788-9EA7-CED44DF32008}"/>
+                <a16:creationId xmlns:a16="http://schemas.microsoft.com/office/drawing/2014/main" id="{81B46072-3217-4A21-B7F8-D15BCA77A36F}"/>
               </a:ext>
             </a:extLst>
           </p:cNvPr>
@@ -3475,14 +3475,14 @@
             <a:pPr algn="ctr">
               <a:defRPr sz="660" b="0">
                 <a:solidFill>
-                  <a:srgbClr val="AEB4BF"/>
+                  <a:srgbClr val="6C6E73"/>
                 </a:solidFill>
               </a:defRPr>
             </a:pPr>
             <a:r>
               <a:rPr sz="660" b="0">
                 <a:solidFill>
-                  <a:srgbClr val="AEB4BF"/>
+                  <a:srgbClr val="6C6E73"/>
                 </a:solidFill>
               </a:rPr>
               <a:t>hosted inference</a:t>
@@ -3495,7 +3495,7 @@
           <p:cNvPr id="55" name="model-response-arrow">
             <a:extLst xmlns:a="http://schemas.openxmlformats.org/drawingml/2006/main">
               <a:ext uri="{FF2B5EF4-FFF2-40B4-BE49-F238E27FC236}">
-                <a16:creationId xmlns:a16="http://schemas.microsoft.com/office/drawing/2014/main" id="{97E90D36-98DF-421B-B2AA-E22EADC99E28}"/>
+                <a16:creationId xmlns:a16="http://schemas.microsoft.com/office/drawing/2014/main" id="{86C72461-AF73-49F7-AF5F-9C2730BB43B6}"/>
               </a:ext>
             </a:extLst>
           </p:cNvPr>
@@ -3513,11 +3513,11 @@
             <a:avLst/>
           </a:prstGeom>
           <a:solidFill xmlns:a="http://schemas.openxmlformats.org/drawingml/2006/main">
-            <a:srgbClr val="A78BFA"/>
+            <a:srgbClr val="1C1D1F"/>
           </a:solidFill>
           <a:ln xmlns:a="http://schemas.openxmlformats.org/drawingml/2006/main" w="0">
             <a:solidFill>
-              <a:srgbClr val="A78BFA"/>
+              <a:srgbClr val="1C1D1F"/>
             </a:solidFill>
             <a:prstDash val="solid"/>
           </a:ln>
@@ -3528,7 +3528,7 @@
           <p:cNvPr id="56" name="model-response-label">
             <a:extLst xmlns:a="http://schemas.openxmlformats.org/drawingml/2006/main">
               <a:ext uri="{FF2B5EF4-FFF2-40B4-BE49-F238E27FC236}">
-                <a16:creationId xmlns:a16="http://schemas.microsoft.com/office/drawing/2014/main" id="{04AFC9A2-E596-4FFD-95EF-B22D009A96A3}"/>
+                <a16:creationId xmlns:a16="http://schemas.microsoft.com/office/drawing/2014/main" id="{AAC86F13-A4D6-47E3-9661-748AAD2D9FEF}"/>
               </a:ext>
             </a:extLst>
           </p:cNvPr>
@@ -3558,14 +3558,14 @@
             <a:pPr algn="ctr">
               <a:defRPr sz="788" b="1">
                 <a:solidFill>
-                  <a:srgbClr val="A78BFA"/>
+                  <a:srgbClr val="1C1D1F"/>
                 </a:solidFill>
               </a:defRPr>
             </a:pPr>
             <a:r>
               <a:rPr sz="788" b="1">
                 <a:solidFill>
-                  <a:srgbClr val="A78BFA"/>
+                  <a:srgbClr val="1C1D1F"/>
                 </a:solidFill>
               </a:rPr>
               <a:t>candidate</a:t>
@@ -3578,7 +3578,7 @@
           <p:cNvPr id="57" name="validation-link">
             <a:extLst xmlns:a="http://schemas.openxmlformats.org/drawingml/2006/main">
               <a:ext uri="{FF2B5EF4-FFF2-40B4-BE49-F238E27FC236}">
-                <a16:creationId xmlns:a16="http://schemas.microsoft.com/office/drawing/2014/main" id="{E990B047-A4A5-4273-8F1C-C530CFF3CFB2}"/>
+                <a16:creationId xmlns:a16="http://schemas.microsoft.com/office/drawing/2014/main" id="{3AB6F249-DFC2-4995-8415-5E207244FD0A}"/>
               </a:ext>
             </a:extLst>
           </p:cNvPr>
@@ -3596,11 +3596,11 @@
             <a:avLst/>
           </a:prstGeom>
           <a:solidFill xmlns:a="http://schemas.openxmlformats.org/drawingml/2006/main">
-            <a:srgbClr val="5EEAD4"/>
+            <a:srgbClr val="2F7D3E"/>
           </a:solidFill>
           <a:ln xmlns:a="http://schemas.openxmlformats.org/drawingml/2006/main" w="0">
             <a:solidFill>
-              <a:srgbClr val="5EEAD4"/>
+              <a:srgbClr val="2F7D3E"/>
             </a:solidFill>
             <a:prstDash val="solid"/>
           </a:ln>
@@ -3611,7 +3611,7 @@
           <p:cNvPr id="58" name="validation-gate">
             <a:extLst xmlns:a="http://schemas.openxmlformats.org/drawingml/2006/main">
               <a:ext uri="{FF2B5EF4-FFF2-40B4-BE49-F238E27FC236}">
-                <a16:creationId xmlns:a16="http://schemas.microsoft.com/office/drawing/2014/main" id="{1AE07108-F8FD-4E6E-B1D8-26A2743126D4}"/>
+                <a16:creationId xmlns:a16="http://schemas.microsoft.com/office/drawing/2014/main" id="{5317F84D-146A-4390-B9F5-184922B7E65D}"/>
               </a:ext>
             </a:extLst>
           </p:cNvPr>
@@ -3631,11 +3631,11 @@
             </a:avLst>
           </a:prstGeom>
           <a:solidFill xmlns:a="http://schemas.openxmlformats.org/drawingml/2006/main">
-            <a:srgbClr val="1E3735"/>
+            <a:srgbClr val="EEF6EE"/>
           </a:solidFill>
           <a:ln xmlns:a="http://schemas.openxmlformats.org/drawingml/2006/main" w="12383">
             <a:solidFill>
-              <a:srgbClr val="5EEAD4"/>
+              <a:srgbClr val="2F7D3E"/>
             </a:solidFill>
             <a:prstDash val="solid"/>
           </a:ln>
@@ -3646,7 +3646,7 @@
           <p:cNvPr id="59" name="validation-title">
             <a:extLst xmlns:a="http://schemas.openxmlformats.org/drawingml/2006/main">
               <a:ext uri="{FF2B5EF4-FFF2-40B4-BE49-F238E27FC236}">
-                <a16:creationId xmlns:a16="http://schemas.microsoft.com/office/drawing/2014/main" id="{BD0E5E98-3A0B-4875-8245-51526885AE1D}"/>
+                <a16:creationId xmlns:a16="http://schemas.microsoft.com/office/drawing/2014/main" id="{DE2D246C-623B-447A-8A6A-2C00AF8DA538}"/>
               </a:ext>
             </a:extLst>
           </p:cNvPr>
@@ -3676,14 +3676,14 @@
             <a:pPr algn="ctr">
               <a:defRPr sz="773" b="1">
                 <a:solidFill>
-                  <a:srgbClr val="5EEAD4"/>
+                  <a:srgbClr val="2F7D3E"/>
                 </a:solidFill>
               </a:defRPr>
             </a:pPr>
             <a:r>
               <a:rPr sz="773" b="1">
                 <a:solidFill>
-                  <a:srgbClr val="5EEAD4"/>
+                  <a:srgbClr val="2F7D3E"/>
                 </a:solidFill>
               </a:rPr>
               <a:t>Pydantic gate</a:t>
@@ -3696,7 +3696,7 @@
           <p:cNvPr id="60" name="validation-copy">
             <a:extLst xmlns:a="http://schemas.openxmlformats.org/drawingml/2006/main">
               <a:ext uri="{FF2B5EF4-FFF2-40B4-BE49-F238E27FC236}">
-                <a16:creationId xmlns:a16="http://schemas.microsoft.com/office/drawing/2014/main" id="{E89FBB33-8076-4042-AAB0-CC9B40E8D229}"/>
+                <a16:creationId xmlns:a16="http://schemas.microsoft.com/office/drawing/2014/main" id="{11642920-CC40-42A6-B86E-27BDA2E5CCC0}"/>
               </a:ext>
             </a:extLst>
           </p:cNvPr>
@@ -3726,14 +3726,14 @@
             <a:pPr algn="ctr">
               <a:defRPr sz="645" b="0">
                 <a:solidFill>
-                  <a:srgbClr val="AEB4BF"/>
+                  <a:srgbClr val="6C6E73"/>
                 </a:solidFill>
               </a:defRPr>
             </a:pPr>
             <a:r>
               <a:rPr sz="645" b="0">
                 <a:solidFill>
-                  <a:srgbClr val="AEB4BF"/>
+                  <a:srgbClr val="6C6E73"/>
                 </a:solidFill>
               </a:rPr>
               <a:t>4 unique · id 0–3</a:t>
@@ -3746,7 +3746,7 @@
           <p:cNvPr id="61" name="tx-boundary">
             <a:extLst xmlns:a="http://schemas.openxmlformats.org/drawingml/2006/main">
               <a:ext uri="{FF2B5EF4-FFF2-40B4-BE49-F238E27FC236}">
-                <a16:creationId xmlns:a16="http://schemas.microsoft.com/office/drawing/2014/main" id="{3B420407-A167-4DD7-804B-8E4DBFC89D29}"/>
+                <a16:creationId xmlns:a16="http://schemas.microsoft.com/office/drawing/2014/main" id="{5BE141A2-5A2A-4CA8-8107-BCE307ED068C}"/>
               </a:ext>
             </a:extLst>
           </p:cNvPr>
@@ -3766,11 +3766,11 @@
             </a:avLst>
           </a:prstGeom>
           <a:solidFill xmlns:a="http://schemas.openxmlformats.org/drawingml/2006/main">
-            <a:srgbClr val="263421"/>
+            <a:srgbClr val="EEF6EE"/>
           </a:solidFill>
           <a:ln xmlns:a="http://schemas.openxmlformats.org/drawingml/2006/main" w="13335">
             <a:solidFill>
-              <a:srgbClr val="A3E635"/>
+              <a:srgbClr val="2F7D3E"/>
             </a:solidFill>
             <a:prstDash val="solid"/>
           </a:ln>
@@ -3781,7 +3781,7 @@
           <p:cNvPr id="62" name="tx-label">
             <a:extLst xmlns:a="http://schemas.openxmlformats.org/drawingml/2006/main">
               <a:ext uri="{FF2B5EF4-FFF2-40B4-BE49-F238E27FC236}">
-                <a16:creationId xmlns:a16="http://schemas.microsoft.com/office/drawing/2014/main" id="{FCE211EC-69F9-4604-843B-03A016760297}"/>
+                <a16:creationId xmlns:a16="http://schemas.microsoft.com/office/drawing/2014/main" id="{F0B3494E-8F4B-4200-8756-88C00E568D6B}"/>
               </a:ext>
             </a:extLst>
           </p:cNvPr>
@@ -3811,14 +3811,14 @@
             <a:pPr algn="l">
               <a:defRPr sz="690" b="1">
                 <a:solidFill>
-                  <a:srgbClr val="A3E635"/>
+                  <a:srgbClr val="2F7D3E"/>
                 </a:solidFill>
               </a:defRPr>
             </a:pPr>
             <a:r>
               <a:rPr sz="690" b="1">
                 <a:solidFill>
-                  <a:srgbClr val="A3E635"/>
+                  <a:srgbClr val="2F7D3E"/>
                 </a:solidFill>
               </a:rPr>
               <a:t>ONE SQLALCHEMY TRANSACTION</a:t>
@@ -3831,7 +3831,7 @@
           <p:cNvPr id="63" name="tx-write-arrow">
             <a:extLst xmlns:a="http://schemas.openxmlformats.org/drawingml/2006/main">
               <a:ext uri="{FF2B5EF4-FFF2-40B4-BE49-F238E27FC236}">
-                <a16:creationId xmlns:a16="http://schemas.microsoft.com/office/drawing/2014/main" id="{DBC9B5D2-E608-4193-9E1F-FDF3129A3D5F}"/>
+                <a16:creationId xmlns:a16="http://schemas.microsoft.com/office/drawing/2014/main" id="{8CFB1F47-3D5B-4E90-A972-5AE65521B61B}"/>
               </a:ext>
             </a:extLst>
           </p:cNvPr>
@@ -3849,11 +3849,11 @@
             <a:avLst/>
           </a:prstGeom>
           <a:solidFill xmlns:a="http://schemas.openxmlformats.org/drawingml/2006/main">
-            <a:srgbClr val="A3E635"/>
+            <a:srgbClr val="2F7D3E"/>
           </a:solidFill>
           <a:ln xmlns:a="http://schemas.openxmlformats.org/drawingml/2006/main" w="0">
             <a:solidFill>
-              <a:srgbClr val="A3E635"/>
+              <a:srgbClr val="2F7D3E"/>
             </a:solidFill>
             <a:prstDash val="solid"/>
           </a:ln>
@@ -3864,7 +3864,7 @@
           <p:cNvPr id="64" name="tx-write-label">
             <a:extLst xmlns:a="http://schemas.openxmlformats.org/drawingml/2006/main">
               <a:ext uri="{FF2B5EF4-FFF2-40B4-BE49-F238E27FC236}">
-                <a16:creationId xmlns:a16="http://schemas.microsoft.com/office/drawing/2014/main" id="{393AD1E1-442E-4FCB-AEAB-C9A696B1B8DB}"/>
+                <a16:creationId xmlns:a16="http://schemas.microsoft.com/office/drawing/2014/main" id="{DFBC387E-28D7-4BE9-A6E6-75D6297E40B0}"/>
               </a:ext>
             </a:extLst>
           </p:cNvPr>
@@ -3894,14 +3894,14 @@
             <a:pPr algn="ctr">
               <a:defRPr sz="773" b="1">
                 <a:solidFill>
-                  <a:srgbClr val="A3E635"/>
+                  <a:srgbClr val="2F7D3E"/>
                 </a:solidFill>
               </a:defRPr>
             </a:pPr>
             <a:r>
               <a:rPr sz="773" b="1">
                 <a:solidFill>
-                  <a:srgbClr val="A3E635"/>
+                  <a:srgbClr val="2F7D3E"/>
                 </a:solidFill>
               </a:rPr>
               <a:t>insert Challenge + decrement quota</a:t>
@@ -3914,7 +3914,7 @@
           <p:cNvPr id="65" name="tx-commit-arrow">
             <a:extLst xmlns:a="http://schemas.openxmlformats.org/drawingml/2006/main">
               <a:ext uri="{FF2B5EF4-FFF2-40B4-BE49-F238E27FC236}">
-                <a16:creationId xmlns:a16="http://schemas.microsoft.com/office/drawing/2014/main" id="{6411563B-0E21-4A05-9E11-B13294628ACC}"/>
+                <a16:creationId xmlns:a16="http://schemas.microsoft.com/office/drawing/2014/main" id="{2E2D7CA5-EB1A-466A-BCE6-2FDAE724A5B8}"/>
               </a:ext>
             </a:extLst>
           </p:cNvPr>
@@ -3932,11 +3932,11 @@
             <a:avLst/>
           </a:prstGeom>
           <a:solidFill xmlns:a="http://schemas.openxmlformats.org/drawingml/2006/main">
-            <a:srgbClr val="A3E635"/>
+            <a:srgbClr val="2F7D3E"/>
           </a:solidFill>
           <a:ln xmlns:a="http://schemas.openxmlformats.org/drawingml/2006/main" w="0">
             <a:solidFill>
-              <a:srgbClr val="A3E635"/>
+              <a:srgbClr val="2F7D3E"/>
             </a:solidFill>
             <a:prstDash val="solid"/>
           </a:ln>
@@ -3947,7 +3947,7 @@
           <p:cNvPr id="66" name="tx-commit-label">
             <a:extLst xmlns:a="http://schemas.openxmlformats.org/drawingml/2006/main">
               <a:ext uri="{FF2B5EF4-FFF2-40B4-BE49-F238E27FC236}">
-                <a16:creationId xmlns:a16="http://schemas.microsoft.com/office/drawing/2014/main" id="{BCFB690F-B3D8-452D-9363-CEDB54281D01}"/>
+                <a16:creationId xmlns:a16="http://schemas.microsoft.com/office/drawing/2014/main" id="{26583FA9-81E7-493C-9DEE-95E2D9C2F2B1}"/>
               </a:ext>
             </a:extLst>
           </p:cNvPr>
@@ -3977,14 +3977,14 @@
             <a:pPr algn="ctr">
               <a:defRPr sz="735" b="1">
                 <a:solidFill>
-                  <a:srgbClr val="A3E635"/>
+                  <a:srgbClr val="2F7D3E"/>
                 </a:solidFill>
               </a:defRPr>
             </a:pPr>
             <a:r>
               <a:rPr sz="735" b="1">
                 <a:solidFill>
-                  <a:srgbClr val="A3E635"/>
+                  <a:srgbClr val="2F7D3E"/>
                 </a:solidFill>
               </a:rPr>
               <a:t>commit</a:t>
@@ -3997,7 +3997,7 @@
           <p:cNvPr id="67" name="rollback-label">
             <a:extLst xmlns:a="http://schemas.openxmlformats.org/drawingml/2006/main">
               <a:ext uri="{FF2B5EF4-FFF2-40B4-BE49-F238E27FC236}">
-                <a16:creationId xmlns:a16="http://schemas.microsoft.com/office/drawing/2014/main" id="{373F52D7-3FA6-4038-97B4-528818B46B49}"/>
+                <a16:creationId xmlns:a16="http://schemas.microsoft.com/office/drawing/2014/main" id="{D103FBB3-4D32-4D1D-A471-284DEC4B9235}"/>
               </a:ext>
             </a:extLst>
           </p:cNvPr>
@@ -4027,14 +4027,14 @@
             <a:pPr algn="ctr">
               <a:defRPr sz="735" b="1">
                 <a:solidFill>
-                  <a:srgbClr val="F3C34E"/>
+                  <a:srgbClr val="A13A2D"/>
                 </a:solidFill>
               </a:defRPr>
             </a:pPr>
             <a:r>
               <a:rPr sz="735" b="1">
                 <a:solidFill>
-                  <a:srgbClr val="F3C34E"/>
+                  <a:srgbClr val="A13A2D"/>
                 </a:solidFill>
               </a:rPr>
               <a:t>failure: rollback · quota unchanged</a:t>
@@ -4047,7 +4047,7 @@
           <p:cNvPr id="68" name="side-paths">
             <a:extLst xmlns:a="http://schemas.openxmlformats.org/drawingml/2006/main">
               <a:ext uri="{FF2B5EF4-FFF2-40B4-BE49-F238E27FC236}">
-                <a16:creationId xmlns:a16="http://schemas.microsoft.com/office/drawing/2014/main" id="{8B9D9280-A444-4A8C-A835-B925C2AA4F82}"/>
+                <a16:creationId xmlns:a16="http://schemas.microsoft.com/office/drawing/2014/main" id="{61EB3961-5C87-4590-AC77-48DB8A7F76FB}"/>
               </a:ext>
             </a:extLst>
           </p:cNvPr>
@@ -4067,11 +4067,11 @@
             </a:avLst>
           </a:prstGeom>
           <a:solidFill xmlns:a="http://schemas.openxmlformats.org/drawingml/2006/main">
-            <a:srgbClr val="1E3735"/>
+            <a:srgbClr val="EEF6EE"/>
           </a:solidFill>
           <a:ln xmlns:a="http://schemas.openxmlformats.org/drawingml/2006/main" w="10478">
             <a:solidFill>
-              <a:srgbClr val="5EEAD4"/>
+              <a:srgbClr val="2F7D3E"/>
             </a:solidFill>
             <a:prstDash val="solid"/>
           </a:ln>
@@ -4082,7 +4082,7 @@
           <p:cNvPr id="69" name="side-paths-label">
             <a:extLst xmlns:a="http://schemas.openxmlformats.org/drawingml/2006/main">
               <a:ext uri="{FF2B5EF4-FFF2-40B4-BE49-F238E27FC236}">
-                <a16:creationId xmlns:a16="http://schemas.microsoft.com/office/drawing/2014/main" id="{2EB6BD9B-B72F-41BB-A3E4-CD0A8CE6D8E8}"/>
+                <a16:creationId xmlns:a16="http://schemas.microsoft.com/office/drawing/2014/main" id="{019C5865-0DEB-43DE-BE2B-9647412DDFCF}"/>
               </a:ext>
             </a:extLst>
           </p:cNvPr>
@@ -4112,14 +4112,14 @@
             <a:pPr algn="l">
               <a:defRPr sz="675" b="1">
                 <a:solidFill>
-                  <a:srgbClr val="5EEAD4"/>
+                  <a:srgbClr val="2F7D3E"/>
                 </a:solidFill>
               </a:defRPr>
             </a:pPr>
             <a:r>
               <a:rPr sz="675" b="1">
                 <a:solidFill>
-                  <a:srgbClr val="5EEAD4"/>
+                  <a:srgbClr val="2F7D3E"/>
                 </a:solidFill>
               </a:rPr>
               <a:t>ASYNC + READ PATHS</a:t>
@@ -4132,7 +4132,7 @@
           <p:cNvPr id="70" name="side-paths-copy">
             <a:extLst xmlns:a="http://schemas.openxmlformats.org/drawingml/2006/main">
               <a:ext uri="{FF2B5EF4-FFF2-40B4-BE49-F238E27FC236}">
-                <a16:creationId xmlns:a16="http://schemas.microsoft.com/office/drawing/2014/main" id="{5BB0FED6-A13C-4638-B8E1-4D885A49E2F2}"/>
+                <a16:creationId xmlns:a16="http://schemas.microsoft.com/office/drawing/2014/main" id="{71DBDF62-B3E6-49EC-8C1E-1339DBC0FFF7}"/>
               </a:ext>
             </a:extLst>
           </p:cNvPr>
@@ -4162,14 +4162,14 @@
             <a:pPr algn="ctr">
               <a:defRPr sz="690" b="0">
                 <a:solidFill>
-                  <a:srgbClr val="F4F2EC"/>
+                  <a:srgbClr val="1C1D1F"/>
                 </a:solidFill>
               </a:defRPr>
             </a:pPr>
             <a:r>
               <a:rPr sz="690" b="0">
                 <a:solidFill>
-                  <a:srgbClr val="F4F2EC"/>
+                  <a:srgbClr val="1C1D1F"/>
                 </a:solidFill>
               </a:rPr>
               <a:t>user.created → Svix → quota row   ·   GET quota   ·   history ≤100</a:t>
@@ -4182,7 +4182,7 @@
           <p:cNvPr id="71" name="sources">
             <a:extLst xmlns:a="http://schemas.openxmlformats.org/drawingml/2006/main">
               <a:ext uri="{FF2B5EF4-FFF2-40B4-BE49-F238E27FC236}">
-                <a16:creationId xmlns:a16="http://schemas.microsoft.com/office/drawing/2014/main" id="{6B5F7380-88ED-4138-BB71-A53D5590B5E3}"/>
+                <a16:creationId xmlns:a16="http://schemas.microsoft.com/office/drawing/2014/main" id="{E2AB3E5F-70BE-419B-9BA4-F0E4DB308336}"/>
               </a:ext>
             </a:extLst>
           </p:cNvPr>
@@ -4212,14 +4212,14 @@
             <a:pPr algn="ctr">
               <a:defRPr sz="660" b="0">
                 <a:solidFill>
-                  <a:srgbClr val="AEB4BF"/>
+                  <a:srgbClr val="6C6E73"/>
                 </a:solidFill>
               </a:defRPr>
             </a:pPr>
             <a:r>
               <a:rPr sz="660" b="0">
                 <a:solidFill>
-                  <a:srgbClr val="AEB4BF"/>
+                  <a:srgbClr val="6C6E73"/>
                 </a:solidFill>
               </a:rPr>
               <a:t>LiveApiProvider.jsx · DemoApiProvider.jsx · routes/challenge.py · ai_generator.py · database/ · routes/webhooks.py</a:t>
@@ -4230,7 +4230,7 @@
     </p:spTree>
     <p:extLst>
       <p:ext uri="{BB962C8B-B14F-4D97-AF65-F5344CB8AC3E}">
-        <p14:creationId xmlns:p14="http://schemas.microsoft.com/office/powerpoint/2010/main" val="1352030010"/>
+        <p14:creationId xmlns:p14="http://schemas.microsoft.com/office/powerpoint/2010/main" val="1101579673"/>
       </p:ext>
     </p:extLst>
   </p:cSld>

</xml_diff>